<commit_message>
Deutsch 11: Szenen ohne Freeze spielen, Auswertung danach; eigene Ideen mit Notfall-Input; Regieplan
Co-Authored-By: Claude Opus 5.5 <noreply@anthropic.com>
Claude-Session: https://claude.ai/code/session_01Kzh1oWiqhC6W8oSNq8mKnj
</commit_message>
<xml_diff>
--- a/Deutsch_11/Kommunikationsstoerungen_loesen/Praesentation_Kommunikationsstoerungen_loesen.pptx
+++ b/Deutsch_11/Kommunikationsstoerungen_loesen/Praesentation_Kommunikationsstoerungen_loesen.pptx
@@ -13,9 +13,10 @@
     <p:sldId id="261" r:id="rId7"/>
     <p:sldId id="262" r:id="rId8"/>
     <p:sldId id="263" r:id="rId9"/>
+    <p:sldId id="264" r:id="rId10"/>
   </p:sldIdLst>
   <p:notesMasterIdLst>
-    <p:notesMasterId r:id="rId10"/>
+    <p:notesMasterId r:id="rId11"/>
   </p:notesMasterIdLst>
   <p:sldSz cx="12192000" cy="6858000"/>
   <p:notesSz cx="6858000" cy="12192000"/>
@@ -509,7 +510,7 @@
           <a:p>
             <a:r>
               <a:rPr lang="en-US" dirty="0"/>
-              <a:t>Diese Folie läuft beim Ankommen. Vorher austeilen: Arbeitsblatt (1 pro Person), Stopp-Karten (1 pro Person). Pro Gruppentisch: Rollen- und Expertenkarten. Aufs Pult: Tippkarten, Situationskarten, Lösungsblätter (Lehrermaterial S. 2–3). Timer sichtbar einblenden (z. B. Handy unter der Dokumentenkamera oder ein Online-Timer). Möglichst ohne Einführung direkt zu Folie 2 wechseln.</a:t>
+              <a:t>Diese Folie läuft beim Ankommen. Alles liegt bereits: Arbeitsblatt auf jedem Platz, pro Gruppentisch ein Umschlag (Rollenkarten, Expertenkarten A–D, Exit-Tickets). Aufs Pult: Tippkarten und Lösungsblätter. Bei Ihnen: Umschlag mit Notfall-Ideen, Moderationskarten. Einziger Satz: „Heute steht alles auf den Folien – schaut einfach dorthin.“ Dann Folie 2 und Timer 5 Min.</a:t>
             </a:r>
             <a:endParaRPr lang="en-US" dirty="0"/>
           </a:p>
@@ -685,7 +686,7 @@
           <a:p>
             <a:r>
               <a:rPr lang="en-US" dirty="0"/>
-              <a:t>Während der Partnerarbeit herumgehen und nur zuhören. Wer fertig ist, holt sich das Lösungsblatt selbst (Lehrermaterial S. 2). Erwartung: Z. 3 (★ Du-Botschaft/Beziehungsohr), Z. 4 (Gegenangriff, symmetrische Eskalation), Z. 5 (Verallgemeinerung, Interpunktion), Z. 7 (Ironie, inkongruent), Z. 8–9 (nonverbaler Rückzug, man kann nicht nicht kommunizieren). Jetzt Vierergruppen bilden lassen (z. B. zwei Paare zusammen).</a:t>
+              <a:t>Während der Partnerarbeit herumgehen und nur zuhören. Wer fertig ist, holt sich das Lösungsblatt „Kipppunkte“ selbst vom Pult. Erwartung: Z. 3 (★ Du-Botschaft/Beziehungsohr), Z. 4 (Gegenangriff, symmetrische Eskalation), Z. 5 (Verallgemeinerung, Interpunktion), Z. 7 (Ironie, inkongruent), Z. 8–9 (nonverbaler Rückzug, man kann nicht nicht kommunizieren). Die Klasse sitzt bereits in den Vierergruppen – kein Umbau nötig.</a:t>
             </a:r>
             <a:endParaRPr lang="en-US" dirty="0"/>
           </a:p>
@@ -773,7 +774,7 @@
           <a:p>
             <a:r>
               <a:rPr lang="en-US" dirty="0"/>
-              <a:t>Timer auf 20 Minuten, die Zeit-Person der Gruppe achtet auf die Teilphasen. Folie 5 (Werkzeugkasten) kann parallel als Überblick eingeblendet werden, sobald die Gruppen mit dem Umschreiben beginnen. Musterlösung: Lehrermaterial S. 3.</a:t>
+              <a:t>Timer auf 17 Minuten, die Zeit-Person der Gruppe achtet auf die Teilphasen. Nach 1 Minute prüfen, ob alle Gruppen Rollen verteilt haben. Ab ca. Minute 24 Folie 5 (Werkzeugkasten) einblenden und stehen lassen. Musterlösung liegt am Pult.</a:t>
             </a:r>
             <a:endParaRPr lang="en-US" dirty="0"/>
           </a:p>
@@ -949,7 +950,7 @@
           <a:p>
             <a:r>
               <a:rPr lang="en-US" dirty="0"/>
-              <a:t>Gruppen verteilen sich zum Proben ggf. auf Flur oder Ecken. Reihenfolge der Auftritte schon jetzt festlegen (z. B. Zettel an der Tafel), damit jede Gruppe weiß, wann sie moderiert: immer die Gruppe, die als nächste spielt.</a:t>
+              <a:t>Nach 5 Minuten eine Runde gehen: Hat jede Gruppe eine eigene Situation? Notfall-Ideen nur ausgeben, wenn Tippkarte 1 nicht geholfen hat. Um ca. Minute 42 eine Person als Moderation gewinnen (z. B. aus der Gruppe, die zuerst fertig ist) und ihr die Moderationskarte geben. Reihenfolge der Auftritte steht an der Tafel. Zum Proben dürfen Gruppen in Flur oder Ecken.</a:t>
             </a:r>
             <a:endParaRPr lang="en-US" dirty="0"/>
           </a:p>
@@ -1037,7 +1038,7 @@
           <a:p>
             <a:r>
               <a:rPr lang="en-US" dirty="0"/>
-              <a:t>Sie setzen sich ins Publikum und notieren nur. Pro Gruppe etwa 4 Minuten. Wird zu früh oder zu spät gestoppt, ist das ein guter Anlass: Die Moderation fragt „Wer sieht es anders?“. Zeit knapp? Nur 3–4 Gruppen spielen, die übrigen zu Beginn der nächsten Stunde. Alternative: Alle spielen nur Version A mit Freeze, und das Publikum schlägt am Kipppunkt spontan eine bessere Reaktion vor.</a:t>
+              <a:t>Sie sitzen im Publikum und notieren gelungene Formulierungen. Die Moderation leitet mit der Moderationskarte. Pro Gruppe ca. 3,5 Minuten (2 × 90 Sek. + Notizzeit). Zeit knapp? Die restlichen Gruppen spielen zu Beginn der nächsten Stunde, die Auswertung findet trotzdem heute statt.</a:t>
             </a:r>
             <a:endParaRPr lang="en-US" dirty="0"/>
           </a:p>
@@ -1125,7 +1126,7 @@
           <a:p>
             <a:r>
               <a:rPr lang="en-US" dirty="0"/>
-              <a:t>Exit-Tickets an der Tür einsammeln. Erwartungshorizont: Lehrermaterial S. 3. Zwei oder drei gelungene Formulierungen können die nächste Stunde eröffnen.</a:t>
+              <a:t>Die Moderation führt durch die drei Schritte; Schritt 3 können Sie auch selbst moderieren. Nur zum Schluss (höchstens 1 Minute): zwei gelungene Formulierungen aus Ihren Notizen vorlesen. Wenn eine Gruppe den Kipppunkt anders sieht als die Spielgruppe, ist das ein produktiver Moment – kurz beide Sichtweisen stehen lassen.</a:t>
             </a:r>
             <a:endParaRPr lang="en-US" dirty="0"/>
           </a:p>
@@ -1149,6 +1150,94 @@
             <a:fld id="{F7021451-1387-4CA6-816F-3879F97B5CBC}" type="slidenum">
               <a:rPr lang="en-US"/>
               <a:t>8</a:t>
+            </a:fld>
+            <a:endParaRPr lang="en-US"/>
+          </a:p>
+        </p:txBody>
+      </p:sp>
+    </p:spTree>
+    <p:extLst>
+      <p:ext uri="{BB962C8B-B14F-4D97-AF65-F5344CB8AC3E}">
+        <p14:creationId xmlns:p14="http://schemas.microsoft.com/office/powerpoint/2010/main" val="1024086991"/>
+      </p:ext>
+    </p:extLst>
+  </p:cSld>
+  <p:clrMapOvr>
+    <a:masterClrMapping/>
+  </p:clrMapOvr>
+</p:notes>
+</file>
+
+<file path=ppt/notesSlides/notesSlide9.xml><?xml version="1.0" encoding="utf-8"?>
+<p:notes xmlns:a="http://schemas.openxmlformats.org/drawingml/2006/main" xmlns:r="http://schemas.openxmlformats.org/officeDocument/2006/relationships" xmlns:p="http://schemas.openxmlformats.org/presentationml/2006/main">
+  <p:cSld>
+    <p:spTree>
+      <p:nvGrpSpPr>
+        <p:cNvPr id="1" name=""/>
+        <p:cNvGrpSpPr/>
+        <p:nvPr/>
+      </p:nvGrpSpPr>
+      <p:grpSpPr>
+        <a:xfrm>
+          <a:off x="0" y="0"/>
+          <a:ext cx="0" cy="0"/>
+          <a:chOff x="0" y="0"/>
+          <a:chExt cx="0" cy="0"/>
+        </a:xfrm>
+      </p:grpSpPr>
+      <p:sp>
+        <p:nvSpPr>
+          <p:cNvPr id="2" name="Slide Image Placeholder 1"/>
+          <p:cNvSpPr>
+            <a:spLocks noGrp="1" noRot="1" noChangeAspect="1"/>
+          </p:cNvSpPr>
+          <p:nvPr>
+            <p:ph type="sldImg"/>
+          </p:nvPr>
+        </p:nvSpPr>
+        <p:spPr/>
+      </p:sp>
+      <p:sp>
+        <p:nvSpPr>
+          <p:cNvPr id="3" name="Notes Placeholder 2"/>
+          <p:cNvSpPr>
+            <a:spLocks noGrp="1"/>
+          </p:cNvSpPr>
+          <p:nvPr>
+            <p:ph type="body" idx="1"/>
+          </p:nvPr>
+        </p:nvSpPr>
+        <p:spPr/>
+        <p:txBody>
+          <a:bodyPr/>
+          <a:lstStyle/>
+          <a:p>
+            <a:r>
+              <a:rPr lang="en-US" dirty="0"/>
+              <a:t>Exit-Tickets an der Tür einsammeln. Erwartungshorizont: Lehrermaterial, Musterlösung Aufgabe 3. Zwei oder drei gelungene Formulierungen können die nächste Stunde eröffnen.</a:t>
+            </a:r>
+            <a:endParaRPr lang="en-US" dirty="0"/>
+          </a:p>
+        </p:txBody>
+      </p:sp>
+      <p:sp>
+        <p:nvSpPr>
+          <p:cNvPr id="4" name="Slide Number Placeholder 3"/>
+          <p:cNvSpPr>
+            <a:spLocks noGrp="1"/>
+          </p:cNvSpPr>
+          <p:nvPr>
+            <p:ph type="sldNum" sz="quarter" idx="10"/>
+          </p:nvPr>
+        </p:nvSpPr>
+        <p:spPr/>
+        <p:txBody>
+          <a:bodyPr/>
+          <a:lstStyle/>
+          <a:p>
+            <a:fld id="{F7021451-1387-4CA6-816F-3879F97B5CBC}" type="slidenum">
+              <a:rPr lang="en-US"/>
+              <a:t>9</a:t>
             </a:fld>
             <a:endParaRPr lang="en-US"/>
           </a:p>
@@ -4110,7 +4199,7 @@
                 <a:ea typeface="Cambria" pitchFamily="34" charset="-122"/>
                 <a:cs typeface="Cambria" pitchFamily="34" charset="-120"/>
               </a:rPr>
-              <a:t>10 Min.</a:t>
+              <a:t>8 Min.</a:t>
             </a:r>
             <a:endParaRPr lang="en-US" sz="2600" dirty="0"/>
           </a:p>
@@ -5124,7 +5213,7 @@
                 <a:ea typeface="Cambria" pitchFamily="34" charset="-122"/>
                 <a:cs typeface="Cambria" pitchFamily="34" charset="-120"/>
               </a:rPr>
-              <a:t>20 Min.</a:t>
+              <a:t>17 Min.</a:t>
             </a:r>
             <a:endParaRPr lang="en-US" sz="2600" dirty="0"/>
           </a:p>
@@ -5178,7 +5267,7 @@
         <p:spPr>
           <a:xfrm>
             <a:off x="548640" y="1783080"/>
-            <a:ext cx="4572000" cy="365760"/>
+            <a:ext cx="9144000" cy="365760"/>
           </a:xfrm>
           <a:prstGeom prst="rect">
             <a:avLst/>
@@ -5202,7 +5291,7 @@
                 <a:ea typeface="Cambria" pitchFamily="34" charset="-122"/>
                 <a:cs typeface="Cambria" pitchFamily="34" charset="-120"/>
               </a:rPr>
-              <a:t>Zuerst: Rollen verteilen</a:t>
+              <a:t>Zuerst: Umschlag öffnen, Rollen verteilen</a:t>
             </a:r>
             <a:endParaRPr lang="en-US" sz="1800" dirty="0"/>
           </a:p>
@@ -5668,7 +5757,7 @@
                 <a:ea typeface="Cambria" pitchFamily="34" charset="-122"/>
                 <a:cs typeface="Cambria" pitchFamily="34" charset="-120"/>
               </a:rPr>
-              <a:t>5'</a:t>
+              <a:t>4'</a:t>
             </a:r>
             <a:endParaRPr lang="en-US" sz="2400" dirty="0"/>
           </a:p>
@@ -5812,7 +5901,7 @@
                 <a:ea typeface="Cambria" pitchFamily="34" charset="-122"/>
                 <a:cs typeface="Cambria" pitchFamily="34" charset="-120"/>
               </a:rPr>
-              <a:t>8'</a:t>
+              <a:t>7'</a:t>
             </a:r>
             <a:endParaRPr lang="en-US" sz="2400" dirty="0"/>
           </a:p>
@@ -5890,7 +5979,7 @@
                 <a:ea typeface="Calibri" pitchFamily="34" charset="-122"/>
                 <a:cs typeface="Calibri" pitchFamily="34" charset="-120"/>
               </a:rPr>
-              <a:t>Reihum: jede Strategie in höchstens 2 Minuten – mit Beispiel.</a:t>
+              <a:t>Reihum: jede Strategie in höchstens 90 Sekunden – mit Beispiel.</a:t>
             </a:r>
             <a:endParaRPr lang="en-US" sz="1500" dirty="0"/>
           </a:p>
@@ -5956,7 +6045,7 @@
                 <a:ea typeface="Cambria" pitchFamily="34" charset="-122"/>
                 <a:cs typeface="Cambria" pitchFamily="34" charset="-120"/>
               </a:rPr>
-              <a:t>7'</a:t>
+              <a:t>6'</a:t>
             </a:r>
             <a:endParaRPr lang="en-US" sz="2400" dirty="0"/>
           </a:p>
@@ -7324,7 +7413,7 @@
                 <a:ea typeface="Calibri" pitchFamily="34" charset="-122"/>
                 <a:cs typeface="Calibri" pitchFamily="34" charset="-120"/>
               </a:rPr>
-              <a:t>Arbeitsblatt S. 4 · Planungsbogen</a:t>
+              <a:t>Arbeitsblatt S. 4 · Denkt euch selbst eine Situation aus!</a:t>
             </a:r>
             <a:endParaRPr lang="en-US" sz="1400" dirty="0"/>
           </a:p>
@@ -7463,7 +7552,7 @@
                 <a:ea typeface="Cambria" pitchFamily="34" charset="-122"/>
                 <a:cs typeface="Cambria" pitchFamily="34" charset="-120"/>
               </a:rPr>
-              <a:t>20 Min.</a:t>
+              <a:t>17 Min.</a:t>
             </a:r>
             <a:endParaRPr lang="en-US" sz="2600" dirty="0"/>
           </a:p>
@@ -7784,7 +7873,7 @@
                 <a:ea typeface="Calibri" pitchFamily="34" charset="-122"/>
                 <a:cs typeface="Calibri" pitchFamily="34" charset="-120"/>
               </a:rPr>
-              <a:t>2–4 Rollen, jede Version höchstens 2 Minuten</a:t>
+              <a:t>2–4 Rollen, jede Version höchstens 90 Sekunden</a:t>
             </a:r>
             <a:endParaRPr lang="en-US" sz="1600" dirty="0"/>
           </a:p>
@@ -7887,7 +7976,7 @@
                 <a:ea typeface="Cambria" pitchFamily="34" charset="-122"/>
                 <a:cs typeface="Cambria" pitchFamily="34" charset="-120"/>
               </a:rPr>
-              <a:t>Keine Idee?</a:t>
+              <a:t>Nach 5 Min. keine Idee?</a:t>
             </a:r>
             <a:endParaRPr lang="en-US" sz="1700" dirty="0"/>
           </a:p>
@@ -7926,7 +8015,24 @@
                 <a:ea typeface="Calibri" pitchFamily="34" charset="-122"/>
                 <a:cs typeface="Calibri" pitchFamily="34" charset="-120"/>
               </a:rPr>
-              <a:t>Material-Person zieht eine Situationskarte: Gruppenarbeit · Party · Chat · Nebenjob · Verein …</a:t>
+              <a:t>1. Tippkarte 1 zu Aufgabe 4 vom Pult</a:t>
+            </a:r>
+            <a:endParaRPr lang="en-US" sz="1400" dirty="0"/>
+          </a:p>
+          <a:p>
+            <a:pPr indent="0" marL="0">
+              <a:buNone/>
+            </a:pPr>
+            <a:r>
+              <a:rPr lang="en-US" sz="1400" dirty="0">
+                <a:solidFill>
+                  <a:srgbClr val="1E2761"/>
+                </a:solidFill>
+                <a:latin typeface="Calibri" pitchFamily="34" charset="0"/>
+                <a:ea typeface="Calibri" pitchFamily="34" charset="-122"/>
+                <a:cs typeface="Calibri" pitchFamily="34" charset="-120"/>
+              </a:rPr>
+              <a:t>2. Hilft nicht? Material-Person holt eine Notfall-Idee bei der Lehrkraft.</a:t>
             </a:r>
             <a:endParaRPr lang="en-US" sz="1400" dirty="0"/>
           </a:p>
@@ -8036,7 +8142,7 @@
                 <a:ea typeface="Cambria" pitchFamily="34" charset="-122"/>
                 <a:cs typeface="Cambria" pitchFamily="34" charset="-120"/>
               </a:rPr>
-              <a:t>Freeze! Hier kippt es</a:t>
+              <a:t>Spielen – ohne Unterbrechung</a:t>
             </a:r>
             <a:endParaRPr lang="en-US" sz="3200" dirty="0"/>
           </a:p>
@@ -8214,7 +8320,7 @@
                 <a:ea typeface="Cambria" pitchFamily="34" charset="-122"/>
                 <a:cs typeface="Cambria" pitchFamily="34" charset="-120"/>
               </a:rPr>
-              <a:t>30 Min.</a:t>
+              <a:t>25 Min.</a:t>
             </a:r>
             <a:endParaRPr lang="en-US" sz="2600" dirty="0"/>
           </a:p>
@@ -8327,7 +8433,7 @@
         <p:spPr>
           <a:xfrm>
             <a:off x="1097280" y="1828800"/>
-            <a:ext cx="6949440" cy="777240"/>
+            <a:ext cx="6949440" cy="868680"/>
           </a:xfrm>
           <a:prstGeom prst="rect">
             <a:avLst/>
@@ -8343,7 +8449,7 @@
               <a:buNone/>
             </a:pPr>
             <a:r>
-              <a:rPr lang="en-US" sz="1700" b="1" dirty="0">
+              <a:rPr lang="en-US" sz="1700" dirty="0">
                 <a:solidFill>
                   <a:srgbClr val="1E2761"/>
                 </a:solidFill>
@@ -8351,21 +8457,7 @@
                 <a:ea typeface="Calibri" pitchFamily="34" charset="-122"/>
                 <a:cs typeface="Calibri" pitchFamily="34" charset="-120"/>
               </a:rPr>
-              <a:t>Version A</a:t>
-            </a:r>
-            <a:pPr indent="0" marL="0">
-              <a:buNone/>
-            </a:pPr>
-            <a:r>
-              <a:rPr lang="en-US" sz="1700" dirty="0">
-                <a:solidFill>
-                  <a:srgbClr val="1E2761"/>
-                </a:solidFill>
-                <a:latin typeface="Calibri" pitchFamily="34" charset="0"/>
-                <a:ea typeface="Calibri" pitchFamily="34" charset="-122"/>
-                <a:cs typeface="Calibri" pitchFamily="34" charset="-120"/>
-              </a:rPr>
-              <a:t> wird gespielt.</a:t>
+              <a:t>Die Moderation ruft die Gruppen in der Reihenfolge an der Tafel auf.</a:t>
             </a:r>
             <a:endParaRPr lang="en-US" sz="1700" dirty="0"/>
           </a:p>
@@ -8379,7 +8471,7 @@
         </p:nvSpPr>
         <p:spPr>
           <a:xfrm>
-            <a:off x="548640" y="2624328"/>
+            <a:off x="548640" y="2715768"/>
             <a:ext cx="384048" cy="384048"/>
           </a:xfrm>
           <a:prstGeom prst="ellipse">
@@ -8399,7 +8491,7 @@
         </p:nvSpPr>
         <p:spPr>
           <a:xfrm>
-            <a:off x="548640" y="2624328"/>
+            <a:off x="548640" y="2715768"/>
             <a:ext cx="384048" cy="384048"/>
           </a:xfrm>
           <a:prstGeom prst="rect">
@@ -8438,8 +8530,8 @@
         </p:nvSpPr>
         <p:spPr>
           <a:xfrm>
-            <a:off x="1097280" y="2606040"/>
-            <a:ext cx="6949440" cy="777240"/>
+            <a:off x="1097280" y="2697480"/>
+            <a:ext cx="6949440" cy="868680"/>
           </a:xfrm>
           <a:prstGeom prst="rect">
             <a:avLst/>
@@ -8455,6 +8547,20 @@
               <a:buNone/>
             </a:pPr>
             <a:r>
+              <a:rPr lang="en-US" sz="1700" b="1" dirty="0">
+                <a:solidFill>
+                  <a:srgbClr val="1E2761"/>
+                </a:solidFill>
+                <a:latin typeface="Calibri" pitchFamily="34" charset="0"/>
+                <a:ea typeface="Calibri" pitchFamily="34" charset="-122"/>
+                <a:cs typeface="Calibri" pitchFamily="34" charset="-120"/>
+              </a:rPr>
+              <a:t>Version A</a:t>
+            </a:r>
+            <a:pPr indent="0" marL="0">
+              <a:buNone/>
+            </a:pPr>
+            <a:r>
               <a:rPr lang="en-US" sz="1700" dirty="0">
                 <a:solidFill>
                   <a:srgbClr val="1E2761"/>
@@ -8463,7 +8569,7 @@
                 <a:ea typeface="Calibri" pitchFamily="34" charset="-122"/>
                 <a:cs typeface="Calibri" pitchFamily="34" charset="-120"/>
               </a:rPr>
-              <a:t>Du erkennst den Kipppunkt? </a:t>
+              <a:t>, direkt danach </a:t>
             </a:r>
             <a:pPr indent="0" marL="0">
               <a:buNone/>
@@ -8477,7 +8583,21 @@
                 <a:ea typeface="Calibri" pitchFamily="34" charset="-122"/>
                 <a:cs typeface="Calibri" pitchFamily="34" charset="-120"/>
               </a:rPr>
-              <a:t>STOPP-Karte hoch!</a:t>
+              <a:t>Version B</a:t>
+            </a:r>
+            <a:pPr indent="0" marL="0">
+              <a:buNone/>
+            </a:pPr>
+            <a:r>
+              <a:rPr lang="en-US" sz="1700" dirty="0">
+                <a:solidFill>
+                  <a:srgbClr val="1E2761"/>
+                </a:solidFill>
+                <a:latin typeface="Calibri" pitchFamily="34" charset="0"/>
+                <a:ea typeface="Calibri" pitchFamily="34" charset="-122"/>
+                <a:cs typeface="Calibri" pitchFamily="34" charset="-120"/>
+              </a:rPr>
+              <a:t> – je höchstens 90 Sekunden.</a:t>
             </a:r>
             <a:endParaRPr lang="en-US" sz="1700" dirty="0"/>
           </a:p>
@@ -8491,7 +8611,7 @@
         </p:nvSpPr>
         <p:spPr>
           <a:xfrm>
-            <a:off x="548640" y="3401568"/>
+            <a:off x="548640" y="3584448"/>
             <a:ext cx="384048" cy="384048"/>
           </a:xfrm>
           <a:prstGeom prst="ellipse">
@@ -8511,7 +8631,7 @@
         </p:nvSpPr>
         <p:spPr>
           <a:xfrm>
-            <a:off x="548640" y="3401568"/>
+            <a:off x="548640" y="3584448"/>
             <a:ext cx="384048" cy="384048"/>
           </a:xfrm>
           <a:prstGeom prst="rect">
@@ -8550,8 +8670,8 @@
         </p:nvSpPr>
         <p:spPr>
           <a:xfrm>
-            <a:off x="1097280" y="3383280"/>
-            <a:ext cx="6949440" cy="777240"/>
+            <a:off x="1097280" y="3566160"/>
+            <a:ext cx="6949440" cy="868680"/>
           </a:xfrm>
           <a:prstGeom prst="rect">
             <a:avLst/>
@@ -8567,6 +8687,20 @@
               <a:buNone/>
             </a:pPr>
             <a:r>
+              <a:rPr lang="en-US" sz="1700" b="1" dirty="0">
+                <a:solidFill>
+                  <a:srgbClr val="1E2761"/>
+                </a:solidFill>
+                <a:latin typeface="Calibri" pitchFamily="34" charset="0"/>
+                <a:ea typeface="Calibri" pitchFamily="34" charset="-122"/>
+                <a:cs typeface="Calibri" pitchFamily="34" charset="-120"/>
+              </a:rPr>
+              <a:t>Niemand unterbricht.</a:t>
+            </a:r>
+            <a:pPr indent="0" marL="0">
+              <a:buNone/>
+            </a:pPr>
+            <a:r>
               <a:rPr lang="en-US" sz="1700" dirty="0">
                 <a:solidFill>
                   <a:srgbClr val="1E2761"/>
@@ -8575,35 +8709,7 @@
                 <a:ea typeface="Calibri" pitchFamily="34" charset="-122"/>
                 <a:cs typeface="Calibri" pitchFamily="34" charset="-120"/>
               </a:rPr>
-              <a:t>Moderation ruft </a:t>
-            </a:r>
-            <a:pPr indent="0" marL="0">
-              <a:buNone/>
-            </a:pPr>
-            <a:r>
-              <a:rPr lang="en-US" sz="1700" b="1" dirty="0">
-                <a:solidFill>
-                  <a:srgbClr val="1E2761"/>
-                </a:solidFill>
-                <a:latin typeface="Calibri" pitchFamily="34" charset="0"/>
-                <a:ea typeface="Calibri" pitchFamily="34" charset="-122"/>
-                <a:cs typeface="Calibri" pitchFamily="34" charset="-120"/>
-              </a:rPr>
-              <a:t>„Freeze!“</a:t>
-            </a:r>
-            <a:pPr indent="0" marL="0">
-              <a:buNone/>
-            </a:pPr>
-            <a:r>
-              <a:rPr lang="en-US" sz="1700" dirty="0">
-                <a:solidFill>
-                  <a:srgbClr val="1E2761"/>
-                </a:solidFill>
-                <a:latin typeface="Calibri" pitchFamily="34" charset="0"/>
-                <a:ea typeface="Calibri" pitchFamily="34" charset="-122"/>
-                <a:cs typeface="Calibri" pitchFamily="34" charset="-120"/>
-              </a:rPr>
-              <a:t> – eine Person erklärt in einem Satz, was passiert ist.</a:t>
+              <a:t> Das Publikum schaut genau hin: Wo kippt es? Was ist in B anders?</a:t>
             </a:r>
             <a:endParaRPr lang="en-US" sz="1700" dirty="0"/>
           </a:p>
@@ -8617,7 +8723,7 @@
         </p:nvSpPr>
         <p:spPr>
           <a:xfrm>
-            <a:off x="548640" y="4178808"/>
+            <a:off x="548640" y="4453128"/>
             <a:ext cx="384048" cy="384048"/>
           </a:xfrm>
           <a:prstGeom prst="ellipse">
@@ -8637,7 +8743,7 @@
         </p:nvSpPr>
         <p:spPr>
           <a:xfrm>
-            <a:off x="548640" y="4178808"/>
+            <a:off x="548640" y="4453128"/>
             <a:ext cx="384048" cy="384048"/>
           </a:xfrm>
           <a:prstGeom prst="rect">
@@ -8676,8 +8782,8 @@
         </p:nvSpPr>
         <p:spPr>
           <a:xfrm>
-            <a:off x="1097280" y="4160520"/>
-            <a:ext cx="6949440" cy="777240"/>
+            <a:off x="1097280" y="4434840"/>
+            <a:ext cx="6949440" cy="868680"/>
           </a:xfrm>
           <a:prstGeom prst="rect">
             <a:avLst/>
@@ -8693,6 +8799,20 @@
               <a:buNone/>
             </a:pPr>
             <a:r>
+              <a:rPr lang="en-US" sz="1700" dirty="0">
+                <a:solidFill>
+                  <a:srgbClr val="1E2761"/>
+                </a:solidFill>
+                <a:latin typeface="Calibri" pitchFamily="34" charset="0"/>
+                <a:ea typeface="Calibri" pitchFamily="34" charset="-122"/>
+                <a:cs typeface="Calibri" pitchFamily="34" charset="-120"/>
+              </a:rPr>
+              <a:t>Applaus – dann </a:t>
+            </a:r>
+            <a:pPr indent="0" marL="0">
+              <a:buNone/>
+            </a:pPr>
+            <a:r>
               <a:rPr lang="en-US" sz="1700" b="1" dirty="0">
                 <a:solidFill>
                   <a:srgbClr val="1E2761"/>
@@ -8701,7 +8821,7 @@
                 <a:ea typeface="Calibri" pitchFamily="34" charset="-122"/>
                 <a:cs typeface="Calibri" pitchFamily="34" charset="-120"/>
               </a:rPr>
-              <a:t>Version B</a:t>
+              <a:t>30 Sekunden</a:t>
             </a:r>
             <a:pPr indent="0" marL="0">
               <a:buNone/>
@@ -8715,7 +8835,7 @@
                 <a:ea typeface="Calibri" pitchFamily="34" charset="-122"/>
                 <a:cs typeface="Calibri" pitchFamily="34" charset="-120"/>
               </a:rPr>
-              <a:t> folgt direkt. Welche Strategie erkennst du?</a:t>
+              <a:t>, um die Zeile im Beobachtungsbogen auszufüllen.</a:t>
             </a:r>
             <a:endParaRPr lang="en-US" sz="1700" dirty="0"/>
           </a:p>
@@ -8729,11 +8849,13 @@
         </p:nvSpPr>
         <p:spPr>
           <a:xfrm>
-            <a:off x="548640" y="4956048"/>
-            <a:ext cx="384048" cy="384048"/>
-          </a:xfrm>
-          <a:prstGeom prst="ellipse">
-            <a:avLst/>
+            <a:off x="8503920" y="1783080"/>
+            <a:ext cx="3154680" cy="2377440"/>
+          </a:xfrm>
+          <a:prstGeom prst="roundRect">
+            <a:avLst>
+              <a:gd name="adj" fmla="val 3077"/>
+            </a:avLst>
           </a:prstGeom>
           <a:solidFill>
             <a:srgbClr val="1E2761"/>
@@ -8749,47 +8871,8 @@
         </p:nvSpPr>
         <p:spPr>
           <a:xfrm>
-            <a:off x="548640" y="4956048"/>
-            <a:ext cx="384048" cy="384048"/>
-          </a:xfrm>
-          <a:prstGeom prst="rect">
-            <a:avLst/>
-          </a:prstGeom>
-          <a:noFill/>
-          <a:ln/>
-        </p:spPr>
-        <p:txBody>
-          <a:bodyPr wrap="square" lIns="0" tIns="0" rIns="0" bIns="0" rtlCol="0" anchor="ctr"/>
-          <a:lstStyle/>
-          <a:p>
-            <a:pPr algn="ctr" indent="0" marL="0">
-              <a:buNone/>
-            </a:pPr>
-            <a:r>
-              <a:rPr lang="en-US" sz="1400" b="1" dirty="0">
-                <a:solidFill>
-                  <a:srgbClr val="FFFFFF"/>
-                </a:solidFill>
-                <a:latin typeface="Calibri" pitchFamily="34" charset="0"/>
-                <a:ea typeface="Calibri" pitchFamily="34" charset="-122"/>
-                <a:cs typeface="Calibri" pitchFamily="34" charset="-120"/>
-              </a:rPr>
-              <a:t>5</a:t>
-            </a:r>
-            <a:endParaRPr lang="en-US" sz="1400" dirty="0"/>
-          </a:p>
-        </p:txBody>
-      </p:sp>
-      <p:sp>
-        <p:nvSpPr>
-          <p:cNvPr id="24" name="Text 22"/>
-          <p:cNvSpPr txBox="1"/>
-          <p:nvPr/>
-        </p:nvSpPr>
-        <p:spPr>
-          <a:xfrm>
-            <a:off x="1097280" y="4937760"/>
-            <a:ext cx="6949440" cy="777240"/>
+            <a:off x="8686800" y="1920240"/>
+            <a:ext cx="2788920" cy="457200"/>
           </a:xfrm>
           <a:prstGeom prst="rect">
             <a:avLst/>
@@ -8805,135 +8888,7 @@
               <a:buNone/>
             </a:pPr>
             <a:r>
-              <a:rPr lang="en-US" sz="1700" dirty="0">
-                <a:solidFill>
-                  <a:srgbClr val="1E2761"/>
-                </a:solidFill>
-                <a:latin typeface="Calibri" pitchFamily="34" charset="0"/>
-                <a:ea typeface="Calibri" pitchFamily="34" charset="-122"/>
-                <a:cs typeface="Calibri" pitchFamily="34" charset="-120"/>
-              </a:rPr>
-              <a:t>Notiere alles im </a:t>
-            </a:r>
-            <a:pPr indent="0" marL="0">
-              <a:buNone/>
-            </a:pPr>
-            <a:r>
-              <a:rPr lang="en-US" sz="1700" b="1" dirty="0">
-                <a:solidFill>
-                  <a:srgbClr val="1E2761"/>
-                </a:solidFill>
-                <a:latin typeface="Calibri" pitchFamily="34" charset="0"/>
-                <a:ea typeface="Calibri" pitchFamily="34" charset="-122"/>
-                <a:cs typeface="Calibri" pitchFamily="34" charset="-120"/>
-              </a:rPr>
-              <a:t>Beobachtungsbogen</a:t>
-            </a:r>
-            <a:pPr indent="0" marL="0">
-              <a:buNone/>
-            </a:pPr>
-            <a:r>
-              <a:rPr lang="en-US" sz="1700" dirty="0">
-                <a:solidFill>
-                  <a:srgbClr val="1E2761"/>
-                </a:solidFill>
-                <a:latin typeface="Calibri" pitchFamily="34" charset="0"/>
-                <a:ea typeface="Calibri" pitchFamily="34" charset="-122"/>
-                <a:cs typeface="Calibri" pitchFamily="34" charset="-120"/>
-              </a:rPr>
-              <a:t>.</a:t>
-            </a:r>
-            <a:endParaRPr lang="en-US" sz="1700" dirty="0"/>
-          </a:p>
-        </p:txBody>
-      </p:sp>
-      <p:sp>
-        <p:nvSpPr>
-          <p:cNvPr id="25" name="Shape 23"/>
-          <p:cNvSpPr/>
-          <p:nvPr/>
-        </p:nvSpPr>
-        <p:spPr>
-          <a:xfrm>
-            <a:off x="8503920" y="1783080"/>
-            <a:ext cx="3154680" cy="3154680"/>
-          </a:xfrm>
-          <a:prstGeom prst="roundRect">
-            <a:avLst>
-              <a:gd name="adj" fmla="val 2319"/>
-            </a:avLst>
-          </a:prstGeom>
-          <a:solidFill>
-            <a:srgbClr val="D9534F"/>
-          </a:solidFill>
-          <a:ln/>
-        </p:spPr>
-      </p:sp>
-      <p:sp>
-        <p:nvSpPr>
-          <p:cNvPr id="26" name="Text 24"/>
-          <p:cNvSpPr txBox="1"/>
-          <p:nvPr/>
-        </p:nvSpPr>
-        <p:spPr>
-          <a:xfrm>
-            <a:off x="8503920" y="1965960"/>
-            <a:ext cx="3154680" cy="914400"/>
-          </a:xfrm>
-          <a:prstGeom prst="rect">
-            <a:avLst/>
-          </a:prstGeom>
-          <a:noFill/>
-          <a:ln/>
-        </p:spPr>
-        <p:txBody>
-          <a:bodyPr wrap="square" lIns="0" tIns="0" rIns="0" bIns="0" rtlCol="0" anchor="ctr"/>
-          <a:lstStyle/>
-          <a:p>
-            <a:pPr algn="ctr" indent="0" marL="0">
-              <a:buNone/>
-            </a:pPr>
-            <a:r>
-              <a:rPr lang="en-US" sz="4800" dirty="0">
-                <a:solidFill>
-                  <a:srgbClr val="FFFFFF"/>
-                </a:solidFill>
-                <a:latin typeface="Calibri" pitchFamily="34" charset="0"/>
-                <a:ea typeface="Calibri" pitchFamily="34" charset="-122"/>
-                <a:cs typeface="Calibri" pitchFamily="34" charset="-120"/>
-              </a:rPr>
-              <a:t>✋</a:t>
-            </a:r>
-            <a:endParaRPr lang="en-US" sz="4800" dirty="0"/>
-          </a:p>
-        </p:txBody>
-      </p:sp>
-      <p:sp>
-        <p:nvSpPr>
-          <p:cNvPr id="27" name="Text 25"/>
-          <p:cNvSpPr txBox="1"/>
-          <p:nvPr/>
-        </p:nvSpPr>
-        <p:spPr>
-          <a:xfrm>
-            <a:off x="8503920" y="2880360"/>
-            <a:ext cx="3154680" cy="914400"/>
-          </a:xfrm>
-          <a:prstGeom prst="rect">
-            <a:avLst/>
-          </a:prstGeom>
-          <a:noFill/>
-          <a:ln/>
-        </p:spPr>
-        <p:txBody>
-          <a:bodyPr wrap="square" lIns="0" tIns="0" rIns="0" bIns="0" rtlCol="0" anchor="ctr"/>
-          <a:lstStyle/>
-          <a:p>
-            <a:pPr algn="ctr" indent="0" marL="0">
-              <a:buNone/>
-            </a:pPr>
-            <a:r>
-              <a:rPr lang="en-US" sz="4800" b="1" dirty="0">
+              <a:rPr lang="en-US" sz="2000" b="1" dirty="0">
                 <a:solidFill>
                   <a:srgbClr val="FFFFFF"/>
                 </a:solidFill>
@@ -8941,38 +8896,38 @@
                 <a:ea typeface="Cambria" pitchFamily="34" charset="-122"/>
                 <a:cs typeface="Cambria" pitchFamily="34" charset="-120"/>
               </a:rPr>
-              <a:t>STOPP</a:t>
-            </a:r>
-            <a:endParaRPr lang="en-US" sz="4800" dirty="0"/>
-          </a:p>
-        </p:txBody>
-      </p:sp>
-      <p:sp>
-        <p:nvSpPr>
-          <p:cNvPr id="28" name="Text 26"/>
-          <p:cNvSpPr txBox="1"/>
-          <p:nvPr/>
-        </p:nvSpPr>
-        <p:spPr>
-          <a:xfrm>
-            <a:off x="8503920" y="3840480"/>
-            <a:ext cx="3154680" cy="457200"/>
-          </a:xfrm>
-          <a:prstGeom prst="rect">
-            <a:avLst/>
-          </a:prstGeom>
-          <a:noFill/>
-          <a:ln/>
-        </p:spPr>
-        <p:txBody>
-          <a:bodyPr wrap="square" lIns="0" tIns="0" rIns="0" bIns="0" rtlCol="0" anchor="ctr"/>
-          <a:lstStyle/>
-          <a:p>
-            <a:pPr algn="ctr" indent="0" marL="0">
-              <a:buNone/>
-            </a:pPr>
-            <a:r>
-              <a:rPr lang="en-US" sz="1800" b="1" dirty="0">
+              <a:t>Patenszene ★</a:t>
+            </a:r>
+            <a:endParaRPr lang="en-US" sz="2000" dirty="0"/>
+          </a:p>
+        </p:txBody>
+      </p:sp>
+      <p:sp>
+        <p:nvSpPr>
+          <p:cNvPr id="24" name="Text 22"/>
+          <p:cNvSpPr txBox="1"/>
+          <p:nvPr/>
+        </p:nvSpPr>
+        <p:spPr>
+          <a:xfrm>
+            <a:off x="8686800" y="2423160"/>
+            <a:ext cx="2788920" cy="1645920"/>
+          </a:xfrm>
+          <a:prstGeom prst="rect">
+            <a:avLst/>
+          </a:prstGeom>
+          <a:noFill/>
+          <a:ln/>
+        </p:spPr>
+        <p:txBody>
+          <a:bodyPr wrap="square" lIns="0" tIns="0" rIns="0" bIns="0" rtlCol="0" anchor="t"/>
+          <a:lstStyle/>
+          <a:p>
+            <a:pPr indent="0" marL="0">
+              <a:buNone/>
+            </a:pPr>
+            <a:r>
+              <a:rPr lang="en-US" sz="1500" dirty="0">
                 <a:solidFill>
                   <a:srgbClr val="FFFFFF"/>
                 </a:solidFill>
@@ -8980,70 +8935,109 @@
                 <a:ea typeface="Calibri" pitchFamily="34" charset="-122"/>
                 <a:cs typeface="Calibri" pitchFamily="34" charset="-120"/>
               </a:rPr>
-              <a:t>Hier kippt es!</a:t>
-            </a:r>
-            <a:endParaRPr lang="en-US" sz="1800" dirty="0"/>
-          </a:p>
-        </p:txBody>
-      </p:sp>
-      <p:sp>
-        <p:nvSpPr>
-          <p:cNvPr id="29" name="Shape 27"/>
+              <a:t>Die Gruppe, die nach euch spielt, beobachtet ihr besonders genau. Die letzte Gruppe beobachtet Gruppe 1.</a:t>
+            </a:r>
+            <a:endParaRPr lang="en-US" sz="1500" dirty="0"/>
+          </a:p>
+        </p:txBody>
+      </p:sp>
+      <p:sp>
+        <p:nvSpPr>
+          <p:cNvPr id="25" name="Shape 23"/>
           <p:cNvSpPr/>
           <p:nvPr/>
         </p:nvSpPr>
         <p:spPr>
           <a:xfrm>
-            <a:off x="8503920" y="5120640"/>
-            <a:ext cx="3154680" cy="960120"/>
+            <a:off x="8503920" y="4389120"/>
+            <a:ext cx="3154680" cy="1691640"/>
           </a:xfrm>
           <a:prstGeom prst="roundRect">
             <a:avLst>
-              <a:gd name="adj" fmla="val 7619"/>
+              <a:gd name="adj" fmla="val 4324"/>
             </a:avLst>
           </a:prstGeom>
           <a:solidFill>
-            <a:srgbClr val="1E2761"/>
+            <a:srgbClr val="EAF0FA"/>
           </a:solidFill>
           <a:ln/>
         </p:spPr>
       </p:sp>
       <p:sp>
         <p:nvSpPr>
-          <p:cNvPr id="30" name="Text 28"/>
-          <p:cNvSpPr txBox="1"/>
-          <p:nvPr/>
-        </p:nvSpPr>
-        <p:spPr>
-          <a:xfrm>
-            <a:off x="8686800" y="5120640"/>
-            <a:ext cx="2788920" cy="960120"/>
-          </a:xfrm>
-          <a:prstGeom prst="rect">
-            <a:avLst/>
-          </a:prstGeom>
-          <a:noFill/>
-          <a:ln/>
-        </p:spPr>
-        <p:txBody>
-          <a:bodyPr wrap="square" lIns="0" tIns="0" rIns="0" bIns="0" rtlCol="0" anchor="ctr"/>
-          <a:lstStyle/>
-          <a:p>
-            <a:pPr algn="ctr" indent="0" marL="0">
-              <a:buNone/>
-            </a:pPr>
-            <a:r>
-              <a:rPr lang="en-US" sz="1400" b="1" dirty="0">
-                <a:solidFill>
-                  <a:srgbClr val="FFFFFF"/>
-                </a:solidFill>
-                <a:latin typeface="Calibri" pitchFamily="34" charset="0"/>
-                <a:ea typeface="Calibri" pitchFamily="34" charset="-122"/>
-                <a:cs typeface="Calibri" pitchFamily="34" charset="-120"/>
-              </a:rPr>
-              <a:t>Moderation = die Gruppe, die als nächste spielt</a:t>
-            </a:r>
-            <a:endParaRPr lang="en-US" sz="1400" dirty="0"/>
+          <p:cNvPr id="26" name="Text 24"/>
+          <p:cNvSpPr txBox="1"/>
+          <p:nvPr/>
+        </p:nvSpPr>
+        <p:spPr>
+          <a:xfrm>
+            <a:off x="8686800" y="4498848"/>
+            <a:ext cx="2788920" cy="365760"/>
+          </a:xfrm>
+          <a:prstGeom prst="rect">
+            <a:avLst/>
+          </a:prstGeom>
+          <a:noFill/>
+          <a:ln/>
+        </p:spPr>
+        <p:txBody>
+          <a:bodyPr wrap="square" lIns="0" tIns="0" rIns="0" bIns="0" rtlCol="0" anchor="t"/>
+          <a:lstStyle/>
+          <a:p>
+            <a:pPr indent="0" marL="0">
+              <a:buNone/>
+            </a:pPr>
+            <a:r>
+              <a:rPr lang="en-US" sz="1600" b="1" dirty="0">
+                <a:solidFill>
+                  <a:srgbClr val="1E2761"/>
+                </a:solidFill>
+                <a:latin typeface="Cambria" pitchFamily="34" charset="0"/>
+                <a:ea typeface="Cambria" pitchFamily="34" charset="-122"/>
+                <a:cs typeface="Cambria" pitchFamily="34" charset="-120"/>
+              </a:rPr>
+              <a:t>Im Bogen notieren</a:t>
+            </a:r>
+            <a:endParaRPr lang="en-US" sz="1600" dirty="0"/>
+          </a:p>
+        </p:txBody>
+      </p:sp>
+      <p:sp>
+        <p:nvSpPr>
+          <p:cNvPr id="27" name="Text 25"/>
+          <p:cNvSpPr txBox="1"/>
+          <p:nvPr/>
+        </p:nvSpPr>
+        <p:spPr>
+          <a:xfrm>
+            <a:off x="8686800" y="4892040"/>
+            <a:ext cx="2788920" cy="1097280"/>
+          </a:xfrm>
+          <a:prstGeom prst="rect">
+            <a:avLst/>
+          </a:prstGeom>
+          <a:noFill/>
+          <a:ln/>
+        </p:spPr>
+        <p:txBody>
+          <a:bodyPr wrap="square" lIns="0" tIns="0" rIns="0" bIns="0" rtlCol="0" anchor="t"/>
+          <a:lstStyle/>
+          <a:p>
+            <a:pPr indent="0" marL="0">
+              <a:buNone/>
+            </a:pPr>
+            <a:r>
+              <a:rPr lang="en-US" sz="1500" dirty="0">
+                <a:solidFill>
+                  <a:srgbClr val="1E2761"/>
+                </a:solidFill>
+                <a:latin typeface="Calibri" pitchFamily="34" charset="0"/>
+                <a:ea typeface="Calibri" pitchFamily="34" charset="-122"/>
+                <a:cs typeface="Calibri" pitchFamily="34" charset="-120"/>
+              </a:rPr>
+              <a:t>Kipppunkt · Ursache · Strategie in B · Wirkt es?</a:t>
+            </a:r>
+            <a:endParaRPr lang="en-US" sz="1500" dirty="0"/>
           </a:p>
         </p:txBody>
       </p:sp>
@@ -9058,6 +9052,811 @@
 <file path=ppt/slides/slide8.xml><?xml version="1.0" encoding="utf-8"?>
 <p:sld xmlns:a="http://schemas.openxmlformats.org/drawingml/2006/main" xmlns:r="http://schemas.openxmlformats.org/officeDocument/2006/relationships" xmlns:p="http://schemas.openxmlformats.org/presentationml/2006/main">
   <p:cSld name="Slide 8">
+    <p:bg>
+      <p:bgPr>
+        <a:solidFill>
+          <a:srgbClr val="FFFFFF"/>
+        </a:solidFill>
+      </p:bgPr>
+    </p:bg>
+    <p:spTree>
+      <p:nvGrpSpPr>
+        <p:cNvPr id="1" name=""/>
+        <p:cNvGrpSpPr/>
+        <p:nvPr/>
+      </p:nvGrpSpPr>
+      <p:grpSpPr>
+        <a:xfrm>
+          <a:off x="0" y="0"/>
+          <a:ext cx="0" cy="0"/>
+          <a:chOff x="0" y="0"/>
+          <a:chExt cx="0" cy="0"/>
+        </a:xfrm>
+      </p:grpSpPr>
+      <p:sp>
+        <p:nvSpPr>
+          <p:cNvPr id="2" name="Text 0"/>
+          <p:cNvSpPr txBox="1"/>
+          <p:nvPr/>
+        </p:nvSpPr>
+        <p:spPr>
+          <a:xfrm>
+            <a:off x="548640" y="365760"/>
+            <a:ext cx="7315200" cy="274320"/>
+          </a:xfrm>
+          <a:prstGeom prst="rect">
+            <a:avLst/>
+          </a:prstGeom>
+          <a:noFill/>
+          <a:ln/>
+        </p:spPr>
+        <p:txBody>
+          <a:bodyPr wrap="square" lIns="0" tIns="0" rIns="0" bIns="0" rtlCol="0" anchor="t"/>
+          <a:lstStyle/>
+          <a:p>
+            <a:pPr indent="0" marL="0">
+              <a:buNone/>
+            </a:pPr>
+            <a:r>
+              <a:rPr lang="en-US" sz="1200" spc="200" kern="0" dirty="0">
+                <a:solidFill>
+                  <a:srgbClr val="5B6B8C"/>
+                </a:solidFill>
+                <a:latin typeface="Calibri" pitchFamily="34" charset="0"/>
+                <a:ea typeface="Calibri" pitchFamily="34" charset="-122"/>
+                <a:cs typeface="Calibri" pitchFamily="34" charset="-120"/>
+              </a:rPr>
+              <a:t>AUSWERTUNG</a:t>
+            </a:r>
+            <a:endParaRPr lang="en-US" sz="1200" dirty="0"/>
+          </a:p>
+        </p:txBody>
+      </p:sp>
+      <p:sp>
+        <p:nvSpPr>
+          <p:cNvPr id="3" name="Text 1"/>
+          <p:cNvSpPr txBox="1"/>
+          <p:nvPr/>
+        </p:nvSpPr>
+        <p:spPr>
+          <a:xfrm>
+            <a:off x="548640" y="658368"/>
+            <a:ext cx="9326880" cy="640080"/>
+          </a:xfrm>
+          <a:prstGeom prst="rect">
+            <a:avLst/>
+          </a:prstGeom>
+          <a:noFill/>
+          <a:ln/>
+        </p:spPr>
+        <p:txBody>
+          <a:bodyPr wrap="square" lIns="0" tIns="0" rIns="0" bIns="0" rtlCol="0" anchor="t"/>
+          <a:lstStyle/>
+          <a:p>
+            <a:pPr indent="0" marL="0">
+              <a:buNone/>
+            </a:pPr>
+            <a:r>
+              <a:rPr lang="en-US" sz="3200" b="1" dirty="0">
+                <a:solidFill>
+                  <a:srgbClr val="1E2761"/>
+                </a:solidFill>
+                <a:latin typeface="Cambria" pitchFamily="34" charset="0"/>
+                <a:ea typeface="Cambria" pitchFamily="34" charset="-122"/>
+                <a:cs typeface="Cambria" pitchFamily="34" charset="-120"/>
+              </a:rPr>
+              <a:t>Was haben wir gesehen?</a:t>
+            </a:r>
+            <a:endParaRPr lang="en-US" sz="3200" dirty="0"/>
+          </a:p>
+        </p:txBody>
+      </p:sp>
+      <p:sp>
+        <p:nvSpPr>
+          <p:cNvPr id="4" name="Text 2"/>
+          <p:cNvSpPr txBox="1"/>
+          <p:nvPr/>
+        </p:nvSpPr>
+        <p:spPr>
+          <a:xfrm>
+            <a:off x="548640" y="1298448"/>
+            <a:ext cx="9326880" cy="320040"/>
+          </a:xfrm>
+          <a:prstGeom prst="rect">
+            <a:avLst/>
+          </a:prstGeom>
+          <a:noFill/>
+          <a:ln/>
+        </p:spPr>
+        <p:txBody>
+          <a:bodyPr wrap="square" lIns="0" tIns="0" rIns="0" bIns="0" rtlCol="0" anchor="t"/>
+          <a:lstStyle/>
+          <a:p>
+            <a:pPr indent="0" marL="0">
+              <a:buNone/>
+            </a:pPr>
+            <a:r>
+              <a:rPr lang="en-US" sz="1400" i="1" dirty="0">
+                <a:solidFill>
+                  <a:srgbClr val="5B6B8C"/>
+                </a:solidFill>
+                <a:latin typeface="Calibri" pitchFamily="34" charset="0"/>
+                <a:ea typeface="Calibri" pitchFamily="34" charset="-122"/>
+                <a:cs typeface="Calibri" pitchFamily="34" charset="-120"/>
+              </a:rPr>
+              <a:t>Beobachtungsbogen · eure Patenszene</a:t>
+            </a:r>
+            <a:endParaRPr lang="en-US" sz="1400" dirty="0"/>
+          </a:p>
+        </p:txBody>
+      </p:sp>
+      <p:sp>
+        <p:nvSpPr>
+          <p:cNvPr id="5" name="Text 3"/>
+          <p:cNvSpPr txBox="1"/>
+          <p:nvPr/>
+        </p:nvSpPr>
+        <p:spPr>
+          <a:xfrm>
+            <a:off x="548640" y="6400800"/>
+            <a:ext cx="5486400" cy="228600"/>
+          </a:xfrm>
+          <a:prstGeom prst="rect">
+            <a:avLst/>
+          </a:prstGeom>
+          <a:noFill/>
+          <a:ln/>
+        </p:spPr>
+        <p:txBody>
+          <a:bodyPr wrap="square" lIns="0" tIns="0" rIns="0" bIns="0" rtlCol="0" anchor="t"/>
+          <a:lstStyle/>
+          <a:p>
+            <a:pPr indent="0" marL="0">
+              <a:buNone/>
+            </a:pPr>
+            <a:r>
+              <a:rPr lang="en-US" sz="1000" dirty="0">
+                <a:solidFill>
+                  <a:srgbClr val="5B6B8C"/>
+                </a:solidFill>
+                <a:latin typeface="Calibri" pitchFamily="34" charset="0"/>
+                <a:ea typeface="Calibri" pitchFamily="34" charset="-122"/>
+                <a:cs typeface="Calibri" pitchFamily="34" charset="-120"/>
+              </a:rPr>
+              <a:t>Kommunikationsstörungen lösen · Deutsch 11</a:t>
+            </a:r>
+            <a:endParaRPr lang="en-US" sz="1000" dirty="0"/>
+          </a:p>
+        </p:txBody>
+      </p:sp>
+      <p:sp>
+        <p:nvSpPr>
+          <p:cNvPr id="6" name="Text 4"/>
+          <p:cNvSpPr txBox="1"/>
+          <p:nvPr/>
+        </p:nvSpPr>
+        <p:spPr>
+          <a:xfrm>
+            <a:off x="11155680" y="6400800"/>
+            <a:ext cx="457200" cy="228600"/>
+          </a:xfrm>
+          <a:prstGeom prst="rect">
+            <a:avLst/>
+          </a:prstGeom>
+          <a:noFill/>
+          <a:ln/>
+        </p:spPr>
+        <p:txBody>
+          <a:bodyPr wrap="square" lIns="0" tIns="0" rIns="0" bIns="0" rtlCol="0" anchor="t"/>
+          <a:lstStyle/>
+          <a:p>
+            <a:pPr algn="r" indent="0" marL="0">
+              <a:buNone/>
+            </a:pPr>
+            <a:r>
+              <a:rPr lang="en-US" sz="1000" dirty="0">
+                <a:solidFill>
+                  <a:srgbClr val="5B6B8C"/>
+                </a:solidFill>
+                <a:latin typeface="Calibri" pitchFamily="34" charset="0"/>
+                <a:ea typeface="Calibri" pitchFamily="34" charset="-122"/>
+                <a:cs typeface="Calibri" pitchFamily="34" charset="-120"/>
+              </a:rPr>
+              <a:t>8</a:t>
+            </a:r>
+            <a:endParaRPr lang="en-US" sz="1000" dirty="0"/>
+          </a:p>
+        </p:txBody>
+      </p:sp>
+      <p:sp>
+        <p:nvSpPr>
+          <p:cNvPr id="7" name="Shape 5"/>
+          <p:cNvSpPr/>
+          <p:nvPr/>
+        </p:nvSpPr>
+        <p:spPr>
+          <a:xfrm>
+            <a:off x="9966960" y="411480"/>
+            <a:ext cx="1691640" cy="914400"/>
+          </a:xfrm>
+          <a:prstGeom prst="roundRect">
+            <a:avLst>
+              <a:gd name="adj" fmla="val 8000"/>
+            </a:avLst>
+          </a:prstGeom>
+          <a:solidFill>
+            <a:srgbClr val="1E2761"/>
+          </a:solidFill>
+          <a:ln/>
+        </p:spPr>
+      </p:sp>
+      <p:sp>
+        <p:nvSpPr>
+          <p:cNvPr id="8" name="Text 6"/>
+          <p:cNvSpPr txBox="1"/>
+          <p:nvPr/>
+        </p:nvSpPr>
+        <p:spPr>
+          <a:xfrm>
+            <a:off x="9966960" y="457200"/>
+            <a:ext cx="1691640" cy="502920"/>
+          </a:xfrm>
+          <a:prstGeom prst="rect">
+            <a:avLst/>
+          </a:prstGeom>
+          <a:noFill/>
+          <a:ln/>
+        </p:spPr>
+        <p:txBody>
+          <a:bodyPr wrap="square" lIns="0" tIns="0" rIns="0" bIns="0" rtlCol="0" anchor="ctr"/>
+          <a:lstStyle/>
+          <a:p>
+            <a:pPr algn="ctr" indent="0" marL="0">
+              <a:buNone/>
+            </a:pPr>
+            <a:r>
+              <a:rPr lang="en-US" sz="2600" b="1" dirty="0">
+                <a:solidFill>
+                  <a:srgbClr val="FFFFFF"/>
+                </a:solidFill>
+                <a:latin typeface="Cambria" pitchFamily="34" charset="0"/>
+                <a:ea typeface="Cambria" pitchFamily="34" charset="-122"/>
+                <a:cs typeface="Cambria" pitchFamily="34" charset="-120"/>
+              </a:rPr>
+              <a:t>13 Min.</a:t>
+            </a:r>
+            <a:endParaRPr lang="en-US" sz="2600" dirty="0"/>
+          </a:p>
+        </p:txBody>
+      </p:sp>
+      <p:sp>
+        <p:nvSpPr>
+          <p:cNvPr id="9" name="Text 7"/>
+          <p:cNvSpPr txBox="1"/>
+          <p:nvPr/>
+        </p:nvSpPr>
+        <p:spPr>
+          <a:xfrm>
+            <a:off x="9966960" y="932688"/>
+            <a:ext cx="1691640" cy="320040"/>
+          </a:xfrm>
+          <a:prstGeom prst="rect">
+            <a:avLst/>
+          </a:prstGeom>
+          <a:noFill/>
+          <a:ln/>
+        </p:spPr>
+        <p:txBody>
+          <a:bodyPr wrap="square" lIns="0" tIns="0" rIns="0" bIns="0" rtlCol="0" anchor="ctr"/>
+          <a:lstStyle/>
+          <a:p>
+            <a:pPr algn="ctr" indent="0" marL="0">
+              <a:buNone/>
+            </a:pPr>
+            <a:r>
+              <a:rPr lang="en-US" sz="1200" dirty="0">
+                <a:solidFill>
+                  <a:srgbClr val="CADCFC"/>
+                </a:solidFill>
+                <a:latin typeface="Calibri" pitchFamily="34" charset="0"/>
+                <a:ea typeface="Calibri" pitchFamily="34" charset="-122"/>
+                <a:cs typeface="Calibri" pitchFamily="34" charset="-120"/>
+              </a:rPr>
+              <a:t>still → Gruppe → Plenum</a:t>
+            </a:r>
+            <a:endParaRPr lang="en-US" sz="1200" dirty="0"/>
+          </a:p>
+        </p:txBody>
+      </p:sp>
+      <p:sp>
+        <p:nvSpPr>
+          <p:cNvPr id="10" name="Shape 8"/>
+          <p:cNvSpPr/>
+          <p:nvPr/>
+        </p:nvSpPr>
+        <p:spPr>
+          <a:xfrm>
+            <a:off x="548640" y="1783080"/>
+            <a:ext cx="3566160" cy="3291840"/>
+          </a:xfrm>
+          <a:prstGeom prst="roundRect">
+            <a:avLst>
+              <a:gd name="adj" fmla="val 2222"/>
+            </a:avLst>
+          </a:prstGeom>
+          <a:solidFill>
+            <a:srgbClr val="F4F7FD"/>
+          </a:solidFill>
+          <a:ln/>
+        </p:spPr>
+      </p:sp>
+      <p:sp>
+        <p:nvSpPr>
+          <p:cNvPr id="11" name="Text 9"/>
+          <p:cNvSpPr txBox="1"/>
+          <p:nvPr/>
+        </p:nvSpPr>
+        <p:spPr>
+          <a:xfrm>
+            <a:off x="777240" y="1920240"/>
+            <a:ext cx="1097280" cy="640080"/>
+          </a:xfrm>
+          <a:prstGeom prst="rect">
+            <a:avLst/>
+          </a:prstGeom>
+          <a:noFill/>
+          <a:ln/>
+        </p:spPr>
+        <p:txBody>
+          <a:bodyPr wrap="square" lIns="0" tIns="0" rIns="0" bIns="0" rtlCol="0" anchor="t"/>
+          <a:lstStyle/>
+          <a:p>
+            <a:pPr indent="0" marL="0">
+              <a:buNone/>
+            </a:pPr>
+            <a:r>
+              <a:rPr lang="en-US" sz="3200" b="1" dirty="0">
+                <a:solidFill>
+                  <a:srgbClr val="D9534F"/>
+                </a:solidFill>
+                <a:latin typeface="Cambria" pitchFamily="34" charset="0"/>
+                <a:ea typeface="Cambria" pitchFamily="34" charset="-122"/>
+                <a:cs typeface="Cambria" pitchFamily="34" charset="-120"/>
+              </a:rPr>
+              <a:t>2'</a:t>
+            </a:r>
+            <a:endParaRPr lang="en-US" sz="3200" dirty="0"/>
+          </a:p>
+        </p:txBody>
+      </p:sp>
+      <p:sp>
+        <p:nvSpPr>
+          <p:cNvPr id="12" name="Text 10"/>
+          <p:cNvSpPr txBox="1"/>
+          <p:nvPr/>
+        </p:nvSpPr>
+        <p:spPr>
+          <a:xfrm>
+            <a:off x="777240" y="2606040"/>
+            <a:ext cx="3108960" cy="457200"/>
+          </a:xfrm>
+          <a:prstGeom prst="rect">
+            <a:avLst/>
+          </a:prstGeom>
+          <a:noFill/>
+          <a:ln/>
+        </p:spPr>
+        <p:txBody>
+          <a:bodyPr wrap="square" lIns="0" tIns="0" rIns="0" bIns="0" rtlCol="0" anchor="t"/>
+          <a:lstStyle/>
+          <a:p>
+            <a:pPr indent="0" marL="0">
+              <a:buNone/>
+            </a:pPr>
+            <a:r>
+              <a:rPr lang="en-US" sz="2000" b="1" dirty="0">
+                <a:solidFill>
+                  <a:srgbClr val="1E2761"/>
+                </a:solidFill>
+                <a:latin typeface="Cambria" pitchFamily="34" charset="0"/>
+                <a:ea typeface="Cambria" pitchFamily="34" charset="-122"/>
+                <a:cs typeface="Cambria" pitchFamily="34" charset="-120"/>
+              </a:rPr>
+              <a:t>Still</a:t>
+            </a:r>
+            <a:endParaRPr lang="en-US" sz="2000" dirty="0"/>
+          </a:p>
+        </p:txBody>
+      </p:sp>
+      <p:sp>
+        <p:nvSpPr>
+          <p:cNvPr id="13" name="Text 11"/>
+          <p:cNvSpPr txBox="1"/>
+          <p:nvPr/>
+        </p:nvSpPr>
+        <p:spPr>
+          <a:xfrm>
+            <a:off x="777240" y="3154680"/>
+            <a:ext cx="3108960" cy="1828800"/>
+          </a:xfrm>
+          <a:prstGeom prst="rect">
+            <a:avLst/>
+          </a:prstGeom>
+          <a:noFill/>
+          <a:ln/>
+        </p:spPr>
+        <p:txBody>
+          <a:bodyPr wrap="square" lIns="0" tIns="0" rIns="0" bIns="0" rtlCol="0" anchor="t"/>
+          <a:lstStyle/>
+          <a:p>
+            <a:pPr indent="0" marL="0">
+              <a:buNone/>
+            </a:pPr>
+            <a:r>
+              <a:rPr lang="en-US" sz="1500" dirty="0">
+                <a:solidFill>
+                  <a:srgbClr val="1E2761"/>
+                </a:solidFill>
+                <a:latin typeface="Calibri" pitchFamily="34" charset="0"/>
+                <a:ea typeface="Calibri" pitchFamily="34" charset="-122"/>
+                <a:cs typeface="Calibri" pitchFamily="34" charset="-120"/>
+              </a:rPr>
+              <a:t>Ergänze deinen Beobachtungsbogen. Was ist dir bei deiner Patenszene aufgefallen?</a:t>
+            </a:r>
+            <a:endParaRPr lang="en-US" sz="1500" dirty="0"/>
+          </a:p>
+        </p:txBody>
+      </p:sp>
+      <p:sp>
+        <p:nvSpPr>
+          <p:cNvPr id="14" name="Shape 12"/>
+          <p:cNvSpPr/>
+          <p:nvPr/>
+        </p:nvSpPr>
+        <p:spPr>
+          <a:xfrm>
+            <a:off x="4297680" y="1783080"/>
+            <a:ext cx="3566160" cy="3291840"/>
+          </a:xfrm>
+          <a:prstGeom prst="roundRect">
+            <a:avLst>
+              <a:gd name="adj" fmla="val 2222"/>
+            </a:avLst>
+          </a:prstGeom>
+          <a:solidFill>
+            <a:srgbClr val="F4F7FD"/>
+          </a:solidFill>
+          <a:ln/>
+        </p:spPr>
+      </p:sp>
+      <p:sp>
+        <p:nvSpPr>
+          <p:cNvPr id="15" name="Text 13"/>
+          <p:cNvSpPr txBox="1"/>
+          <p:nvPr/>
+        </p:nvSpPr>
+        <p:spPr>
+          <a:xfrm>
+            <a:off x="4526280" y="1920240"/>
+            <a:ext cx="1097280" cy="640080"/>
+          </a:xfrm>
+          <a:prstGeom prst="rect">
+            <a:avLst/>
+          </a:prstGeom>
+          <a:noFill/>
+          <a:ln/>
+        </p:spPr>
+        <p:txBody>
+          <a:bodyPr wrap="square" lIns="0" tIns="0" rIns="0" bIns="0" rtlCol="0" anchor="t"/>
+          <a:lstStyle/>
+          <a:p>
+            <a:pPr indent="0" marL="0">
+              <a:buNone/>
+            </a:pPr>
+            <a:r>
+              <a:rPr lang="en-US" sz="3200" b="1" dirty="0">
+                <a:solidFill>
+                  <a:srgbClr val="D9534F"/>
+                </a:solidFill>
+                <a:latin typeface="Cambria" pitchFamily="34" charset="0"/>
+                <a:ea typeface="Cambria" pitchFamily="34" charset="-122"/>
+                <a:cs typeface="Cambria" pitchFamily="34" charset="-120"/>
+              </a:rPr>
+              <a:t>4'</a:t>
+            </a:r>
+            <a:endParaRPr lang="en-US" sz="3200" dirty="0"/>
+          </a:p>
+        </p:txBody>
+      </p:sp>
+      <p:sp>
+        <p:nvSpPr>
+          <p:cNvPr id="16" name="Text 14"/>
+          <p:cNvSpPr txBox="1"/>
+          <p:nvPr/>
+        </p:nvSpPr>
+        <p:spPr>
+          <a:xfrm>
+            <a:off x="4526280" y="2606040"/>
+            <a:ext cx="3108960" cy="457200"/>
+          </a:xfrm>
+          <a:prstGeom prst="rect">
+            <a:avLst/>
+          </a:prstGeom>
+          <a:noFill/>
+          <a:ln/>
+        </p:spPr>
+        <p:txBody>
+          <a:bodyPr wrap="square" lIns="0" tIns="0" rIns="0" bIns="0" rtlCol="0" anchor="t"/>
+          <a:lstStyle/>
+          <a:p>
+            <a:pPr indent="0" marL="0">
+              <a:buNone/>
+            </a:pPr>
+            <a:r>
+              <a:rPr lang="en-US" sz="2000" b="1" dirty="0">
+                <a:solidFill>
+                  <a:srgbClr val="1E2761"/>
+                </a:solidFill>
+                <a:latin typeface="Cambria" pitchFamily="34" charset="0"/>
+                <a:ea typeface="Cambria" pitchFamily="34" charset="-122"/>
+                <a:cs typeface="Cambria" pitchFamily="34" charset="-120"/>
+              </a:rPr>
+              <a:t>Tischgruppe</a:t>
+            </a:r>
+            <a:endParaRPr lang="en-US" sz="2000" dirty="0"/>
+          </a:p>
+        </p:txBody>
+      </p:sp>
+      <p:sp>
+        <p:nvSpPr>
+          <p:cNvPr id="17" name="Text 15"/>
+          <p:cNvSpPr txBox="1"/>
+          <p:nvPr/>
+        </p:nvSpPr>
+        <p:spPr>
+          <a:xfrm>
+            <a:off x="4526280" y="3154680"/>
+            <a:ext cx="3108960" cy="1828800"/>
+          </a:xfrm>
+          <a:prstGeom prst="rect">
+            <a:avLst/>
+          </a:prstGeom>
+          <a:noFill/>
+          <a:ln/>
+        </p:spPr>
+        <p:txBody>
+          <a:bodyPr wrap="square" lIns="0" tIns="0" rIns="0" bIns="0" rtlCol="0" anchor="t"/>
+          <a:lstStyle/>
+          <a:p>
+            <a:pPr indent="0" marL="0">
+              <a:buNone/>
+            </a:pPr>
+            <a:r>
+              <a:rPr lang="en-US" sz="1500" dirty="0">
+                <a:solidFill>
+                  <a:srgbClr val="1E2761"/>
+                </a:solidFill>
+                <a:latin typeface="Calibri" pitchFamily="34" charset="0"/>
+                <a:ea typeface="Calibri" pitchFamily="34" charset="-122"/>
+                <a:cs typeface="Calibri" pitchFamily="34" charset="-120"/>
+              </a:rPr>
+              <a:t>Einigt euch zu eurer Patenszene: Wo genau kippt es? Warum (Fachbegriff)? Welche Strategie hat in Version B am besten gewirkt?</a:t>
+            </a:r>
+            <a:endParaRPr lang="en-US" sz="1500" dirty="0"/>
+          </a:p>
+        </p:txBody>
+      </p:sp>
+      <p:sp>
+        <p:nvSpPr>
+          <p:cNvPr id="18" name="Shape 16"/>
+          <p:cNvSpPr/>
+          <p:nvPr/>
+        </p:nvSpPr>
+        <p:spPr>
+          <a:xfrm>
+            <a:off x="8046720" y="1783080"/>
+            <a:ext cx="3566160" cy="3291840"/>
+          </a:xfrm>
+          <a:prstGeom prst="roundRect">
+            <a:avLst>
+              <a:gd name="adj" fmla="val 2222"/>
+            </a:avLst>
+          </a:prstGeom>
+          <a:solidFill>
+            <a:srgbClr val="EAF0FA"/>
+          </a:solidFill>
+          <a:ln/>
+        </p:spPr>
+      </p:sp>
+      <p:sp>
+        <p:nvSpPr>
+          <p:cNvPr id="19" name="Text 17"/>
+          <p:cNvSpPr txBox="1"/>
+          <p:nvPr/>
+        </p:nvSpPr>
+        <p:spPr>
+          <a:xfrm>
+            <a:off x="8275320" y="1920240"/>
+            <a:ext cx="1097280" cy="640080"/>
+          </a:xfrm>
+          <a:prstGeom prst="rect">
+            <a:avLst/>
+          </a:prstGeom>
+          <a:noFill/>
+          <a:ln/>
+        </p:spPr>
+        <p:txBody>
+          <a:bodyPr wrap="square" lIns="0" tIns="0" rIns="0" bIns="0" rtlCol="0" anchor="t"/>
+          <a:lstStyle/>
+          <a:p>
+            <a:pPr indent="0" marL="0">
+              <a:buNone/>
+            </a:pPr>
+            <a:r>
+              <a:rPr lang="en-US" sz="3200" b="1" dirty="0">
+                <a:solidFill>
+                  <a:srgbClr val="D9534F"/>
+                </a:solidFill>
+                <a:latin typeface="Cambria" pitchFamily="34" charset="0"/>
+                <a:ea typeface="Cambria" pitchFamily="34" charset="-122"/>
+                <a:cs typeface="Cambria" pitchFamily="34" charset="-120"/>
+              </a:rPr>
+              <a:t>7'</a:t>
+            </a:r>
+            <a:endParaRPr lang="en-US" sz="3200" dirty="0"/>
+          </a:p>
+        </p:txBody>
+      </p:sp>
+      <p:sp>
+        <p:nvSpPr>
+          <p:cNvPr id="20" name="Text 18"/>
+          <p:cNvSpPr txBox="1"/>
+          <p:nvPr/>
+        </p:nvSpPr>
+        <p:spPr>
+          <a:xfrm>
+            <a:off x="8275320" y="2606040"/>
+            <a:ext cx="3108960" cy="457200"/>
+          </a:xfrm>
+          <a:prstGeom prst="rect">
+            <a:avLst/>
+          </a:prstGeom>
+          <a:noFill/>
+          <a:ln/>
+        </p:spPr>
+        <p:txBody>
+          <a:bodyPr wrap="square" lIns="0" tIns="0" rIns="0" bIns="0" rtlCol="0" anchor="t"/>
+          <a:lstStyle/>
+          <a:p>
+            <a:pPr indent="0" marL="0">
+              <a:buNone/>
+            </a:pPr>
+            <a:r>
+              <a:rPr lang="en-US" sz="2000" b="1" dirty="0">
+                <a:solidFill>
+                  <a:srgbClr val="1E2761"/>
+                </a:solidFill>
+                <a:latin typeface="Cambria" pitchFamily="34" charset="0"/>
+                <a:ea typeface="Cambria" pitchFamily="34" charset="-122"/>
+                <a:cs typeface="Cambria" pitchFamily="34" charset="-120"/>
+              </a:rPr>
+              <a:t>Plenum</a:t>
+            </a:r>
+            <a:endParaRPr lang="en-US" sz="2000" dirty="0"/>
+          </a:p>
+        </p:txBody>
+      </p:sp>
+      <p:sp>
+        <p:nvSpPr>
+          <p:cNvPr id="21" name="Text 19"/>
+          <p:cNvSpPr txBox="1"/>
+          <p:nvPr/>
+        </p:nvSpPr>
+        <p:spPr>
+          <a:xfrm>
+            <a:off x="8275320" y="3154680"/>
+            <a:ext cx="3108960" cy="1828800"/>
+          </a:xfrm>
+          <a:prstGeom prst="rect">
+            <a:avLst/>
+          </a:prstGeom>
+          <a:noFill/>
+          <a:ln/>
+        </p:spPr>
+        <p:txBody>
+          <a:bodyPr wrap="square" lIns="0" tIns="0" rIns="0" bIns="0" rtlCol="0" anchor="t"/>
+          <a:lstStyle/>
+          <a:p>
+            <a:pPr indent="0" marL="0">
+              <a:buNone/>
+            </a:pPr>
+            <a:r>
+              <a:rPr lang="en-US" sz="1500" dirty="0">
+                <a:solidFill>
+                  <a:srgbClr val="1E2761"/>
+                </a:solidFill>
+                <a:latin typeface="Calibri" pitchFamily="34" charset="0"/>
+                <a:ea typeface="Calibri" pitchFamily="34" charset="-122"/>
+                <a:cs typeface="Calibri" pitchFamily="34" charset="-120"/>
+              </a:rPr>
+              <a:t>Jede Gruppe: 1 Minute Rückmeldung zu ihrer Patenszene. Die Spielgruppe darf mit einem Satz ergänzen.</a:t>
+            </a:r>
+            <a:endParaRPr lang="en-US" sz="1500" dirty="0"/>
+          </a:p>
+        </p:txBody>
+      </p:sp>
+      <p:sp>
+        <p:nvSpPr>
+          <p:cNvPr id="22" name="Shape 20"/>
+          <p:cNvSpPr/>
+          <p:nvPr/>
+        </p:nvSpPr>
+        <p:spPr>
+          <a:xfrm>
+            <a:off x="548640" y="5349240"/>
+            <a:ext cx="11109960" cy="731520"/>
+          </a:xfrm>
+          <a:prstGeom prst="roundRect">
+            <a:avLst>
+              <a:gd name="adj" fmla="val 10000"/>
+            </a:avLst>
+          </a:prstGeom>
+          <a:solidFill>
+            <a:srgbClr val="1E2761"/>
+          </a:solidFill>
+          <a:ln/>
+        </p:spPr>
+      </p:sp>
+      <p:sp>
+        <p:nvSpPr>
+          <p:cNvPr id="23" name="Text 21"/>
+          <p:cNvSpPr txBox="1"/>
+          <p:nvPr/>
+        </p:nvSpPr>
+        <p:spPr>
+          <a:xfrm>
+            <a:off x="822960" y="5349240"/>
+            <a:ext cx="10607040" cy="731520"/>
+          </a:xfrm>
+          <a:prstGeom prst="rect">
+            <a:avLst/>
+          </a:prstGeom>
+          <a:noFill/>
+          <a:ln/>
+        </p:spPr>
+        <p:txBody>
+          <a:bodyPr wrap="square" lIns="0" tIns="0" rIns="0" bIns="0" rtlCol="0" anchor="ctr"/>
+          <a:lstStyle/>
+          <a:p>
+            <a:pPr indent="0" marL="0">
+              <a:buNone/>
+            </a:pPr>
+            <a:r>
+              <a:rPr lang="en-US" sz="1600" b="1" dirty="0">
+                <a:solidFill>
+                  <a:srgbClr val="FFFFFF"/>
+                </a:solidFill>
+                <a:latin typeface="Calibri" pitchFamily="34" charset="0"/>
+                <a:ea typeface="Calibri" pitchFamily="34" charset="-122"/>
+                <a:cs typeface="Calibri" pitchFamily="34" charset="-120"/>
+              </a:rPr>
+              <a:t>Sprechende Person im Plenum: die Regie-Person der Gruppe.   Die Moderation ruft auf.</a:t>
+            </a:r>
+            <a:endParaRPr lang="en-US" sz="1600" dirty="0"/>
+          </a:p>
+        </p:txBody>
+      </p:sp>
+    </p:spTree>
+  </p:cSld>
+  <p:clrMapOvr>
+    <a:masterClrMapping/>
+  </p:clrMapOvr>
+</p:sld>
+</file>
+
+<file path=ppt/slides/slide9.xml><?xml version="1.0" encoding="utf-8"?>
+<p:sld xmlns:a="http://schemas.openxmlformats.org/drawingml/2006/main" xmlns:r="http://schemas.openxmlformats.org/officeDocument/2006/relationships" xmlns:p="http://schemas.openxmlformats.org/presentationml/2006/main">
+  <p:cSld name="Slide 9">
     <p:bg>
       <p:bgPr>
         <a:solidFill>
@@ -9174,7 +9973,7 @@
                 <a:ea typeface="Calibri" pitchFamily="34" charset="-122"/>
                 <a:cs typeface="Calibri" pitchFamily="34" charset="-120"/>
               </a:rPr>
-              <a:t>EXIT-TICKET · 5 MIN.</a:t>
+              <a:t>EXIT-TICKET · 4 MIN.</a:t>
             </a:r>
             <a:endParaRPr lang="en-US" sz="1200" dirty="0"/>
           </a:p>
@@ -9487,7 +10286,7 @@
                 <a:ea typeface="Calibri" pitchFamily="34" charset="-122"/>
                 <a:cs typeface="Calibri" pitchFamily="34" charset="-120"/>
               </a:rPr>
-              <a:t>Abgabe an der Tür.</a:t>
+              <a:t>Ticket liegt im Gruppenumschlag · Abgabe an der Tür.</a:t>
             </a:r>
             <a:endParaRPr lang="en-US" sz="1600" dirty="0"/>
           </a:p>

</xml_diff>

<commit_message>
Deutsch 11: Impuls EA/PA, danach drei Reihen-Gruppen à 7 (Wand, Mitte, Fenster)
Co-Authored-By: Claude Opus 5.5 <noreply@anthropic.com>
Claude-Session: https://claude.ai/code/session_01Kzh1oWiqhC6W8oSNq8mKnj
</commit_message>
<xml_diff>
--- a/Deutsch_11/Kommunikationsstoerungen_loesen/Praesentation_Kommunikationsstoerungen_loesen.pptx
+++ b/Deutsch_11/Kommunikationsstoerungen_loesen/Praesentation_Kommunikationsstoerungen_loesen.pptx
@@ -510,7 +510,7 @@
           <a:p>
             <a:r>
               <a:rPr lang="en-US" dirty="0"/>
-              <a:t>Diese Folie läuft beim Ankommen. Alles liegt bereits: Arbeitsblatt auf jedem Platz, pro Gruppentisch ein Umschlag (Rollenkarten, Expertenkarten A–D, Exit-Tickets). Aufs Pult: Tippkarten und Lösungsblätter. Bei Ihnen: Umschlag mit Notfall-Ideen, Moderationskarten. Einziger Satz: „Heute steht alles auf den Folien – schaut einfach dorthin.“ Dann Folie 2 und Timer 5 Min.</a:t>
+              <a:t>Diese Folie läuft beim Ankommen. Die Klasse sitzt normal in den drei Reihen. Alles liegt bereits: Arbeitsblatt auf jedem Platz, je ein geschlossener Umschlag auf dem ersten Tisch jeder Reihe (Rollenkarten, 2 Sätze Expertenkarten, 7 Exit-Tickets). Aufs Pult: Tippkarten und Lösungsblätter. Bei Ihnen: Notfall-Ideen und Moderationskarten. Einziger Satz: „Heute steht alles auf den Folien – schaut einfach dorthin.“ Dann Folie 2 und Timer 5 Min.</a:t>
             </a:r>
             <a:endParaRPr lang="en-US" dirty="0"/>
           </a:p>
@@ -686,7 +686,7 @@
           <a:p>
             <a:r>
               <a:rPr lang="en-US" dirty="0"/>
-              <a:t>Während der Partnerarbeit herumgehen und nur zuhören. Wer fertig ist, holt sich das Lösungsblatt „Kipppunkte“ selbst vom Pult. Erwartung: Z. 3 (★ Du-Botschaft/Beziehungsohr), Z. 4 (Gegenangriff, symmetrische Eskalation), Z. 5 (Verallgemeinerung, Interpunktion), Z. 7 (Ironie, inkongruent), Z. 8–9 (nonverbaler Rückzug, man kann nicht nicht kommunizieren). Die Klasse sitzt bereits in den Vierergruppen – kein Umbau nötig.</a:t>
+              <a:t>Während der Partnerarbeit herumgehen und nur zuhören. Wer fertig ist, holt sich das Lösungsblatt „Kipppunkte“ selbst vom Pult. Erwartung: Z. 3 (★ Du-Botschaft/Beziehungsohr), Z. 4 (Gegenangriff, symmetrische Eskalation), Z. 5 (Verallgemeinerung, Interpunktion), Z. 7 (Ironie, inkongruent), Z. 8–9 (nonverbaler Rückzug, man kann nicht nicht kommunizieren). Danach Folie 4: Die drei Reihen setzen sich als Gruppen zusammen.</a:t>
             </a:r>
             <a:endParaRPr lang="en-US" dirty="0"/>
           </a:p>
@@ -774,7 +774,7 @@
           <a:p>
             <a:r>
               <a:rPr lang="en-US" dirty="0"/>
-              <a:t>Timer auf 17 Minuten, die Zeit-Person der Gruppe achtet auf die Teilphasen. Nach 1 Minute prüfen, ob alle Gruppen Rollen verteilt haben. Ab ca. Minute 24 Folie 5 (Werkzeugkasten) einblenden und stehen lassen. Musterlösung liegt am Pult.</a:t>
+              <a:t>Erst 3 Minuten Umsetzen: Wand-, Mittel- und Fensterreihe rücken zu je einer Gruppe (7 Personen) zusammen. Dann Timer auf 20 Minuten, die Zeit-Person achtet auf die Teilphasen. Tandems: B, C, D werden zu zweit gelesen, A allein. Ab ca. Minute 31 Folie 5 (Werkzeugkasten) einblenden und stehen lassen. Musterlösung liegt am Pult.</a:t>
             </a:r>
             <a:endParaRPr lang="en-US" dirty="0"/>
           </a:p>
@@ -950,7 +950,7 @@
           <a:p>
             <a:r>
               <a:rPr lang="en-US" dirty="0"/>
-              <a:t>Nach 5 Minuten eine Runde gehen: Hat jede Gruppe eine eigene Situation? Notfall-Ideen nur ausgeben, wenn Tippkarte 1 nicht geholfen hat. Um ca. Minute 42 eine Person als Moderation gewinnen (z. B. aus der Gruppe, die zuerst fertig ist) und ihr die Moderationskarte geben. Reihenfolge der Auftritte steht an der Tafel. Zum Proben dürfen Gruppen in Flur oder Ecken.</a:t>
+              <a:t>Nach 5 Minuten eine Runde gehen: Hat jede Gruppe eine eigene Situation? Notfall-Ideen nur ausgeben, wenn Tippkarte 1 nicht geholfen hat. Mit 7 Personen: Besetzung A (2–4), Besetzung B (2–4), Rest Regie – so steht fast jede Person einmal auf der Bühne. Um ca. Minute 53 eine Person als Moderation gewinnen und ihr die Moderationskarte geben. Zum Proben dürfen Gruppen in Flur oder Ecken.</a:t>
             </a:r>
             <a:endParaRPr lang="en-US" dirty="0"/>
           </a:p>
@@ -1038,7 +1038,7 @@
           <a:p>
             <a:r>
               <a:rPr lang="en-US" dirty="0"/>
-              <a:t>Sie sitzen im Publikum und notieren gelungene Formulierungen. Die Moderation leitet mit der Moderationskarte. Pro Gruppe ca. 3,5 Minuten (2 × 90 Sek. + Notizzeit). Zeit knapp? Die restlichen Gruppen spielen zu Beginn der nächsten Stunde, die Auswertung findet trotzdem heute statt.</a:t>
+              <a:t>Sie sitzen im Publikum und notieren gelungene Formulierungen. Die Moderation leitet mit der Moderationskarte. Pro Gruppe ca. 4,5 Minuten (2 × 2 Min. + Notizzeit), insgesamt knapp 15 Minuten.</a:t>
             </a:r>
             <a:endParaRPr lang="en-US" dirty="0"/>
           </a:p>
@@ -2114,7 +2114,7 @@
                 <a:ea typeface="Calibri" pitchFamily="34" charset="-122"/>
                 <a:cs typeface="Calibri" pitchFamily="34" charset="-120"/>
               </a:rPr>
-              <a:t>EINSTIEG · STILL</a:t>
+              <a:t>IMPULS · EINZELARBEIT → PARTNERARBEIT</a:t>
             </a:r>
             <a:endParaRPr lang="en-US" sz="1200" dirty="0"/>
           </a:p>
@@ -2192,7 +2192,7 @@
                 <a:ea typeface="Calibri" pitchFamily="34" charset="-122"/>
                 <a:cs typeface="Calibri" pitchFamily="34" charset="-120"/>
               </a:rPr>
-              <a:t>M1 auf deinem Arbeitsblatt · erst allein, dann mit dem Nachbarn</a:t>
+              <a:t>M1 auf deinem Arbeitsblatt · erst allein, dann mit deinem Sitznachbarn</a:t>
             </a:r>
             <a:endParaRPr lang="en-US" sz="1400" dirty="0"/>
           </a:p>
@@ -4199,7 +4199,7 @@
                 <a:ea typeface="Cambria" pitchFamily="34" charset="-122"/>
                 <a:cs typeface="Cambria" pitchFamily="34" charset="-120"/>
               </a:rPr>
-              <a:t>8 Min.</a:t>
+              <a:t>10 Min.</a:t>
             </a:r>
             <a:endParaRPr lang="en-US" sz="2600" dirty="0"/>
           </a:p>
@@ -4925,7 +4925,7 @@
                 <a:ea typeface="Calibri" pitchFamily="34" charset="-122"/>
                 <a:cs typeface="Calibri" pitchFamily="34" charset="-120"/>
               </a:rPr>
-              <a:t>1. Nachbarn fragen   →   2. Tippkarte vom Pult holen   →   3. erst dann die Lehrkraft</a:t>
+              <a:t>1. Tippkarte 1 vom Pult   →   2. Tippkarte 2   →   3. erst dann die Lehrkraft</a:t>
             </a:r>
             <a:endParaRPr lang="en-US" sz="1700" dirty="0"/>
           </a:p>
@@ -5074,7 +5074,7 @@
                 <a:ea typeface="Calibri" pitchFamily="34" charset="-122"/>
                 <a:cs typeface="Calibri" pitchFamily="34" charset="-120"/>
               </a:rPr>
-              <a:t>Arbeitsblatt S. 3 · Vierergruppen</a:t>
+              <a:t>Arbeitsblatt S. 3 · drei Gruppen à 7: Wandreihe · Mittelreihe · Fensterreihe</a:t>
             </a:r>
             <a:endParaRPr lang="en-US" sz="1400" dirty="0"/>
           </a:p>
@@ -5213,7 +5213,7 @@
                 <a:ea typeface="Cambria" pitchFamily="34" charset="-122"/>
                 <a:cs typeface="Cambria" pitchFamily="34" charset="-120"/>
               </a:rPr>
-              <a:t>17 Min.</a:t>
+              <a:t>20 Min.</a:t>
             </a:r>
             <a:endParaRPr lang="en-US" sz="2600" dirty="0"/>
           </a:p>
@@ -5252,7 +5252,7 @@
                 <a:ea typeface="Calibri" pitchFamily="34" charset="-122"/>
                 <a:cs typeface="Calibri" pitchFamily="34" charset="-120"/>
               </a:rPr>
-              <a:t>Gruppe</a:t>
+              <a:t>+ 3 Min. Umsetzen</a:t>
             </a:r>
             <a:endParaRPr lang="en-US" sz="1200" dirty="0"/>
           </a:p>
@@ -5267,7 +5267,7 @@
         <p:spPr>
           <a:xfrm>
             <a:off x="548640" y="1783080"/>
-            <a:ext cx="9144000" cy="365760"/>
+            <a:ext cx="10972800" cy="365760"/>
           </a:xfrm>
           <a:prstGeom prst="rect">
             <a:avLst/>
@@ -5283,7 +5283,7 @@
               <a:buNone/>
             </a:pPr>
             <a:r>
-              <a:rPr lang="en-US" sz="1800" b="1" dirty="0">
+              <a:rPr lang="en-US" sz="1600" b="1" dirty="0">
                 <a:solidFill>
                   <a:srgbClr val="1E2761"/>
                 </a:solidFill>
@@ -5291,9 +5291,9 @@
                 <a:ea typeface="Cambria" pitchFamily="34" charset="-122"/>
                 <a:cs typeface="Cambria" pitchFamily="34" charset="-120"/>
               </a:rPr>
-              <a:t>Zuerst: Umschlag öffnen, Rollen verteilen</a:t>
-            </a:r>
-            <a:endParaRPr lang="en-US" sz="1800" dirty="0"/>
+              <a:t>Zuerst (3 Min.): als Reihe zusammenrücken, Umschlag öffnen, Rollen verteilen</a:t>
+            </a:r>
+            <a:endParaRPr lang="en-US" sz="1600" dirty="0"/>
           </a:p>
         </p:txBody>
       </p:sp>
@@ -5757,7 +5757,7 @@
                 <a:ea typeface="Cambria" pitchFamily="34" charset="-122"/>
                 <a:cs typeface="Cambria" pitchFamily="34" charset="-120"/>
               </a:rPr>
-              <a:t>4'</a:t>
+              <a:t>5'</a:t>
             </a:r>
             <a:endParaRPr lang="en-US" sz="2400" dirty="0"/>
           </a:p>
@@ -5835,7 +5835,7 @@
                 <a:ea typeface="Calibri" pitchFamily="34" charset="-122"/>
                 <a:cs typeface="Calibri" pitchFamily="34" charset="-120"/>
               </a:rPr>
-              <a:t>Jede Person liest allein eine Expertenkarte A–D.</a:t>
+              <a:t>A liest eine Person allein, B, C und D je ein Tandem.</a:t>
             </a:r>
             <a:endParaRPr lang="en-US" sz="1500" dirty="0"/>
           </a:p>
@@ -5901,7 +5901,7 @@
                 <a:ea typeface="Cambria" pitchFamily="34" charset="-122"/>
                 <a:cs typeface="Cambria" pitchFamily="34" charset="-120"/>
               </a:rPr>
-              <a:t>7'</a:t>
+              <a:t>8'</a:t>
             </a:r>
             <a:endParaRPr lang="en-US" sz="2400" dirty="0"/>
           </a:p>
@@ -5979,7 +5979,7 @@
                 <a:ea typeface="Calibri" pitchFamily="34" charset="-122"/>
                 <a:cs typeface="Calibri" pitchFamily="34" charset="-120"/>
               </a:rPr>
-              <a:t>Reihum: jede Strategie in höchstens 90 Sekunden – mit Beispiel.</a:t>
+              <a:t>Reihum: jede Strategie in höchstens 2 Minuten – mit Beispiel.</a:t>
             </a:r>
             <a:endParaRPr lang="en-US" sz="1500" dirty="0"/>
           </a:p>
@@ -6045,7 +6045,7 @@
                 <a:ea typeface="Cambria" pitchFamily="34" charset="-122"/>
                 <a:cs typeface="Cambria" pitchFamily="34" charset="-120"/>
               </a:rPr>
-              <a:t>6'</a:t>
+              <a:t>7'</a:t>
             </a:r>
             <a:endParaRPr lang="en-US" sz="2400" dirty="0"/>
           </a:p>
@@ -6123,7 +6123,7 @@
                 <a:ea typeface="Calibri" pitchFamily="34" charset="-122"/>
                 <a:cs typeface="Calibri" pitchFamily="34" charset="-120"/>
               </a:rPr>
-              <a:t>Dialog ab Zeile 3 neu schreiben, mindestens 3 Strategien. Checkliste prüfen.</a:t>
+              <a:t>Dialog ab Zeile 3 gemeinsam neu schreiben, alle schreiben mit. Checkliste prüfen.</a:t>
             </a:r>
             <a:endParaRPr lang="en-US" sz="1500" dirty="0"/>
           </a:p>
@@ -7335,7 +7335,7 @@
                 <a:ea typeface="Calibri" pitchFamily="34" charset="-122"/>
                 <a:cs typeface="Calibri" pitchFamily="34" charset="-120"/>
               </a:rPr>
-              <a:t>AUFGABE 4 · GRUPPE</a:t>
+              <a:t>AUFGABE 4 · REIHEN-GRUPPE</a:t>
             </a:r>
             <a:endParaRPr lang="en-US" sz="1200" dirty="0"/>
           </a:p>
@@ -7552,7 +7552,7 @@
                 <a:ea typeface="Cambria" pitchFamily="34" charset="-122"/>
                 <a:cs typeface="Cambria" pitchFamily="34" charset="-120"/>
               </a:rPr>
-              <a:t>17 Min.</a:t>
+              <a:t>20 Min.</a:t>
             </a:r>
             <a:endParaRPr lang="en-US" sz="2600" dirty="0"/>
           </a:p>
@@ -7873,7 +7873,28 @@
                 <a:ea typeface="Calibri" pitchFamily="34" charset="-122"/>
                 <a:cs typeface="Calibri" pitchFamily="34" charset="-120"/>
               </a:rPr>
-              <a:t>2–4 Rollen, jede Version höchstens 90 Sekunden</a:t>
+              <a:t>2–4 Rollen pro Version, jede Version höchstens 2 Minuten</a:t>
+            </a:r>
+            <a:endParaRPr lang="en-US" sz="1600" dirty="0"/>
+          </a:p>
+          <a:p>
+            <a:pPr marL="342900" indent="-342900">
+              <a:spcAft>
+                <a:spcPts val="600"/>
+              </a:spcAft>
+              <a:buSzPct val="100000"/>
+              <a:buChar char="•"/>
+            </a:pPr>
+            <a:r>
+              <a:rPr lang="en-US" sz="1600" dirty="0">
+                <a:solidFill>
+                  <a:srgbClr val="1E2761"/>
+                </a:solidFill>
+                <a:latin typeface="Calibri" pitchFamily="34" charset="0"/>
+                <a:ea typeface="Calibri" pitchFamily="34" charset="-122"/>
+                <a:cs typeface="Calibri" pitchFamily="34" charset="-120"/>
+              </a:rPr>
+              <a:t>A und B spielen verschiedene Personen – wer nicht spielt, führt Regie</a:t>
             </a:r>
             <a:endParaRPr lang="en-US" sz="1600" dirty="0"/>
           </a:p>
@@ -8320,7 +8341,7 @@
                 <a:ea typeface="Cambria" pitchFamily="34" charset="-122"/>
                 <a:cs typeface="Cambria" pitchFamily="34" charset="-120"/>
               </a:rPr>
-              <a:t>25 Min.</a:t>
+              <a:t>15 Min.</a:t>
             </a:r>
             <a:endParaRPr lang="en-US" sz="2600" dirty="0"/>
           </a:p>
@@ -8457,7 +8478,35 @@
                 <a:ea typeface="Calibri" pitchFamily="34" charset="-122"/>
                 <a:cs typeface="Calibri" pitchFamily="34" charset="-120"/>
               </a:rPr>
-              <a:t>Die Moderation ruft die Gruppen in der Reihenfolge an der Tafel auf.</a:t>
+              <a:t>Reihenfolge: </a:t>
+            </a:r>
+            <a:pPr indent="0" marL="0">
+              <a:buNone/>
+            </a:pPr>
+            <a:r>
+              <a:rPr lang="en-US" sz="1700" b="1" dirty="0">
+                <a:solidFill>
+                  <a:srgbClr val="1E2761"/>
+                </a:solidFill>
+                <a:latin typeface="Calibri" pitchFamily="34" charset="0"/>
+                <a:ea typeface="Calibri" pitchFamily="34" charset="-122"/>
+                <a:cs typeface="Calibri" pitchFamily="34" charset="-120"/>
+              </a:rPr>
+              <a:t>Wandreihe → Mittelreihe → Fensterreihe</a:t>
+            </a:r>
+            <a:pPr indent="0" marL="0">
+              <a:buNone/>
+            </a:pPr>
+            <a:r>
+              <a:rPr lang="en-US" sz="1700" dirty="0">
+                <a:solidFill>
+                  <a:srgbClr val="1E2761"/>
+                </a:solidFill>
+                <a:latin typeface="Calibri" pitchFamily="34" charset="0"/>
+                <a:ea typeface="Calibri" pitchFamily="34" charset="-122"/>
+                <a:cs typeface="Calibri" pitchFamily="34" charset="-120"/>
+              </a:rPr>
+              <a:t>.</a:t>
             </a:r>
             <a:endParaRPr lang="en-US" sz="1700" dirty="0"/>
           </a:p>
@@ -8597,7 +8646,7 @@
                 <a:ea typeface="Calibri" pitchFamily="34" charset="-122"/>
                 <a:cs typeface="Calibri" pitchFamily="34" charset="-120"/>
               </a:rPr>
-              <a:t> – je höchstens 90 Sekunden.</a:t>
+              <a:t> mit anderer Besetzung – je höchstens 2 Minuten.</a:t>
             </a:r>
             <a:endParaRPr lang="en-US" sz="1700" dirty="0"/>
           </a:p>
@@ -8935,7 +8984,41 @@
                 <a:ea typeface="Calibri" pitchFamily="34" charset="-122"/>
                 <a:cs typeface="Calibri" pitchFamily="34" charset="-120"/>
               </a:rPr>
-              <a:t>Die Gruppe, die nach euch spielt, beobachtet ihr besonders genau. Die letzte Gruppe beobachtet Gruppe 1.</a:t>
+              <a:t>Wand beobachtet Mitte</a:t>
+            </a:r>
+            <a:endParaRPr lang="en-US" sz="1500" dirty="0"/>
+          </a:p>
+          <a:p>
+            <a:pPr indent="0" marL="0">
+              <a:buNone/>
+            </a:pPr>
+            <a:r>
+              <a:rPr lang="en-US" sz="1500" dirty="0">
+                <a:solidFill>
+                  <a:srgbClr val="FFFFFF"/>
+                </a:solidFill>
+                <a:latin typeface="Calibri" pitchFamily="34" charset="0"/>
+                <a:ea typeface="Calibri" pitchFamily="34" charset="-122"/>
+                <a:cs typeface="Calibri" pitchFamily="34" charset="-120"/>
+              </a:rPr>
+              <a:t>Mitte beobachtet Fenster</a:t>
+            </a:r>
+            <a:endParaRPr lang="en-US" sz="1500" dirty="0"/>
+          </a:p>
+          <a:p>
+            <a:pPr indent="0" marL="0">
+              <a:buNone/>
+            </a:pPr>
+            <a:r>
+              <a:rPr lang="en-US" sz="1500" dirty="0">
+                <a:solidFill>
+                  <a:srgbClr val="FFFFFF"/>
+                </a:solidFill>
+                <a:latin typeface="Calibri" pitchFamily="34" charset="0"/>
+                <a:ea typeface="Calibri" pitchFamily="34" charset="-122"/>
+                <a:cs typeface="Calibri" pitchFamily="34" charset="-120"/>
+              </a:rPr>
+              <a:t>Fenster beobachtet Wand</a:t>
             </a:r>
             <a:endParaRPr lang="en-US" sz="1500" dirty="0"/>
           </a:p>
@@ -9601,7 +9684,7 @@
                 <a:ea typeface="Cambria" pitchFamily="34" charset="-122"/>
                 <a:cs typeface="Cambria" pitchFamily="34" charset="-120"/>
               </a:rPr>
-              <a:t>Tischgruppe</a:t>
+              <a:t>Gruppe</a:t>
             </a:r>
             <a:endParaRPr lang="en-US" sz="2000" dirty="0"/>
           </a:p>
@@ -9779,7 +9862,7 @@
                 <a:ea typeface="Calibri" pitchFamily="34" charset="-122"/>
                 <a:cs typeface="Calibri" pitchFamily="34" charset="-120"/>
               </a:rPr>
-              <a:t>Jede Gruppe: 1 Minute Rückmeldung zu ihrer Patenszene. Die Spielgruppe darf mit einem Satz ergänzen.</a:t>
+              <a:t>Jede Gruppe: ca. 2 Minuten Rückmeldung zu ihrer Patenszene. Die Spielgruppe darf ergänzen.</a:t>
             </a:r>
             <a:endParaRPr lang="en-US" sz="1500" dirty="0"/>
           </a:p>

</xml_diff>

<commit_message>
Deutsch 11: Merkkasten Werkzeugkasten als Sicherung im Unterrichtsgespräch 2
Co-Authored-By: Claude Opus 5.5 <noreply@anthropic.com>
Claude-Session: https://claude.ai/code/session_01Kzh1oWiqhC6W8oSNq8mKnj
</commit_message>
<xml_diff>
--- a/Deutsch_11/Kommunikationsstoerungen_loesen/Praesentation_Kommunikationsstoerungen_loesen.pptx
+++ b/Deutsch_11/Kommunikationsstoerungen_loesen/Praesentation_Kommunikationsstoerungen_loesen.pptx
@@ -1040,7 +1040,7 @@
           <a:p>
             <a:r>
               <a:rPr lang="en-US" dirty="0"/>
-              <a:t>Erst 3 Minuten Umsetzen: Wand-, Mittel- und Fensterreihe rücken zu je einer Gruppe (7 Personen) zusammen. Dann Timer auf 17 Minuten, die Zeit-Person achtet auf die Teilphasen. Tandems: B, C, D werden zu zweit gelesen, A allein. Ab ca. Minute 31 Folie 6 (Werkzeugkasten) einblenden und stehen lassen.</a:t>
+              <a:t>Erst 3 Minuten Umsetzen: Wand-, Mittel- und Fensterreihe rücken zu je einer Gruppe (7 Personen) zusammen. Dann Timer auf 17 Minuten, die Zeit-Person achtet auf die Teilphasen. Tandems: B, C, D werden zu zweit gelesen, A allein. Folie 6 (Werkzeugkasten) noch nicht zeigen – sie ist der Vergleich für den Merkkasten im Unterrichtsgespräch 2.</a:t>
             </a:r>
             <a:endParaRPr lang="en-US" dirty="0"/>
           </a:p>
@@ -1128,7 +1128,7 @@
           <a:p>
             <a:r>
               <a:rPr lang="en-US" dirty="0"/>
-              <a:t>Überblicksfolie, kein Vortrag. Sie steht ab ca. Minute 31 und dient im Unterrichtsgespräch 2 als Stütze: „Welche Strategie erkennt ihr – und an welcher Formulierung?“</a:t>
+              <a:t>Unterrichtsgespräch 2 (7 Min.): Erst lesen die Protokoll-Personen der drei Gruppen ihre Version B vor, die Klasse benennt die Strategien (Impuls: „Welche Strategie erkennt ihr – und an welcher Formulierung?“). Alle füllen dabei den Merkkasten auf Arbeitsblatt S. 4 aus, Strategie für Strategie. Erst danach diese Folie zum Vergleich zeigen, zuletzt Folie 7 (Musterlösung).</a:t>
             </a:r>
             <a:endParaRPr lang="en-US" dirty="0"/>
           </a:p>
@@ -1304,7 +1304,7 @@
           <a:p>
             <a:r>
               <a:rPr lang="en-US" dirty="0"/>
-              <a:t>Nach 5 Minuten eine Runde gehen: Hat jede Gruppe eine eigene Situation? Notfall-Ideen nur ausgeben, wenn Tippkarte 1 nicht geholfen hat. Mit 7 Personen: Besetzung A (2–4), Besetzung B (2–4), Rest Regie – so steht fast jede Person einmal auf der Bühne. Um ca. Minute 55 eine Person als Moderation gewinnen und ihr die Moderationskarte geben. Zum Proben dürfen Gruppen in Flur oder Ecken.</a:t>
+              <a:t>Nach 5 Minuten eine Runde gehen: Hat jede Gruppe eine eigene Situation? Notfall-Ideen nur ausgeben, wenn Tippkarte 1 nicht geholfen hat. Mit 7 Personen: Besetzung A (2–4), Besetzung B (2–4), Rest Regie – so steht fast jede Person einmal auf der Bühne. Um ca. Minute 57 eine Person als Moderation gewinnen und ihr die Moderationskarte geben. Zum Proben dürfen Gruppen in Flur oder Ecken.</a:t>
             </a:r>
             <a:endParaRPr lang="en-US" dirty="0"/>
           </a:p>
@@ -2509,7 +2509,7 @@
                 <a:ea typeface="Cambria" pitchFamily="34" charset="-122"/>
                 <a:cs typeface="Cambria" pitchFamily="34" charset="-120"/>
               </a:rPr>
-              <a:t>13 Min.</a:t>
+              <a:t>11 Min.</a:t>
             </a:r>
             <a:endParaRPr lang="en-US" sz="2600" dirty="0"/>
           </a:p>
@@ -2748,7 +2748,7 @@
                 <a:ea typeface="Cambria" pitchFamily="34" charset="-122"/>
                 <a:cs typeface="Cambria" pitchFamily="34" charset="-120"/>
               </a:rPr>
-              <a:t>4'</a:t>
+              <a:t>3'</a:t>
             </a:r>
             <a:endParaRPr lang="en-US" sz="3200" dirty="0"/>
           </a:p>
@@ -2887,7 +2887,7 @@
                 <a:ea typeface="Cambria" pitchFamily="34" charset="-122"/>
                 <a:cs typeface="Cambria" pitchFamily="34" charset="-120"/>
               </a:rPr>
-              <a:t>7'</a:t>
+              <a:t>6'</a:t>
             </a:r>
             <a:endParaRPr lang="en-US" sz="3200" dirty="0"/>
           </a:p>
@@ -8706,7 +8706,7 @@
                 <a:ea typeface="Calibri" pitchFamily="34" charset="-122"/>
                 <a:cs typeface="Calibri" pitchFamily="34" charset="-120"/>
               </a:rPr>
-              <a:t>ÜBERBLICK</a:t>
+              <a:t>SICHERUNG · VERGLEICH MIT EUREM MERKKASTEN</a:t>
             </a:r>
             <a:endParaRPr lang="en-US" sz="1200" dirty="0"/>
           </a:p>
@@ -8871,6 +8871,106 @@
       <p:sp>
         <p:nvSpPr>
           <p:cNvPr id="7" name="Shape 5"/>
+          <p:cNvSpPr/>
+          <p:nvPr/>
+        </p:nvSpPr>
+        <p:spPr>
+          <a:xfrm>
+            <a:off x="9966960" y="411480"/>
+            <a:ext cx="1691640" cy="914400"/>
+          </a:xfrm>
+          <a:prstGeom prst="roundRect">
+            <a:avLst>
+              <a:gd name="adj" fmla="val 8000"/>
+            </a:avLst>
+          </a:prstGeom>
+          <a:solidFill>
+            <a:srgbClr val="1E2761"/>
+          </a:solidFill>
+          <a:ln/>
+        </p:spPr>
+      </p:sp>
+      <p:sp>
+        <p:nvSpPr>
+          <p:cNvPr id="8" name="Text 6"/>
+          <p:cNvSpPr txBox="1"/>
+          <p:nvPr/>
+        </p:nvSpPr>
+        <p:spPr>
+          <a:xfrm>
+            <a:off x="9966960" y="457200"/>
+            <a:ext cx="1691640" cy="502920"/>
+          </a:xfrm>
+          <a:prstGeom prst="rect">
+            <a:avLst/>
+          </a:prstGeom>
+          <a:noFill/>
+          <a:ln/>
+        </p:spPr>
+        <p:txBody>
+          <a:bodyPr wrap="square" lIns="0" tIns="0" rIns="0" bIns="0" rtlCol="0" anchor="ctr"/>
+          <a:lstStyle/>
+          <a:p>
+            <a:pPr algn="ctr" indent="0" marL="0">
+              <a:buNone/>
+            </a:pPr>
+            <a:r>
+              <a:rPr lang="en-US" sz="2600" b="1" dirty="0">
+                <a:solidFill>
+                  <a:srgbClr val="FFFFFF"/>
+                </a:solidFill>
+                <a:latin typeface="Cambria" pitchFamily="34" charset="0"/>
+                <a:ea typeface="Cambria" pitchFamily="34" charset="-122"/>
+                <a:cs typeface="Cambria" pitchFamily="34" charset="-120"/>
+              </a:rPr>
+              <a:t>7 Min.</a:t>
+            </a:r>
+            <a:endParaRPr lang="en-US" sz="2600" dirty="0"/>
+          </a:p>
+        </p:txBody>
+      </p:sp>
+      <p:sp>
+        <p:nvSpPr>
+          <p:cNvPr id="9" name="Text 7"/>
+          <p:cNvSpPr txBox="1"/>
+          <p:nvPr/>
+        </p:nvSpPr>
+        <p:spPr>
+          <a:xfrm>
+            <a:off x="9966960" y="932688"/>
+            <a:ext cx="1691640" cy="320040"/>
+          </a:xfrm>
+          <a:prstGeom prst="rect">
+            <a:avLst/>
+          </a:prstGeom>
+          <a:noFill/>
+          <a:ln/>
+        </p:spPr>
+        <p:txBody>
+          <a:bodyPr wrap="square" lIns="0" tIns="0" rIns="0" bIns="0" rtlCol="0" anchor="ctr"/>
+          <a:lstStyle/>
+          <a:p>
+            <a:pPr algn="ctr" indent="0" marL="0">
+              <a:buNone/>
+            </a:pPr>
+            <a:r>
+              <a:rPr lang="en-US" sz="1200" dirty="0">
+                <a:solidFill>
+                  <a:srgbClr val="CADCFC"/>
+                </a:solidFill>
+                <a:latin typeface="Calibri" pitchFamily="34" charset="0"/>
+                <a:ea typeface="Calibri" pitchFamily="34" charset="-122"/>
+                <a:cs typeface="Calibri" pitchFamily="34" charset="-120"/>
+              </a:rPr>
+              <a:t>Plenum</a:t>
+            </a:r>
+            <a:endParaRPr lang="en-US" sz="1200" dirty="0"/>
+          </a:p>
+        </p:txBody>
+      </p:sp>
+      <p:sp>
+        <p:nvSpPr>
+          <p:cNvPr id="10" name="Shape 8"/>
           <p:cNvSpPr/>
           <p:nvPr/>
         </p:nvSpPr>
@@ -8892,7 +8992,7 @@
       </p:sp>
       <p:sp>
         <p:nvSpPr>
-          <p:cNvPr id="8" name="Shape 6"/>
+          <p:cNvPr id="11" name="Shape 9"/>
           <p:cNvSpPr/>
           <p:nvPr/>
         </p:nvSpPr>
@@ -8912,7 +9012,7 @@
       </p:sp>
       <p:sp>
         <p:nvSpPr>
-          <p:cNvPr id="9" name="Text 7"/>
+          <p:cNvPr id="12" name="Text 10"/>
           <p:cNvSpPr txBox="1"/>
           <p:nvPr/>
         </p:nvSpPr>
@@ -8951,7 +9051,7 @@
       </p:sp>
       <p:sp>
         <p:nvSpPr>
-          <p:cNvPr id="10" name="Text 8"/>
+          <p:cNvPr id="13" name="Text 11"/>
           <p:cNvSpPr txBox="1"/>
           <p:nvPr/>
         </p:nvSpPr>
@@ -8990,7 +9090,7 @@
       </p:sp>
       <p:sp>
         <p:nvSpPr>
-          <p:cNvPr id="11" name="Text 9"/>
+          <p:cNvPr id="14" name="Text 12"/>
           <p:cNvSpPr txBox="1"/>
           <p:nvPr/>
         </p:nvSpPr>
@@ -9029,7 +9129,7 @@
       </p:sp>
       <p:sp>
         <p:nvSpPr>
-          <p:cNvPr id="12" name="Text 10"/>
+          <p:cNvPr id="15" name="Text 13"/>
           <p:cNvSpPr txBox="1"/>
           <p:nvPr/>
         </p:nvSpPr>
@@ -9068,7 +9168,7 @@
       </p:sp>
       <p:sp>
         <p:nvSpPr>
-          <p:cNvPr id="13" name="Shape 11"/>
+          <p:cNvPr id="16" name="Shape 14"/>
           <p:cNvSpPr/>
           <p:nvPr/>
         </p:nvSpPr>
@@ -9090,7 +9190,7 @@
       </p:sp>
       <p:sp>
         <p:nvSpPr>
-          <p:cNvPr id="14" name="Shape 12"/>
+          <p:cNvPr id="17" name="Shape 15"/>
           <p:cNvSpPr/>
           <p:nvPr/>
         </p:nvSpPr>
@@ -9110,7 +9210,7 @@
       </p:sp>
       <p:sp>
         <p:nvSpPr>
-          <p:cNvPr id="15" name="Text 13"/>
+          <p:cNvPr id="18" name="Text 16"/>
           <p:cNvSpPr txBox="1"/>
           <p:nvPr/>
         </p:nvSpPr>
@@ -9149,7 +9249,7 @@
       </p:sp>
       <p:sp>
         <p:nvSpPr>
-          <p:cNvPr id="16" name="Text 14"/>
+          <p:cNvPr id="19" name="Text 17"/>
           <p:cNvSpPr txBox="1"/>
           <p:nvPr/>
         </p:nvSpPr>
@@ -9188,7 +9288,7 @@
       </p:sp>
       <p:sp>
         <p:nvSpPr>
-          <p:cNvPr id="17" name="Text 15"/>
+          <p:cNvPr id="20" name="Text 18"/>
           <p:cNvSpPr txBox="1"/>
           <p:nvPr/>
         </p:nvSpPr>
@@ -9227,7 +9327,7 @@
       </p:sp>
       <p:sp>
         <p:nvSpPr>
-          <p:cNvPr id="18" name="Text 16"/>
+          <p:cNvPr id="21" name="Text 19"/>
           <p:cNvSpPr txBox="1"/>
           <p:nvPr/>
         </p:nvSpPr>
@@ -9266,7 +9366,7 @@
       </p:sp>
       <p:sp>
         <p:nvSpPr>
-          <p:cNvPr id="19" name="Shape 17"/>
+          <p:cNvPr id="22" name="Shape 20"/>
           <p:cNvSpPr/>
           <p:nvPr/>
         </p:nvSpPr>
@@ -9288,7 +9388,7 @@
       </p:sp>
       <p:sp>
         <p:nvSpPr>
-          <p:cNvPr id="20" name="Shape 18"/>
+          <p:cNvPr id="23" name="Shape 21"/>
           <p:cNvSpPr/>
           <p:nvPr/>
         </p:nvSpPr>
@@ -9308,7 +9408,7 @@
       </p:sp>
       <p:sp>
         <p:nvSpPr>
-          <p:cNvPr id="21" name="Text 19"/>
+          <p:cNvPr id="24" name="Text 22"/>
           <p:cNvSpPr txBox="1"/>
           <p:nvPr/>
         </p:nvSpPr>
@@ -9347,7 +9447,7 @@
       </p:sp>
       <p:sp>
         <p:nvSpPr>
-          <p:cNvPr id="22" name="Text 20"/>
+          <p:cNvPr id="25" name="Text 23"/>
           <p:cNvSpPr txBox="1"/>
           <p:nvPr/>
         </p:nvSpPr>
@@ -9386,7 +9486,7 @@
       </p:sp>
       <p:sp>
         <p:nvSpPr>
-          <p:cNvPr id="23" name="Text 21"/>
+          <p:cNvPr id="26" name="Text 24"/>
           <p:cNvSpPr txBox="1"/>
           <p:nvPr/>
         </p:nvSpPr>
@@ -9425,7 +9525,7 @@
       </p:sp>
       <p:sp>
         <p:nvSpPr>
-          <p:cNvPr id="24" name="Text 22"/>
+          <p:cNvPr id="27" name="Text 25"/>
           <p:cNvSpPr txBox="1"/>
           <p:nvPr/>
         </p:nvSpPr>
@@ -9464,7 +9564,7 @@
       </p:sp>
       <p:sp>
         <p:nvSpPr>
-          <p:cNvPr id="25" name="Shape 23"/>
+          <p:cNvPr id="28" name="Shape 26"/>
           <p:cNvSpPr/>
           <p:nvPr/>
         </p:nvSpPr>
@@ -9486,7 +9586,7 @@
       </p:sp>
       <p:sp>
         <p:nvSpPr>
-          <p:cNvPr id="26" name="Shape 24"/>
+          <p:cNvPr id="29" name="Shape 27"/>
           <p:cNvSpPr/>
           <p:nvPr/>
         </p:nvSpPr>
@@ -9506,7 +9606,7 @@
       </p:sp>
       <p:sp>
         <p:nvSpPr>
-          <p:cNvPr id="27" name="Text 25"/>
+          <p:cNvPr id="30" name="Text 28"/>
           <p:cNvSpPr txBox="1"/>
           <p:nvPr/>
         </p:nvSpPr>
@@ -9545,7 +9645,7 @@
       </p:sp>
       <p:sp>
         <p:nvSpPr>
-          <p:cNvPr id="28" name="Text 26"/>
+          <p:cNvPr id="31" name="Text 29"/>
           <p:cNvSpPr txBox="1"/>
           <p:nvPr/>
         </p:nvSpPr>
@@ -9584,7 +9684,7 @@
       </p:sp>
       <p:sp>
         <p:nvSpPr>
-          <p:cNvPr id="29" name="Text 27"/>
+          <p:cNvPr id="32" name="Text 30"/>
           <p:cNvSpPr txBox="1"/>
           <p:nvPr/>
         </p:nvSpPr>
@@ -9623,7 +9723,7 @@
       </p:sp>
       <p:sp>
         <p:nvSpPr>
-          <p:cNvPr id="30" name="Text 28"/>
+          <p:cNvPr id="33" name="Text 31"/>
           <p:cNvSpPr txBox="1"/>
           <p:nvPr/>
         </p:nvSpPr>
@@ -9662,7 +9762,7 @@
       </p:sp>
       <p:sp>
         <p:nvSpPr>
-          <p:cNvPr id="31" name="Shape 29"/>
+          <p:cNvPr id="34" name="Shape 32"/>
           <p:cNvSpPr/>
           <p:nvPr/>
         </p:nvSpPr>
@@ -9684,7 +9784,7 @@
       </p:sp>
       <p:sp>
         <p:nvSpPr>
-          <p:cNvPr id="32" name="Text 30"/>
+          <p:cNvPr id="35" name="Text 33"/>
           <p:cNvSpPr txBox="1"/>
           <p:nvPr/>
         </p:nvSpPr>
@@ -10003,7 +10103,7 @@
                 <a:ea typeface="Cambria" pitchFamily="34" charset="-122"/>
                 <a:cs typeface="Cambria" pitchFamily="34" charset="-120"/>
               </a:rPr>
-              <a:t>5 Min.</a:t>
+              <a:t>7 Min.</a:t>
             </a:r>
             <a:endParaRPr lang="en-US" sz="2600" dirty="0"/>
           </a:p>
@@ -10996,7 +11096,7 @@
                 <a:ea typeface="Calibri" pitchFamily="34" charset="-122"/>
                 <a:cs typeface="Calibri" pitchFamily="34" charset="-120"/>
               </a:rPr>
-              <a:t>Arbeitsblatt S. 4 · Denkt euch selbst eine Situation aus!</a:t>
+              <a:t>Arbeitsblatt S. 5 · Denkt euch selbst eine Situation aus! Euer Merkkasten (S. 4) hilft.</a:t>
             </a:r>
             <a:endParaRPr lang="en-US" sz="1400" dirty="0"/>
           </a:p>
@@ -11785,7 +11885,7 @@
                 <a:ea typeface="Calibri" pitchFamily="34" charset="-122"/>
                 <a:cs typeface="Calibri" pitchFamily="34" charset="-120"/>
               </a:rPr>
-              <a:t>Arbeitsblatt S. 5 · Beobachtungsbogen</a:t>
+              <a:t>Arbeitsblatt S. 6 · Beobachtungsbogen</a:t>
             </a:r>
             <a:endParaRPr lang="en-US" sz="1400" dirty="0"/>
           </a:p>

</xml_diff>

<commit_message>
Deutsch 11: Technik-Training in Einzelarbeit statt Gruppenpuzzle, Exit-Ticket als Mini-Test
Co-Authored-By: Claude Opus 5.5 <noreply@anthropic.com>
Claude-Session: https://claude.ai/code/session_01Kzh1oWiqhC6W8oSNq8mKnj
</commit_message>
<xml_diff>
--- a/Deutsch_11/Kommunikationsstoerungen_loesen/Praesentation_Kommunikationsstoerungen_loesen.pptx
+++ b/Deutsch_11/Kommunikationsstoerungen_loesen/Praesentation_Kommunikationsstoerungen_loesen.pptx
@@ -512,7 +512,7 @@
           <a:p>
             <a:r>
               <a:rPr lang="en-US" dirty="0"/>
-              <a:t>Diese Folie läuft beim Ankommen. Die Klasse sitzt normal in den drei Reihen. Alles liegt bereits: Arbeitsblatt auf jedem Platz, je ein geschlossener Umschlag auf dem ersten Tisch jeder Reihe (Rollenkarten, 2 Sätze Expertenkarten, 7 Exit-Tickets). Aufs Pult: Tippkarten und Lösungsblätter. Bei Ihnen: Notfall-Ideen und Moderationskarten. Einziger Satz: „Heute steht alles auf den Folien – schaut einfach dorthin.“ Dann Folie 2 und Timer 5 Min.</a:t>
+              <a:t>Diese Folie läuft beim Ankommen. Die Klasse sitzt normal in den drei Reihen. Alles liegt bereits: Arbeitsblatt auf jedem Platz, je ein geschlossener Umschlag auf dem ersten Tisch jeder Reihe (4 Rollenkarten, 7 Exit-Tickets) – geöffnet wird er erst in Minute 43. Aufs Pult: Tippkarten. Bei Ihnen: Notfall-Ideen und Moderationskarten. Einziger Satz: „Heute steht alles auf den Folien – schaut einfach dorthin.“ Dann Folie 2 und Timer 5 Min.</a:t>
             </a:r>
             <a:endParaRPr lang="en-US" dirty="0"/>
           </a:p>
@@ -688,7 +688,7 @@
           <a:p>
             <a:r>
               <a:rPr lang="en-US" dirty="0"/>
-              <a:t>Exit-Tickets an der Tür einsammeln. Erwartungshorizont: Lehrermaterial S. 4. Zwei oder drei gelungene Formulierungen können die nächste Stunde eröffnen.</a:t>
+              <a:t>Einzelarbeit, 6 Minuten, ohne Hilfe – das Format entspricht der späteren Testaufgabe. An der Tür einsammeln. Erwartungshorizont und Bewertungskriterien: Lehrermaterial S. 4. Die Auswertung zeigt, welche Technik in der nächsten Stunde noch einmal geübt werden muss.</a:t>
             </a:r>
             <a:endParaRPr lang="en-US" dirty="0"/>
           </a:p>
@@ -952,7 +952,7 @@
           <a:p>
             <a:r>
               <a:rPr lang="en-US" dirty="0"/>
-              <a:t>Erst nach dem Unterrichtsgespräch zeigen. ★ Zeile 3 ist der Kipppunkt, an dem man am leichtesten hätte eingreifen können: Lena will eigentlich nur Sicherheit für morgen. Ausführlicher Erwartungshorizont: Lehrermaterial S. 3.</a:t>
+              <a:t>Erst nach dem Unterrichtsgespräch zeigen. ★ Zeile 3 ist der Kipppunkt, an dem man am leichtesten hätte eingreifen können. Überleitung: Genau diese Zeilen 3, 4, 5 und 7 schreibt gleich jede und jeder allein um – mit je einer Technik.</a:t>
             </a:r>
             <a:endParaRPr lang="en-US" dirty="0"/>
           </a:p>
@@ -1040,7 +1040,7 @@
           <a:p>
             <a:r>
               <a:rPr lang="en-US" dirty="0"/>
-              <a:t>Erst 3 Minuten Umsetzen: Wand-, Mittel- und Fensterreihe rücken zu je einer Gruppe (7 Personen) zusammen. Dann Timer auf 17 Minuten, die Zeit-Person achtet auf die Teilphasen. Tandems: B, C, D werden zu zweit gelesen, A allein. Folie 6 (Werkzeugkasten) noch nicht zeigen – sie ist der Vergleich für den Merkkasten im Unterrichtsgespräch 2.</a:t>
+              <a:t>Timer 4 Minuten, bei jedem Gong neu starten (22', 26', 30', 34'), dann 2 Minuten Partnervergleich. Herumgehen und mitlesen: Wer schreibt noch Du-Botschaften oder ‚immer‘? Pro Technik ein bis zwei gelungene Lösungen für das Unterrichtsgespräch vormerken. Schnelle Schülerinnen und Schüler: eine zweite Technik am selben Kipppunkt ausprobieren.</a:t>
             </a:r>
             <a:endParaRPr lang="en-US" dirty="0"/>
           </a:p>
@@ -1128,7 +1128,7 @@
           <a:p>
             <a:r>
               <a:rPr lang="en-US" dirty="0"/>
-              <a:t>Unterrichtsgespräch 2 (7 Min.): Erst lesen die Protokoll-Personen der drei Gruppen ihre Version B vor, die Klasse benennt die Strategien (Impuls: „Welche Strategie erkennt ihr – und an welcher Formulierung?“). Alle füllen dabei den Merkkasten auf Arbeitsblatt S. 4 aus, Strategie für Strategie. Erst danach diese Folie zum Vergleich zeigen, zuletzt Folie 7 (Musterlösung).</a:t>
+              <a:t>Unterrichtsgespräch 2 (7 Min.): Technik für Technik lesen ein bis zwei Personen ihre Lösung vor (gezielt die vorgemerkten drannehmen). Impuls: „Was ist daran gelungen – was sagt die Checkliste?“ Erst danach diese Folie zum Vergleich zeigen. Folie 7 (ganzer Dialog) nur, wenn Zeit bleibt.</a:t>
             </a:r>
             <a:endParaRPr lang="en-US" dirty="0"/>
           </a:p>
@@ -1216,7 +1216,7 @@
           <a:p>
             <a:r>
               <a:rPr lang="en-US" dirty="0"/>
-              <a:t>Erst zeigen, nachdem alle drei Gruppen ihre Version vorgelesen haben – als eine mögliche Lösung, nicht als die richtige. Vollständige Musterlösung: Lehrermaterial S. 4.</a:t>
+              <a:t>Optional, wenn Zeit bleibt: Hier sieht man, wie die Techniken im ganzen Gespräch zusammenspielen. Als eine mögliche Lösung zeigen, nicht als die richtige.</a:t>
             </a:r>
             <a:endParaRPr lang="en-US" dirty="0"/>
           </a:p>
@@ -1304,7 +1304,7 @@
           <a:p>
             <a:r>
               <a:rPr lang="en-US" dirty="0"/>
-              <a:t>Nach 5 Minuten eine Runde gehen: Hat jede Gruppe eine eigene Situation? Notfall-Ideen nur ausgeben, wenn Tippkarte 1 nicht geholfen hat. Mit 7 Personen: Besetzung A (2–4), Besetzung B (2–4), Rest Regie – so steht fast jede Person einmal auf der Bühne. Um ca. Minute 57 eine Person als Moderation gewinnen und ihr die Moderationskarte geben. Zum Proben dürfen Gruppen in Flur oder Ecken.</a:t>
+              <a:t>Erst 3 Minuten Umsetzen: Wand-, Mittel- und Fensterreihe rücken zu je einer Gruppe zusammen, öffnen den Umschlag und verteilen die Rollen. Dann Timer 16 Minuten. Nach 5 Minuten eine Runde: Hat jede Gruppe eine eigene Situation? Notfall-Ideen nur ausgeben, wenn Tippkarte 1 nicht geholfen hat. Besetzung A (2–4), Besetzung B (2–4), Rest Regie. Um ca. Minute 57 eine Person als Moderation gewinnen und ihr die Moderationskarte geben.</a:t>
             </a:r>
             <a:endParaRPr lang="en-US" dirty="0"/>
           </a:p>
@@ -2509,7 +2509,7 @@
                 <a:ea typeface="Cambria" pitchFamily="34" charset="-122"/>
                 <a:cs typeface="Cambria" pitchFamily="34" charset="-120"/>
               </a:rPr>
-              <a:t>11 Min.</a:t>
+              <a:t>9 Min.</a:t>
             </a:r>
             <a:endParaRPr lang="en-US" sz="2600" dirty="0"/>
           </a:p>
@@ -2748,7 +2748,7 @@
                 <a:ea typeface="Cambria" pitchFamily="34" charset="-122"/>
                 <a:cs typeface="Cambria" pitchFamily="34" charset="-120"/>
               </a:rPr>
-              <a:t>3'</a:t>
+              <a:t>2'</a:t>
             </a:r>
             <a:endParaRPr lang="en-US" sz="3200" dirty="0"/>
           </a:p>
@@ -2887,7 +2887,7 @@
                 <a:ea typeface="Cambria" pitchFamily="34" charset="-122"/>
                 <a:cs typeface="Cambria" pitchFamily="34" charset="-120"/>
               </a:rPr>
-              <a:t>6'</a:t>
+              <a:t>5'</a:t>
             </a:r>
             <a:endParaRPr lang="en-US" sz="3200" dirty="0"/>
           </a:p>
@@ -2965,7 +2965,7 @@
                 <a:ea typeface="Calibri" pitchFamily="34" charset="-122"/>
                 <a:cs typeface="Calibri" pitchFamily="34" charset="-120"/>
               </a:rPr>
-              <a:t>Jede Gruppe: ca. 2 Minuten Rückmeldung zu ihrer Patenszene. Die Spielgruppe darf ergänzen.</a:t>
+              <a:t>Jede Gruppe: ca. 1,5 Minuten Rückmeldung zu ihrer Patenszene. Die Spielgruppe darf ergänzen.</a:t>
             </a:r>
             <a:endParaRPr lang="en-US" sz="1500" dirty="0"/>
           </a:p>
@@ -3112,8 +3112,8 @@
         </p:nvSpPr>
         <p:spPr>
           <a:xfrm>
-            <a:off x="822960" y="1097280"/>
-            <a:ext cx="2926080" cy="384048"/>
+            <a:off x="822960" y="731520"/>
+            <a:ext cx="4572000" cy="384048"/>
           </a:xfrm>
           <a:prstGeom prst="roundRect">
             <a:avLst>
@@ -3134,8 +3134,8 @@
         </p:nvSpPr>
         <p:spPr>
           <a:xfrm>
-            <a:off x="822960" y="1097280"/>
-            <a:ext cx="2926080" cy="384048"/>
+            <a:off x="822960" y="731520"/>
+            <a:ext cx="4572000" cy="384048"/>
           </a:xfrm>
           <a:prstGeom prst="rect">
             <a:avLst/>
@@ -3159,7 +3159,7 @@
                 <a:ea typeface="Calibri" pitchFamily="34" charset="-122"/>
                 <a:cs typeface="Calibri" pitchFamily="34" charset="-120"/>
               </a:rPr>
-              <a:t>EXIT-TICKET · 4 MIN.</a:t>
+              <a:t>EXIT-TICKET · MINI-TEST · 6 MIN. · ALLEIN</a:t>
             </a:r>
             <a:endParaRPr lang="en-US" sz="1200" dirty="0"/>
           </a:p>
@@ -3173,8 +3173,8 @@
         </p:nvSpPr>
         <p:spPr>
           <a:xfrm>
-            <a:off x="822960" y="1645920"/>
-            <a:ext cx="9144000" cy="731520"/>
+            <a:off x="822960" y="1280160"/>
+            <a:ext cx="10058400" cy="731520"/>
           </a:xfrm>
           <a:prstGeom prst="rect">
             <a:avLst/>
@@ -3190,7 +3190,7 @@
               <a:buNone/>
             </a:pPr>
             <a:r>
-              <a:rPr lang="en-US" sz="3600" b="1" dirty="0">
+              <a:rPr lang="en-US" sz="3200" b="1" dirty="0">
                 <a:solidFill>
                   <a:srgbClr val="FFFFFF"/>
                 </a:solidFill>
@@ -3198,22 +3198,607 @@
                 <a:ea typeface="Cambria" pitchFamily="34" charset="-122"/>
                 <a:cs typeface="Cambria" pitchFamily="34" charset="-120"/>
               </a:rPr>
-              <a:t>Bevor du gehst …</a:t>
-            </a:r>
-            <a:endParaRPr lang="en-US" sz="3600" dirty="0"/>
-          </a:p>
-        </p:txBody>
-      </p:sp>
-      <p:sp>
-        <p:nvSpPr>
-          <p:cNvPr id="7" name="Shape 5"/>
+              <a:t>Jetzt allein: Kipppunkt finden und retten</a:t>
+            </a:r>
+            <a:endParaRPr lang="en-US" sz="3200" dirty="0"/>
+          </a:p>
+        </p:txBody>
+      </p:sp>
+      <p:sp>
+        <p:nvSpPr>
+          <p:cNvPr id="7" name="Text 5"/>
+          <p:cNvSpPr txBox="1"/>
+          <p:nvPr/>
+        </p:nvSpPr>
+        <p:spPr>
+          <a:xfrm>
+            <a:off x="822960" y="2240280"/>
+            <a:ext cx="365760" cy="411480"/>
+          </a:xfrm>
+          <a:prstGeom prst="rect">
+            <a:avLst/>
+          </a:prstGeom>
+          <a:noFill/>
+          <a:ln/>
+        </p:spPr>
+        <p:txBody>
+          <a:bodyPr wrap="square" lIns="0" tIns="0" rIns="0" bIns="0" rtlCol="0" anchor="ctr"/>
+          <a:lstStyle/>
+          <a:p>
+            <a:pPr indent="0" marL="0">
+              <a:buNone/>
+            </a:pPr>
+            <a:r>
+              <a:rPr lang="en-US" sz="1400" b="1" dirty="0">
+                <a:solidFill>
+                  <a:srgbClr val="CADCFC"/>
+                </a:solidFill>
+                <a:latin typeface="Calibri" pitchFamily="34" charset="0"/>
+                <a:ea typeface="Calibri" pitchFamily="34" charset="-122"/>
+                <a:cs typeface="Calibri" pitchFamily="34" charset="-120"/>
+              </a:rPr>
+              <a:t>1</a:t>
+            </a:r>
+            <a:endParaRPr lang="en-US" sz="1400" dirty="0"/>
+          </a:p>
+        </p:txBody>
+      </p:sp>
+      <p:sp>
+        <p:nvSpPr>
+          <p:cNvPr id="8" name="Text 6"/>
+          <p:cNvSpPr txBox="1"/>
+          <p:nvPr/>
+        </p:nvSpPr>
+        <p:spPr>
+          <a:xfrm>
+            <a:off x="1234440" y="2240280"/>
+            <a:ext cx="914400" cy="411480"/>
+          </a:xfrm>
+          <a:prstGeom prst="rect">
+            <a:avLst/>
+          </a:prstGeom>
+          <a:noFill/>
+          <a:ln/>
+        </p:spPr>
+        <p:txBody>
+          <a:bodyPr wrap="square" lIns="0" tIns="0" rIns="0" bIns="0" rtlCol="0" anchor="ctr"/>
+          <a:lstStyle/>
+          <a:p>
+            <a:pPr indent="0" marL="0">
+              <a:buNone/>
+            </a:pPr>
+            <a:r>
+              <a:rPr lang="en-US" sz="1500" b="1" dirty="0">
+                <a:solidFill>
+                  <a:srgbClr val="FFFFFF"/>
+                </a:solidFill>
+                <a:latin typeface="Calibri" pitchFamily="34" charset="0"/>
+                <a:ea typeface="Calibri" pitchFamily="34" charset="-122"/>
+                <a:cs typeface="Calibri" pitchFamily="34" charset="-120"/>
+              </a:rPr>
+              <a:t>Mia</a:t>
+            </a:r>
+            <a:endParaRPr lang="en-US" sz="1500" dirty="0"/>
+          </a:p>
+        </p:txBody>
+      </p:sp>
+      <p:sp>
+        <p:nvSpPr>
+          <p:cNvPr id="9" name="Text 7"/>
+          <p:cNvSpPr txBox="1"/>
+          <p:nvPr/>
+        </p:nvSpPr>
+        <p:spPr>
+          <a:xfrm>
+            <a:off x="2194560" y="2240280"/>
+            <a:ext cx="8686800" cy="411480"/>
+          </a:xfrm>
+          <a:prstGeom prst="rect">
+            <a:avLst/>
+          </a:prstGeom>
+          <a:noFill/>
+          <a:ln/>
+        </p:spPr>
+        <p:txBody>
+          <a:bodyPr wrap="square" lIns="0" tIns="0" rIns="0" bIns="0" rtlCol="0" anchor="ctr"/>
+          <a:lstStyle/>
+          <a:p>
+            <a:pPr indent="0" marL="0">
+              <a:buNone/>
+            </a:pPr>
+            <a:r>
+              <a:rPr lang="en-US" sz="1600" dirty="0">
+                <a:solidFill>
+                  <a:srgbClr val="FFFFFF"/>
+                </a:solidFill>
+                <a:latin typeface="Cambria" pitchFamily="34" charset="0"/>
+                <a:ea typeface="Cambria" pitchFamily="34" charset="-122"/>
+                <a:cs typeface="Cambria" pitchFamily="34" charset="-120"/>
+              </a:rPr>
+              <a:t>Papa, kann ich am Samstag auf Leons Party?</a:t>
+            </a:r>
+            <a:endParaRPr lang="en-US" sz="1600" dirty="0"/>
+          </a:p>
+        </p:txBody>
+      </p:sp>
+      <p:sp>
+        <p:nvSpPr>
+          <p:cNvPr id="10" name="Text 8"/>
+          <p:cNvSpPr txBox="1"/>
+          <p:nvPr/>
+        </p:nvSpPr>
+        <p:spPr>
+          <a:xfrm>
+            <a:off x="822960" y="2697480"/>
+            <a:ext cx="365760" cy="411480"/>
+          </a:xfrm>
+          <a:prstGeom prst="rect">
+            <a:avLst/>
+          </a:prstGeom>
+          <a:noFill/>
+          <a:ln/>
+        </p:spPr>
+        <p:txBody>
+          <a:bodyPr wrap="square" lIns="0" tIns="0" rIns="0" bIns="0" rtlCol="0" anchor="ctr"/>
+          <a:lstStyle/>
+          <a:p>
+            <a:pPr indent="0" marL="0">
+              <a:buNone/>
+            </a:pPr>
+            <a:r>
+              <a:rPr lang="en-US" sz="1400" b="1" dirty="0">
+                <a:solidFill>
+                  <a:srgbClr val="CADCFC"/>
+                </a:solidFill>
+                <a:latin typeface="Calibri" pitchFamily="34" charset="0"/>
+                <a:ea typeface="Calibri" pitchFamily="34" charset="-122"/>
+                <a:cs typeface="Calibri" pitchFamily="34" charset="-120"/>
+              </a:rPr>
+              <a:t>2</a:t>
+            </a:r>
+            <a:endParaRPr lang="en-US" sz="1400" dirty="0"/>
+          </a:p>
+        </p:txBody>
+      </p:sp>
+      <p:sp>
+        <p:nvSpPr>
+          <p:cNvPr id="11" name="Text 9"/>
+          <p:cNvSpPr txBox="1"/>
+          <p:nvPr/>
+        </p:nvSpPr>
+        <p:spPr>
+          <a:xfrm>
+            <a:off x="1234440" y="2697480"/>
+            <a:ext cx="914400" cy="411480"/>
+          </a:xfrm>
+          <a:prstGeom prst="rect">
+            <a:avLst/>
+          </a:prstGeom>
+          <a:noFill/>
+          <a:ln/>
+        </p:spPr>
+        <p:txBody>
+          <a:bodyPr wrap="square" lIns="0" tIns="0" rIns="0" bIns="0" rtlCol="0" anchor="ctr"/>
+          <a:lstStyle/>
+          <a:p>
+            <a:pPr indent="0" marL="0">
+              <a:buNone/>
+            </a:pPr>
+            <a:r>
+              <a:rPr lang="en-US" sz="1500" b="1" dirty="0">
+                <a:solidFill>
+                  <a:srgbClr val="FFFFFF"/>
+                </a:solidFill>
+                <a:latin typeface="Calibri" pitchFamily="34" charset="0"/>
+                <a:ea typeface="Calibri" pitchFamily="34" charset="-122"/>
+                <a:cs typeface="Calibri" pitchFamily="34" charset="-120"/>
+              </a:rPr>
+              <a:t>Vater</a:t>
+            </a:r>
+            <a:endParaRPr lang="en-US" sz="1500" dirty="0"/>
+          </a:p>
+        </p:txBody>
+      </p:sp>
+      <p:sp>
+        <p:nvSpPr>
+          <p:cNvPr id="12" name="Text 10"/>
+          <p:cNvSpPr txBox="1"/>
+          <p:nvPr/>
+        </p:nvSpPr>
+        <p:spPr>
+          <a:xfrm>
+            <a:off x="2194560" y="2697480"/>
+            <a:ext cx="8686800" cy="411480"/>
+          </a:xfrm>
+          <a:prstGeom prst="rect">
+            <a:avLst/>
+          </a:prstGeom>
+          <a:noFill/>
+          <a:ln/>
+        </p:spPr>
+        <p:txBody>
+          <a:bodyPr wrap="square" lIns="0" tIns="0" rIns="0" bIns="0" rtlCol="0" anchor="ctr"/>
+          <a:lstStyle/>
+          <a:p>
+            <a:pPr indent="0" marL="0">
+              <a:buNone/>
+            </a:pPr>
+            <a:r>
+              <a:rPr lang="en-US" sz="1600" dirty="0">
+                <a:solidFill>
+                  <a:srgbClr val="FFFFFF"/>
+                </a:solidFill>
+                <a:latin typeface="Cambria" pitchFamily="34" charset="0"/>
+                <a:ea typeface="Cambria" pitchFamily="34" charset="-122"/>
+                <a:cs typeface="Cambria" pitchFamily="34" charset="-120"/>
+              </a:rPr>
+              <a:t>Wie lange geht die denn?</a:t>
+            </a:r>
+            <a:endParaRPr lang="en-US" sz="1600" dirty="0"/>
+          </a:p>
+        </p:txBody>
+      </p:sp>
+      <p:sp>
+        <p:nvSpPr>
+          <p:cNvPr id="13" name="Text 11"/>
+          <p:cNvSpPr txBox="1"/>
+          <p:nvPr/>
+        </p:nvSpPr>
+        <p:spPr>
+          <a:xfrm>
+            <a:off x="822960" y="3154680"/>
+            <a:ext cx="365760" cy="411480"/>
+          </a:xfrm>
+          <a:prstGeom prst="rect">
+            <a:avLst/>
+          </a:prstGeom>
+          <a:noFill/>
+          <a:ln/>
+        </p:spPr>
+        <p:txBody>
+          <a:bodyPr wrap="square" lIns="0" tIns="0" rIns="0" bIns="0" rtlCol="0" anchor="ctr"/>
+          <a:lstStyle/>
+          <a:p>
+            <a:pPr indent="0" marL="0">
+              <a:buNone/>
+            </a:pPr>
+            <a:r>
+              <a:rPr lang="en-US" sz="1400" b="1" dirty="0">
+                <a:solidFill>
+                  <a:srgbClr val="CADCFC"/>
+                </a:solidFill>
+                <a:latin typeface="Calibri" pitchFamily="34" charset="0"/>
+                <a:ea typeface="Calibri" pitchFamily="34" charset="-122"/>
+                <a:cs typeface="Calibri" pitchFamily="34" charset="-120"/>
+              </a:rPr>
+              <a:t>3</a:t>
+            </a:r>
+            <a:endParaRPr lang="en-US" sz="1400" dirty="0"/>
+          </a:p>
+        </p:txBody>
+      </p:sp>
+      <p:sp>
+        <p:nvSpPr>
+          <p:cNvPr id="14" name="Text 12"/>
+          <p:cNvSpPr txBox="1"/>
+          <p:nvPr/>
+        </p:nvSpPr>
+        <p:spPr>
+          <a:xfrm>
+            <a:off x="1234440" y="3154680"/>
+            <a:ext cx="914400" cy="411480"/>
+          </a:xfrm>
+          <a:prstGeom prst="rect">
+            <a:avLst/>
+          </a:prstGeom>
+          <a:noFill/>
+          <a:ln/>
+        </p:spPr>
+        <p:txBody>
+          <a:bodyPr wrap="square" lIns="0" tIns="0" rIns="0" bIns="0" rtlCol="0" anchor="ctr"/>
+          <a:lstStyle/>
+          <a:p>
+            <a:pPr indent="0" marL="0">
+              <a:buNone/>
+            </a:pPr>
+            <a:r>
+              <a:rPr lang="en-US" sz="1500" b="1" dirty="0">
+                <a:solidFill>
+                  <a:srgbClr val="FFFFFF"/>
+                </a:solidFill>
+                <a:latin typeface="Calibri" pitchFamily="34" charset="0"/>
+                <a:ea typeface="Calibri" pitchFamily="34" charset="-122"/>
+                <a:cs typeface="Calibri" pitchFamily="34" charset="-120"/>
+              </a:rPr>
+              <a:t>Mia</a:t>
+            </a:r>
+            <a:endParaRPr lang="en-US" sz="1500" dirty="0"/>
+          </a:p>
+        </p:txBody>
+      </p:sp>
+      <p:sp>
+        <p:nvSpPr>
+          <p:cNvPr id="15" name="Text 13"/>
+          <p:cNvSpPr txBox="1"/>
+          <p:nvPr/>
+        </p:nvSpPr>
+        <p:spPr>
+          <a:xfrm>
+            <a:off x="2194560" y="3154680"/>
+            <a:ext cx="8686800" cy="411480"/>
+          </a:xfrm>
+          <a:prstGeom prst="rect">
+            <a:avLst/>
+          </a:prstGeom>
+          <a:noFill/>
+          <a:ln/>
+        </p:spPr>
+        <p:txBody>
+          <a:bodyPr wrap="square" lIns="0" tIns="0" rIns="0" bIns="0" rtlCol="0" anchor="ctr"/>
+          <a:lstStyle/>
+          <a:p>
+            <a:pPr indent="0" marL="0">
+              <a:buNone/>
+            </a:pPr>
+            <a:r>
+              <a:rPr lang="en-US" sz="1600" dirty="0">
+                <a:solidFill>
+                  <a:srgbClr val="FFFFFF"/>
+                </a:solidFill>
+                <a:latin typeface="Cambria" pitchFamily="34" charset="0"/>
+                <a:ea typeface="Cambria" pitchFamily="34" charset="-122"/>
+                <a:cs typeface="Cambria" pitchFamily="34" charset="-120"/>
+              </a:rPr>
+              <a:t>Keine Ahnung, bis eins vielleicht.</a:t>
+            </a:r>
+            <a:endParaRPr lang="en-US" sz="1600" dirty="0"/>
+          </a:p>
+        </p:txBody>
+      </p:sp>
+      <p:sp>
+        <p:nvSpPr>
+          <p:cNvPr id="16" name="Text 14"/>
+          <p:cNvSpPr txBox="1"/>
+          <p:nvPr/>
+        </p:nvSpPr>
+        <p:spPr>
+          <a:xfrm>
+            <a:off x="822960" y="3611880"/>
+            <a:ext cx="365760" cy="411480"/>
+          </a:xfrm>
+          <a:prstGeom prst="rect">
+            <a:avLst/>
+          </a:prstGeom>
+          <a:noFill/>
+          <a:ln/>
+        </p:spPr>
+        <p:txBody>
+          <a:bodyPr wrap="square" lIns="0" tIns="0" rIns="0" bIns="0" rtlCol="0" anchor="ctr"/>
+          <a:lstStyle/>
+          <a:p>
+            <a:pPr indent="0" marL="0">
+              <a:buNone/>
+            </a:pPr>
+            <a:r>
+              <a:rPr lang="en-US" sz="1400" b="1" dirty="0">
+                <a:solidFill>
+                  <a:srgbClr val="CADCFC"/>
+                </a:solidFill>
+                <a:latin typeface="Calibri" pitchFamily="34" charset="0"/>
+                <a:ea typeface="Calibri" pitchFamily="34" charset="-122"/>
+                <a:cs typeface="Calibri" pitchFamily="34" charset="-120"/>
+              </a:rPr>
+              <a:t>4</a:t>
+            </a:r>
+            <a:endParaRPr lang="en-US" sz="1400" dirty="0"/>
+          </a:p>
+        </p:txBody>
+      </p:sp>
+      <p:sp>
+        <p:nvSpPr>
+          <p:cNvPr id="17" name="Text 15"/>
+          <p:cNvSpPr txBox="1"/>
+          <p:nvPr/>
+        </p:nvSpPr>
+        <p:spPr>
+          <a:xfrm>
+            <a:off x="1234440" y="3611880"/>
+            <a:ext cx="914400" cy="411480"/>
+          </a:xfrm>
+          <a:prstGeom prst="rect">
+            <a:avLst/>
+          </a:prstGeom>
+          <a:noFill/>
+          <a:ln/>
+        </p:spPr>
+        <p:txBody>
+          <a:bodyPr wrap="square" lIns="0" tIns="0" rIns="0" bIns="0" rtlCol="0" anchor="ctr"/>
+          <a:lstStyle/>
+          <a:p>
+            <a:pPr indent="0" marL="0">
+              <a:buNone/>
+            </a:pPr>
+            <a:r>
+              <a:rPr lang="en-US" sz="1500" b="1" dirty="0">
+                <a:solidFill>
+                  <a:srgbClr val="FFFFFF"/>
+                </a:solidFill>
+                <a:latin typeface="Calibri" pitchFamily="34" charset="0"/>
+                <a:ea typeface="Calibri" pitchFamily="34" charset="-122"/>
+                <a:cs typeface="Calibri" pitchFamily="34" charset="-120"/>
+              </a:rPr>
+              <a:t>Vater</a:t>
+            </a:r>
+            <a:endParaRPr lang="en-US" sz="1500" dirty="0"/>
+          </a:p>
+        </p:txBody>
+      </p:sp>
+      <p:sp>
+        <p:nvSpPr>
+          <p:cNvPr id="18" name="Text 16"/>
+          <p:cNvSpPr txBox="1"/>
+          <p:nvPr/>
+        </p:nvSpPr>
+        <p:spPr>
+          <a:xfrm>
+            <a:off x="2194560" y="3611880"/>
+            <a:ext cx="8686800" cy="411480"/>
+          </a:xfrm>
+          <a:prstGeom prst="rect">
+            <a:avLst/>
+          </a:prstGeom>
+          <a:noFill/>
+          <a:ln/>
+        </p:spPr>
+        <p:txBody>
+          <a:bodyPr wrap="square" lIns="0" tIns="0" rIns="0" bIns="0" rtlCol="0" anchor="ctr"/>
+          <a:lstStyle/>
+          <a:p>
+            <a:pPr indent="0" marL="0">
+              <a:buNone/>
+            </a:pPr>
+            <a:r>
+              <a:rPr lang="en-US" sz="1600" dirty="0">
+                <a:solidFill>
+                  <a:srgbClr val="FFFFFF"/>
+                </a:solidFill>
+                <a:latin typeface="Cambria" pitchFamily="34" charset="0"/>
+                <a:ea typeface="Cambria" pitchFamily="34" charset="-122"/>
+                <a:cs typeface="Cambria" pitchFamily="34" charset="-120"/>
+              </a:rPr>
+              <a:t>Du bist doch sowieso immer die Letzte, die nach Hause kommt.</a:t>
+            </a:r>
+            <a:endParaRPr lang="en-US" sz="1600" dirty="0"/>
+          </a:p>
+        </p:txBody>
+      </p:sp>
+      <p:sp>
+        <p:nvSpPr>
+          <p:cNvPr id="19" name="Text 17"/>
+          <p:cNvSpPr txBox="1"/>
+          <p:nvPr/>
+        </p:nvSpPr>
+        <p:spPr>
+          <a:xfrm>
+            <a:off x="822960" y="4069080"/>
+            <a:ext cx="365760" cy="411480"/>
+          </a:xfrm>
+          <a:prstGeom prst="rect">
+            <a:avLst/>
+          </a:prstGeom>
+          <a:noFill/>
+          <a:ln/>
+        </p:spPr>
+        <p:txBody>
+          <a:bodyPr wrap="square" lIns="0" tIns="0" rIns="0" bIns="0" rtlCol="0" anchor="ctr"/>
+          <a:lstStyle/>
+          <a:p>
+            <a:pPr indent="0" marL="0">
+              <a:buNone/>
+            </a:pPr>
+            <a:r>
+              <a:rPr lang="en-US" sz="1400" b="1" dirty="0">
+                <a:solidFill>
+                  <a:srgbClr val="CADCFC"/>
+                </a:solidFill>
+                <a:latin typeface="Calibri" pitchFamily="34" charset="0"/>
+                <a:ea typeface="Calibri" pitchFamily="34" charset="-122"/>
+                <a:cs typeface="Calibri" pitchFamily="34" charset="-120"/>
+              </a:rPr>
+              <a:t>5</a:t>
+            </a:r>
+            <a:endParaRPr lang="en-US" sz="1400" dirty="0"/>
+          </a:p>
+        </p:txBody>
+      </p:sp>
+      <p:sp>
+        <p:nvSpPr>
+          <p:cNvPr id="20" name="Text 18"/>
+          <p:cNvSpPr txBox="1"/>
+          <p:nvPr/>
+        </p:nvSpPr>
+        <p:spPr>
+          <a:xfrm>
+            <a:off x="1234440" y="4069080"/>
+            <a:ext cx="914400" cy="411480"/>
+          </a:xfrm>
+          <a:prstGeom prst="rect">
+            <a:avLst/>
+          </a:prstGeom>
+          <a:noFill/>
+          <a:ln/>
+        </p:spPr>
+        <p:txBody>
+          <a:bodyPr wrap="square" lIns="0" tIns="0" rIns="0" bIns="0" rtlCol="0" anchor="ctr"/>
+          <a:lstStyle/>
+          <a:p>
+            <a:pPr indent="0" marL="0">
+              <a:buNone/>
+            </a:pPr>
+            <a:r>
+              <a:rPr lang="en-US" sz="1500" b="1" dirty="0">
+                <a:solidFill>
+                  <a:srgbClr val="FFFFFF"/>
+                </a:solidFill>
+                <a:latin typeface="Calibri" pitchFamily="34" charset="0"/>
+                <a:ea typeface="Calibri" pitchFamily="34" charset="-122"/>
+                <a:cs typeface="Calibri" pitchFamily="34" charset="-120"/>
+              </a:rPr>
+              <a:t>Mia</a:t>
+            </a:r>
+            <a:endParaRPr lang="en-US" sz="1500" dirty="0"/>
+          </a:p>
+        </p:txBody>
+      </p:sp>
+      <p:sp>
+        <p:nvSpPr>
+          <p:cNvPr id="21" name="Text 19"/>
+          <p:cNvSpPr txBox="1"/>
+          <p:nvPr/>
+        </p:nvSpPr>
+        <p:spPr>
+          <a:xfrm>
+            <a:off x="2194560" y="4069080"/>
+            <a:ext cx="8686800" cy="411480"/>
+          </a:xfrm>
+          <a:prstGeom prst="rect">
+            <a:avLst/>
+          </a:prstGeom>
+          <a:noFill/>
+          <a:ln/>
+        </p:spPr>
+        <p:txBody>
+          <a:bodyPr wrap="square" lIns="0" tIns="0" rIns="0" bIns="0" rtlCol="0" anchor="ctr"/>
+          <a:lstStyle/>
+          <a:p>
+            <a:pPr indent="0" marL="0">
+              <a:buNone/>
+            </a:pPr>
+            <a:r>
+              <a:rPr lang="en-US" sz="1600" dirty="0">
+                <a:solidFill>
+                  <a:srgbClr val="FFFFFF"/>
+                </a:solidFill>
+                <a:latin typeface="Cambria" pitchFamily="34" charset="0"/>
+                <a:ea typeface="Cambria" pitchFamily="34" charset="-122"/>
+                <a:cs typeface="Cambria" pitchFamily="34" charset="-120"/>
+              </a:rPr>
+              <a:t>Boah, du vertraust mir echt nie!</a:t>
+            </a:r>
+            <a:endParaRPr lang="en-US" sz="1600" dirty="0"/>
+          </a:p>
+        </p:txBody>
+      </p:sp>
+      <p:sp>
+        <p:nvSpPr>
+          <p:cNvPr id="22" name="Shape 20"/>
           <p:cNvSpPr/>
           <p:nvPr/>
         </p:nvSpPr>
         <p:spPr>
           <a:xfrm>
-            <a:off x="822960" y="2743200"/>
-            <a:ext cx="502920" cy="502920"/>
+            <a:off x="822960" y="4709160"/>
+            <a:ext cx="457200" cy="457200"/>
           </a:xfrm>
           <a:prstGeom prst="ellipse">
             <a:avLst/>
@@ -3226,14 +3811,14 @@
       </p:sp>
       <p:sp>
         <p:nvSpPr>
-          <p:cNvPr id="8" name="Text 6"/>
-          <p:cNvSpPr txBox="1"/>
-          <p:nvPr/>
-        </p:nvSpPr>
-        <p:spPr>
-          <a:xfrm>
-            <a:off x="822960" y="2743200"/>
-            <a:ext cx="502920" cy="502920"/>
+          <p:cNvPr id="23" name="Text 21"/>
+          <p:cNvSpPr txBox="1"/>
+          <p:nvPr/>
+        </p:nvSpPr>
+        <p:spPr>
+          <a:xfrm>
+            <a:off x="822960" y="4709160"/>
+            <a:ext cx="457200" cy="457200"/>
           </a:xfrm>
           <a:prstGeom prst="rect">
             <a:avLst/>
@@ -3249,7 +3834,7 @@
               <a:buNone/>
             </a:pPr>
             <a:r>
-              <a:rPr lang="en-US" sz="1800" b="1" dirty="0">
+              <a:rPr lang="en-US" sz="1600" b="1" dirty="0">
                 <a:solidFill>
                   <a:srgbClr val="FFFFFF"/>
                 </a:solidFill>
@@ -3259,98 +3844,59 @@
               </a:rPr>
               <a:t>1</a:t>
             </a:r>
+            <a:endParaRPr lang="en-US" sz="1600" dirty="0"/>
+          </a:p>
+        </p:txBody>
+      </p:sp>
+      <p:sp>
+        <p:nvSpPr>
+          <p:cNvPr id="24" name="Text 22"/>
+          <p:cNvSpPr txBox="1"/>
+          <p:nvPr/>
+        </p:nvSpPr>
+        <p:spPr>
+          <a:xfrm>
+            <a:off x="1463040" y="4709160"/>
+            <a:ext cx="9601200" cy="457200"/>
+          </a:xfrm>
+          <a:prstGeom prst="rect">
+            <a:avLst/>
+          </a:prstGeom>
+          <a:noFill/>
+          <a:ln/>
+        </p:spPr>
+        <p:txBody>
+          <a:bodyPr wrap="square" lIns="0" tIns="0" rIns="0" bIns="0" rtlCol="0" anchor="ctr"/>
+          <a:lstStyle/>
+          <a:p>
+            <a:pPr indent="0" marL="0">
+              <a:buNone/>
+            </a:pPr>
+            <a:r>
+              <a:rPr lang="en-US" sz="1800" dirty="0">
+                <a:solidFill>
+                  <a:srgbClr val="CADCFC"/>
+                </a:solidFill>
+                <a:latin typeface="Calibri" pitchFamily="34" charset="0"/>
+                <a:ea typeface="Calibri" pitchFamily="34" charset="-122"/>
+                <a:cs typeface="Calibri" pitchFamily="34" charset="-120"/>
+              </a:rPr>
+              <a:t>In welcher Zeile kippt es? Warum? (Fachbegriff)</a:t>
+            </a:r>
             <a:endParaRPr lang="en-US" sz="1800" dirty="0"/>
           </a:p>
         </p:txBody>
       </p:sp>
       <p:sp>
         <p:nvSpPr>
-          <p:cNvPr id="9" name="Text 7"/>
-          <p:cNvSpPr txBox="1"/>
-          <p:nvPr/>
-        </p:nvSpPr>
-        <p:spPr>
-          <a:xfrm>
-            <a:off x="1554480" y="2761488"/>
-            <a:ext cx="9144000" cy="457200"/>
-          </a:xfrm>
-          <a:prstGeom prst="rect">
-            <a:avLst/>
-          </a:prstGeom>
-          <a:noFill/>
-          <a:ln/>
-        </p:spPr>
-        <p:txBody>
-          <a:bodyPr wrap="square" lIns="0" tIns="0" rIns="0" bIns="0" rtlCol="0" anchor="t"/>
-          <a:lstStyle/>
-          <a:p>
-            <a:pPr indent="0" marL="0">
-              <a:buNone/>
-            </a:pPr>
-            <a:r>
-              <a:rPr lang="en-US" sz="2000" dirty="0">
-                <a:solidFill>
-                  <a:srgbClr val="CADCFC"/>
-                </a:solidFill>
-                <a:latin typeface="Calibri" pitchFamily="34" charset="0"/>
-                <a:ea typeface="Calibri" pitchFamily="34" charset="-122"/>
-                <a:cs typeface="Calibri" pitchFamily="34" charset="-120"/>
-              </a:rPr>
-              <a:t>Formuliere als Ich-Botschaft mit Bitte:</a:t>
-            </a:r>
-            <a:endParaRPr lang="en-US" sz="2000" dirty="0"/>
-          </a:p>
-        </p:txBody>
-      </p:sp>
-      <p:sp>
-        <p:nvSpPr>
-          <p:cNvPr id="10" name="Text 8"/>
-          <p:cNvSpPr txBox="1"/>
-          <p:nvPr/>
-        </p:nvSpPr>
-        <p:spPr>
-          <a:xfrm>
-            <a:off x="1554480" y="3246120"/>
-            <a:ext cx="9144000" cy="731520"/>
-          </a:xfrm>
-          <a:prstGeom prst="rect">
-            <a:avLst/>
-          </a:prstGeom>
-          <a:noFill/>
-          <a:ln/>
-        </p:spPr>
-        <p:txBody>
-          <a:bodyPr wrap="square" lIns="0" tIns="0" rIns="0" bIns="0" rtlCol="0" anchor="t"/>
-          <a:lstStyle/>
-          <a:p>
-            <a:pPr indent="0" marL="0">
-              <a:buNone/>
-            </a:pPr>
-            <a:r>
-              <a:rPr lang="en-US" sz="3200" b="1" dirty="0">
-                <a:solidFill>
-                  <a:srgbClr val="FFFFFF"/>
-                </a:solidFill>
-                <a:latin typeface="Cambria" pitchFamily="34" charset="0"/>
-                <a:ea typeface="Cambria" pitchFamily="34" charset="-122"/>
-                <a:cs typeface="Cambria" pitchFamily="34" charset="-120"/>
-              </a:rPr>
-              <a:t>„Nie hörst du mir zu!“</a:t>
-            </a:r>
-            <a:endParaRPr lang="en-US" sz="3200" dirty="0"/>
-          </a:p>
-        </p:txBody>
-      </p:sp>
-      <p:sp>
-        <p:nvSpPr>
-          <p:cNvPr id="11" name="Shape 9"/>
+          <p:cNvPr id="25" name="Shape 23"/>
           <p:cNvSpPr/>
           <p:nvPr/>
         </p:nvSpPr>
         <p:spPr>
           <a:xfrm>
-            <a:off x="822960" y="4343400"/>
-            <a:ext cx="502920" cy="502920"/>
+            <a:off x="822960" y="5303520"/>
+            <a:ext cx="457200" cy="457200"/>
           </a:xfrm>
           <a:prstGeom prst="ellipse">
             <a:avLst/>
@@ -3363,14 +3909,14 @@
       </p:sp>
       <p:sp>
         <p:nvSpPr>
-          <p:cNvPr id="12" name="Text 10"/>
-          <p:cNvSpPr txBox="1"/>
-          <p:nvPr/>
-        </p:nvSpPr>
-        <p:spPr>
-          <a:xfrm>
-            <a:off x="822960" y="4343400"/>
-            <a:ext cx="502920" cy="502920"/>
+          <p:cNvPr id="26" name="Text 24"/>
+          <p:cNvSpPr txBox="1"/>
+          <p:nvPr/>
+        </p:nvSpPr>
+        <p:spPr>
+          <a:xfrm>
+            <a:off x="822960" y="5303520"/>
+            <a:ext cx="457200" cy="457200"/>
           </a:xfrm>
           <a:prstGeom prst="rect">
             <a:avLst/>
@@ -3386,7 +3932,7 @@
               <a:buNone/>
             </a:pPr>
             <a:r>
-              <a:rPr lang="en-US" sz="1800" b="1" dirty="0">
+              <a:rPr lang="en-US" sz="1600" b="1" dirty="0">
                 <a:solidFill>
                   <a:srgbClr val="FFFFFF"/>
                 </a:solidFill>
@@ -3396,20 +3942,59 @@
               </a:rPr>
               <a:t>2</a:t>
             </a:r>
+            <a:endParaRPr lang="en-US" sz="1600" dirty="0"/>
+          </a:p>
+        </p:txBody>
+      </p:sp>
+      <p:sp>
+        <p:nvSpPr>
+          <p:cNvPr id="27" name="Text 25"/>
+          <p:cNvSpPr txBox="1"/>
+          <p:nvPr/>
+        </p:nvSpPr>
+        <p:spPr>
+          <a:xfrm>
+            <a:off x="1463040" y="5303520"/>
+            <a:ext cx="9601200" cy="457200"/>
+          </a:xfrm>
+          <a:prstGeom prst="rect">
+            <a:avLst/>
+          </a:prstGeom>
+          <a:noFill/>
+          <a:ln/>
+        </p:spPr>
+        <p:txBody>
+          <a:bodyPr wrap="square" lIns="0" tIns="0" rIns="0" bIns="0" rtlCol="0" anchor="ctr"/>
+          <a:lstStyle/>
+          <a:p>
+            <a:pPr indent="0" marL="0">
+              <a:buNone/>
+            </a:pPr>
+            <a:r>
+              <a:rPr lang="en-US" sz="1800" dirty="0">
+                <a:solidFill>
+                  <a:srgbClr val="CADCFC"/>
+                </a:solidFill>
+                <a:latin typeface="Calibri" pitchFamily="34" charset="0"/>
+                <a:ea typeface="Calibri" pitchFamily="34" charset="-122"/>
+                <a:cs typeface="Calibri" pitchFamily="34" charset="-120"/>
+              </a:rPr>
+              <a:t>Schreibe diese Zeile mit zwei Techniken um und notiere die Buchstaben.</a:t>
+            </a:r>
             <a:endParaRPr lang="en-US" sz="1800" dirty="0"/>
           </a:p>
         </p:txBody>
       </p:sp>
       <p:sp>
         <p:nvSpPr>
-          <p:cNvPr id="13" name="Text 11"/>
-          <p:cNvSpPr txBox="1"/>
-          <p:nvPr/>
-        </p:nvSpPr>
-        <p:spPr>
-          <a:xfrm>
-            <a:off x="1554480" y="4361688"/>
-            <a:ext cx="9601200" cy="548640"/>
+          <p:cNvPr id="28" name="Text 26"/>
+          <p:cNvSpPr txBox="1"/>
+          <p:nvPr/>
+        </p:nvSpPr>
+        <p:spPr>
+          <a:xfrm>
+            <a:off x="822960" y="6126480"/>
+            <a:ext cx="7315200" cy="365760"/>
           </a:xfrm>
           <a:prstGeom prst="rect">
             <a:avLst/>
@@ -3425,7 +4010,7 @@
               <a:buNone/>
             </a:pPr>
             <a:r>
-              <a:rPr lang="en-US" sz="2000" dirty="0">
+              <a:rPr lang="en-US" sz="1400" i="1" dirty="0">
                 <a:solidFill>
                   <a:srgbClr val="CADCFC"/>
                 </a:solidFill>
@@ -3433,48 +4018,9 @@
                 <a:ea typeface="Calibri" pitchFamily="34" charset="-122"/>
                 <a:cs typeface="Calibri" pitchFamily="34" charset="-120"/>
               </a:rPr>
-              <a:t>Woran erkennst du, dass ein Gespräch gerade kippt? Nenne zwei Signale.</a:t>
-            </a:r>
-            <a:endParaRPr lang="en-US" sz="2000" dirty="0"/>
-          </a:p>
-        </p:txBody>
-      </p:sp>
-      <p:sp>
-        <p:nvSpPr>
-          <p:cNvPr id="14" name="Text 12"/>
-          <p:cNvSpPr txBox="1"/>
-          <p:nvPr/>
-        </p:nvSpPr>
-        <p:spPr>
-          <a:xfrm>
-            <a:off x="822960" y="5852160"/>
-            <a:ext cx="5486400" cy="365760"/>
-          </a:xfrm>
-          <a:prstGeom prst="rect">
-            <a:avLst/>
-          </a:prstGeom>
-          <a:noFill/>
-          <a:ln/>
-        </p:spPr>
-        <p:txBody>
-          <a:bodyPr wrap="square" lIns="0" tIns="0" rIns="0" bIns="0" rtlCol="0" anchor="t"/>
-          <a:lstStyle/>
-          <a:p>
-            <a:pPr indent="0" marL="0">
-              <a:buNone/>
-            </a:pPr>
-            <a:r>
-              <a:rPr lang="en-US" sz="1600" i="1" dirty="0">
-                <a:solidFill>
-                  <a:srgbClr val="CADCFC"/>
-                </a:solidFill>
-                <a:latin typeface="Calibri" pitchFamily="34" charset="0"/>
-                <a:ea typeface="Calibri" pitchFamily="34" charset="-122"/>
-                <a:cs typeface="Calibri" pitchFamily="34" charset="-120"/>
-              </a:rPr>
               <a:t>Ticket liegt im Gruppenumschlag · Abgabe an der Tür.</a:t>
             </a:r>
-            <a:endParaRPr lang="en-US" sz="1600" dirty="0"/>
+            <a:endParaRPr lang="en-US" sz="1400" dirty="0"/>
           </a:p>
         </p:txBody>
       </p:sp>
@@ -7447,7 +7993,7 @@
                 <a:ea typeface="Calibri" pitchFamily="34" charset="-122"/>
                 <a:cs typeface="Calibri" pitchFamily="34" charset="-120"/>
               </a:rPr>
-              <a:t>AUFGABE 3 · GRUPPENPUZZLE</a:t>
+              <a:t>AUFGABE 3 · EINZELARBEIT</a:t>
             </a:r>
             <a:endParaRPr lang="en-US" sz="1200" dirty="0"/>
           </a:p>
@@ -7486,7 +8032,7 @@
                 <a:ea typeface="Cambria" pitchFamily="34" charset="-122"/>
                 <a:cs typeface="Cambria" pitchFamily="34" charset="-120"/>
               </a:rPr>
-              <a:t>Das Gespräch retten</a:t>
+              <a:t>Technik-Training: Schritt für Schritt</a:t>
             </a:r>
             <a:endParaRPr lang="en-US" sz="3200" dirty="0"/>
           </a:p>
@@ -7525,7 +8071,7 @@
                 <a:ea typeface="Calibri" pitchFamily="34" charset="-122"/>
                 <a:cs typeface="Calibri" pitchFamily="34" charset="-120"/>
               </a:rPr>
-              <a:t>Arbeitsblatt S. 3 · drei Gruppen à 7: Wandreihe · Mittelreihe · Fensterreihe</a:t>
+              <a:t>Arbeitsblatt S. 3–4 · jede Technik an einem Kipppunkt aus M1</a:t>
             </a:r>
             <a:endParaRPr lang="en-US" sz="1400" dirty="0"/>
           </a:p>
@@ -7664,7 +8210,7 @@
                 <a:ea typeface="Cambria" pitchFamily="34" charset="-122"/>
                 <a:cs typeface="Cambria" pitchFamily="34" charset="-120"/>
               </a:rPr>
-              <a:t>17 Min.</a:t>
+              <a:t>18 Min.</a:t>
             </a:r>
             <a:endParaRPr lang="en-US" sz="2600" dirty="0"/>
           </a:p>
@@ -7703,7 +8249,7 @@
                 <a:ea typeface="Calibri" pitchFamily="34" charset="-122"/>
                 <a:cs typeface="Calibri" pitchFamily="34" charset="-120"/>
               </a:rPr>
-              <a:t>+ 3 Min. Umsetzen</a:t>
+              <a:t>4 × 4' + 2' PA</a:t>
             </a:r>
             <a:endParaRPr lang="en-US" sz="1200" dirty="0"/>
           </a:p>
@@ -7711,453 +8257,14 @@
       </p:sp>
       <p:sp>
         <p:nvSpPr>
-          <p:cNvPr id="10" name="Text 8"/>
-          <p:cNvSpPr txBox="1"/>
+          <p:cNvPr id="10" name="Shape 8"/>
+          <p:cNvSpPr/>
           <p:nvPr/>
         </p:nvSpPr>
         <p:spPr>
           <a:xfrm>
             <a:off x="548640" y="1783080"/>
-            <a:ext cx="10972800" cy="365760"/>
-          </a:xfrm>
-          <a:prstGeom prst="rect">
-            <a:avLst/>
-          </a:prstGeom>
-          <a:noFill/>
-          <a:ln/>
-        </p:spPr>
-        <p:txBody>
-          <a:bodyPr wrap="square" lIns="0" tIns="0" rIns="0" bIns="0" rtlCol="0" anchor="t"/>
-          <a:lstStyle/>
-          <a:p>
-            <a:pPr indent="0" marL="0">
-              <a:buNone/>
-            </a:pPr>
-            <a:r>
-              <a:rPr lang="en-US" sz="1600" b="1" dirty="0">
-                <a:solidFill>
-                  <a:srgbClr val="1E2761"/>
-                </a:solidFill>
-                <a:latin typeface="Cambria" pitchFamily="34" charset="0"/>
-                <a:ea typeface="Cambria" pitchFamily="34" charset="-122"/>
-                <a:cs typeface="Cambria" pitchFamily="34" charset="-120"/>
-              </a:rPr>
-              <a:t>Zuerst (3 Min.): als Reihe zusammenrücken, Umschlag öffnen, Rollen verteilen</a:t>
-            </a:r>
-            <a:endParaRPr lang="en-US" sz="1600" dirty="0"/>
-          </a:p>
-        </p:txBody>
-      </p:sp>
-      <p:sp>
-        <p:nvSpPr>
-          <p:cNvPr id="11" name="Shape 9"/>
-          <p:cNvSpPr/>
-          <p:nvPr/>
-        </p:nvSpPr>
-        <p:spPr>
-          <a:xfrm>
-            <a:off x="548640" y="2240280"/>
-            <a:ext cx="2651760" cy="960120"/>
-          </a:xfrm>
-          <a:prstGeom prst="roundRect">
-            <a:avLst>
-              <a:gd name="adj" fmla="val 7619"/>
-            </a:avLst>
-          </a:prstGeom>
-          <a:solidFill>
-            <a:srgbClr val="F4F7FD"/>
-          </a:solidFill>
-          <a:ln/>
-        </p:spPr>
-      </p:sp>
-      <p:sp>
-        <p:nvSpPr>
-          <p:cNvPr id="12" name="Text 10"/>
-          <p:cNvSpPr txBox="1"/>
-          <p:nvPr/>
-        </p:nvSpPr>
-        <p:spPr>
-          <a:xfrm>
-            <a:off x="731520" y="2304288"/>
-            <a:ext cx="2286000" cy="365760"/>
-          </a:xfrm>
-          <a:prstGeom prst="rect">
-            <a:avLst/>
-          </a:prstGeom>
-          <a:noFill/>
-          <a:ln/>
-        </p:spPr>
-        <p:txBody>
-          <a:bodyPr wrap="square" lIns="0" tIns="0" rIns="0" bIns="0" rtlCol="0" anchor="t"/>
-          <a:lstStyle/>
-          <a:p>
-            <a:pPr indent="0" marL="0">
-              <a:buNone/>
-            </a:pPr>
-            <a:r>
-              <a:rPr lang="en-US" sz="1700" b="1" dirty="0">
-                <a:solidFill>
-                  <a:srgbClr val="1E2761"/>
-                </a:solidFill>
-                <a:latin typeface="Cambria" pitchFamily="34" charset="0"/>
-                <a:ea typeface="Cambria" pitchFamily="34" charset="-122"/>
-                <a:cs typeface="Cambria" pitchFamily="34" charset="-120"/>
-              </a:rPr>
-              <a:t>Zeit</a:t>
-            </a:r>
-            <a:endParaRPr lang="en-US" sz="1700" dirty="0"/>
-          </a:p>
-        </p:txBody>
-      </p:sp>
-      <p:sp>
-        <p:nvSpPr>
-          <p:cNvPr id="13" name="Text 11"/>
-          <p:cNvSpPr txBox="1"/>
-          <p:nvPr/>
-        </p:nvSpPr>
-        <p:spPr>
-          <a:xfrm>
-            <a:off x="731520" y="2670048"/>
-            <a:ext cx="2286000" cy="502920"/>
-          </a:xfrm>
-          <a:prstGeom prst="rect">
-            <a:avLst/>
-          </a:prstGeom>
-          <a:noFill/>
-          <a:ln/>
-        </p:spPr>
-        <p:txBody>
-          <a:bodyPr wrap="square" lIns="0" tIns="0" rIns="0" bIns="0" rtlCol="0" anchor="t"/>
-          <a:lstStyle/>
-          <a:p>
-            <a:pPr indent="0" marL="0">
-              <a:buNone/>
-            </a:pPr>
-            <a:r>
-              <a:rPr lang="en-US" sz="1300" dirty="0">
-                <a:solidFill>
-                  <a:srgbClr val="5B6B8C"/>
-                </a:solidFill>
-                <a:latin typeface="Calibri" pitchFamily="34" charset="0"/>
-                <a:ea typeface="Calibri" pitchFamily="34" charset="-122"/>
-                <a:cs typeface="Calibri" pitchFamily="34" charset="-120"/>
-              </a:rPr>
-              <a:t>hat den Timer im Blick</a:t>
-            </a:r>
-            <a:endParaRPr lang="en-US" sz="1300" dirty="0"/>
-          </a:p>
-        </p:txBody>
-      </p:sp>
-      <p:sp>
-        <p:nvSpPr>
-          <p:cNvPr id="14" name="Shape 12"/>
-          <p:cNvSpPr/>
-          <p:nvPr/>
-        </p:nvSpPr>
-        <p:spPr>
-          <a:xfrm>
-            <a:off x="3364992" y="2240280"/>
-            <a:ext cx="2651760" cy="960120"/>
-          </a:xfrm>
-          <a:prstGeom prst="roundRect">
-            <a:avLst>
-              <a:gd name="adj" fmla="val 7619"/>
-            </a:avLst>
-          </a:prstGeom>
-          <a:solidFill>
-            <a:srgbClr val="F4F7FD"/>
-          </a:solidFill>
-          <a:ln/>
-        </p:spPr>
-      </p:sp>
-      <p:sp>
-        <p:nvSpPr>
-          <p:cNvPr id="15" name="Text 13"/>
-          <p:cNvSpPr txBox="1"/>
-          <p:nvPr/>
-        </p:nvSpPr>
-        <p:spPr>
-          <a:xfrm>
-            <a:off x="3547872" y="2304288"/>
-            <a:ext cx="2286000" cy="365760"/>
-          </a:xfrm>
-          <a:prstGeom prst="rect">
-            <a:avLst/>
-          </a:prstGeom>
-          <a:noFill/>
-          <a:ln/>
-        </p:spPr>
-        <p:txBody>
-          <a:bodyPr wrap="square" lIns="0" tIns="0" rIns="0" bIns="0" rtlCol="0" anchor="t"/>
-          <a:lstStyle/>
-          <a:p>
-            <a:pPr indent="0" marL="0">
-              <a:buNone/>
-            </a:pPr>
-            <a:r>
-              <a:rPr lang="en-US" sz="1700" b="1" dirty="0">
-                <a:solidFill>
-                  <a:srgbClr val="1E2761"/>
-                </a:solidFill>
-                <a:latin typeface="Cambria" pitchFamily="34" charset="0"/>
-                <a:ea typeface="Cambria" pitchFamily="34" charset="-122"/>
-                <a:cs typeface="Cambria" pitchFamily="34" charset="-120"/>
-              </a:rPr>
-              <a:t>Protokoll</a:t>
-            </a:r>
-            <a:endParaRPr lang="en-US" sz="1700" dirty="0"/>
-          </a:p>
-        </p:txBody>
-      </p:sp>
-      <p:sp>
-        <p:nvSpPr>
-          <p:cNvPr id="16" name="Text 14"/>
-          <p:cNvSpPr txBox="1"/>
-          <p:nvPr/>
-        </p:nvSpPr>
-        <p:spPr>
-          <a:xfrm>
-            <a:off x="3547872" y="2670048"/>
-            <a:ext cx="2286000" cy="502920"/>
-          </a:xfrm>
-          <a:prstGeom prst="rect">
-            <a:avLst/>
-          </a:prstGeom>
-          <a:noFill/>
-          <a:ln/>
-        </p:spPr>
-        <p:txBody>
-          <a:bodyPr wrap="square" lIns="0" tIns="0" rIns="0" bIns="0" rtlCol="0" anchor="t"/>
-          <a:lstStyle/>
-          <a:p>
-            <a:pPr indent="0" marL="0">
-              <a:buNone/>
-            </a:pPr>
-            <a:r>
-              <a:rPr lang="en-US" sz="1300" dirty="0">
-                <a:solidFill>
-                  <a:srgbClr val="5B6B8C"/>
-                </a:solidFill>
-                <a:latin typeface="Calibri" pitchFamily="34" charset="0"/>
-                <a:ea typeface="Calibri" pitchFamily="34" charset="-122"/>
-                <a:cs typeface="Calibri" pitchFamily="34" charset="-120"/>
-              </a:rPr>
-              <a:t>schreibt auf</a:t>
-            </a:r>
-            <a:endParaRPr lang="en-US" sz="1300" dirty="0"/>
-          </a:p>
-        </p:txBody>
-      </p:sp>
-      <p:sp>
-        <p:nvSpPr>
-          <p:cNvPr id="17" name="Shape 15"/>
-          <p:cNvSpPr/>
-          <p:nvPr/>
-        </p:nvSpPr>
-        <p:spPr>
-          <a:xfrm>
-            <a:off x="6181344" y="2240280"/>
-            <a:ext cx="2651760" cy="960120"/>
-          </a:xfrm>
-          <a:prstGeom prst="roundRect">
-            <a:avLst>
-              <a:gd name="adj" fmla="val 7619"/>
-            </a:avLst>
-          </a:prstGeom>
-          <a:solidFill>
-            <a:srgbClr val="F4F7FD"/>
-          </a:solidFill>
-          <a:ln/>
-        </p:spPr>
-      </p:sp>
-      <p:sp>
-        <p:nvSpPr>
-          <p:cNvPr id="18" name="Text 16"/>
-          <p:cNvSpPr txBox="1"/>
-          <p:nvPr/>
-        </p:nvSpPr>
-        <p:spPr>
-          <a:xfrm>
-            <a:off x="6364224" y="2304288"/>
-            <a:ext cx="2286000" cy="365760"/>
-          </a:xfrm>
-          <a:prstGeom prst="rect">
-            <a:avLst/>
-          </a:prstGeom>
-          <a:noFill/>
-          <a:ln/>
-        </p:spPr>
-        <p:txBody>
-          <a:bodyPr wrap="square" lIns="0" tIns="0" rIns="0" bIns="0" rtlCol="0" anchor="t"/>
-          <a:lstStyle/>
-          <a:p>
-            <a:pPr indent="0" marL="0">
-              <a:buNone/>
-            </a:pPr>
-            <a:r>
-              <a:rPr lang="en-US" sz="1700" b="1" dirty="0">
-                <a:solidFill>
-                  <a:srgbClr val="1E2761"/>
-                </a:solidFill>
-                <a:latin typeface="Cambria" pitchFamily="34" charset="0"/>
-                <a:ea typeface="Cambria" pitchFamily="34" charset="-122"/>
-                <a:cs typeface="Cambria" pitchFamily="34" charset="-120"/>
-              </a:rPr>
-              <a:t>Regie</a:t>
-            </a:r>
-            <a:endParaRPr lang="en-US" sz="1700" dirty="0"/>
-          </a:p>
-        </p:txBody>
-      </p:sp>
-      <p:sp>
-        <p:nvSpPr>
-          <p:cNvPr id="19" name="Text 17"/>
-          <p:cNvSpPr txBox="1"/>
-          <p:nvPr/>
-        </p:nvSpPr>
-        <p:spPr>
-          <a:xfrm>
-            <a:off x="6364224" y="2670048"/>
-            <a:ext cx="2286000" cy="502920"/>
-          </a:xfrm>
-          <a:prstGeom prst="rect">
-            <a:avLst/>
-          </a:prstGeom>
-          <a:noFill/>
-          <a:ln/>
-        </p:spPr>
-        <p:txBody>
-          <a:bodyPr wrap="square" lIns="0" tIns="0" rIns="0" bIns="0" rtlCol="0" anchor="t"/>
-          <a:lstStyle/>
-          <a:p>
-            <a:pPr indent="0" marL="0">
-              <a:buNone/>
-            </a:pPr>
-            <a:r>
-              <a:rPr lang="en-US" sz="1300" dirty="0">
-                <a:solidFill>
-                  <a:srgbClr val="5B6B8C"/>
-                </a:solidFill>
-                <a:latin typeface="Calibri" pitchFamily="34" charset="0"/>
-                <a:ea typeface="Calibri" pitchFamily="34" charset="-122"/>
-                <a:cs typeface="Calibri" pitchFamily="34" charset="-120"/>
-              </a:rPr>
-              <a:t>alle kommen zu Wort</a:t>
-            </a:r>
-            <a:endParaRPr lang="en-US" sz="1300" dirty="0"/>
-          </a:p>
-        </p:txBody>
-      </p:sp>
-      <p:sp>
-        <p:nvSpPr>
-          <p:cNvPr id="20" name="Shape 18"/>
-          <p:cNvSpPr/>
-          <p:nvPr/>
-        </p:nvSpPr>
-        <p:spPr>
-          <a:xfrm>
-            <a:off x="8997696" y="2240280"/>
-            <a:ext cx="2651760" cy="960120"/>
-          </a:xfrm>
-          <a:prstGeom prst="roundRect">
-            <a:avLst>
-              <a:gd name="adj" fmla="val 7619"/>
-            </a:avLst>
-          </a:prstGeom>
-          <a:solidFill>
-            <a:srgbClr val="F4F7FD"/>
-          </a:solidFill>
-          <a:ln/>
-        </p:spPr>
-      </p:sp>
-      <p:sp>
-        <p:nvSpPr>
-          <p:cNvPr id="21" name="Text 19"/>
-          <p:cNvSpPr txBox="1"/>
-          <p:nvPr/>
-        </p:nvSpPr>
-        <p:spPr>
-          <a:xfrm>
-            <a:off x="9180576" y="2304288"/>
-            <a:ext cx="2286000" cy="365760"/>
-          </a:xfrm>
-          <a:prstGeom prst="rect">
-            <a:avLst/>
-          </a:prstGeom>
-          <a:noFill/>
-          <a:ln/>
-        </p:spPr>
-        <p:txBody>
-          <a:bodyPr wrap="square" lIns="0" tIns="0" rIns="0" bIns="0" rtlCol="0" anchor="t"/>
-          <a:lstStyle/>
-          <a:p>
-            <a:pPr indent="0" marL="0">
-              <a:buNone/>
-            </a:pPr>
-            <a:r>
-              <a:rPr lang="en-US" sz="1700" b="1" dirty="0">
-                <a:solidFill>
-                  <a:srgbClr val="1E2761"/>
-                </a:solidFill>
-                <a:latin typeface="Cambria" pitchFamily="34" charset="0"/>
-                <a:ea typeface="Cambria" pitchFamily="34" charset="-122"/>
-                <a:cs typeface="Cambria" pitchFamily="34" charset="-120"/>
-              </a:rPr>
-              <a:t>Material</a:t>
-            </a:r>
-            <a:endParaRPr lang="en-US" sz="1700" dirty="0"/>
-          </a:p>
-        </p:txBody>
-      </p:sp>
-      <p:sp>
-        <p:nvSpPr>
-          <p:cNvPr id="22" name="Text 20"/>
-          <p:cNvSpPr txBox="1"/>
-          <p:nvPr/>
-        </p:nvSpPr>
-        <p:spPr>
-          <a:xfrm>
-            <a:off x="9180576" y="2670048"/>
-            <a:ext cx="2286000" cy="502920"/>
-          </a:xfrm>
-          <a:prstGeom prst="rect">
-            <a:avLst/>
-          </a:prstGeom>
-          <a:noFill/>
-          <a:ln/>
-        </p:spPr>
-        <p:txBody>
-          <a:bodyPr wrap="square" lIns="0" tIns="0" rIns="0" bIns="0" rtlCol="0" anchor="t"/>
-          <a:lstStyle/>
-          <a:p>
-            <a:pPr indent="0" marL="0">
-              <a:buNone/>
-            </a:pPr>
-            <a:r>
-              <a:rPr lang="en-US" sz="1300" dirty="0">
-                <a:solidFill>
-                  <a:srgbClr val="5B6B8C"/>
-                </a:solidFill>
-                <a:latin typeface="Calibri" pitchFamily="34" charset="0"/>
-                <a:ea typeface="Calibri" pitchFamily="34" charset="-122"/>
-                <a:cs typeface="Calibri" pitchFamily="34" charset="-120"/>
-              </a:rPr>
-              <a:t>holt Karten · fragt als Einzige die Lehrkraft</a:t>
-            </a:r>
-            <a:endParaRPr lang="en-US" sz="1300" dirty="0"/>
-          </a:p>
-        </p:txBody>
-      </p:sp>
-      <p:sp>
-        <p:nvSpPr>
-          <p:cNvPr id="23" name="Shape 21"/>
-          <p:cNvSpPr/>
-          <p:nvPr/>
-        </p:nvSpPr>
-        <p:spPr>
-          <a:xfrm>
-            <a:off x="548640" y="3520440"/>
-            <a:ext cx="3566160" cy="1828800"/>
+            <a:ext cx="2651760" cy="1828800"/>
           </a:xfrm>
           <a:prstGeom prst="roundRect">
             <a:avLst>
@@ -8165,65 +8272,119 @@
             </a:avLst>
           </a:prstGeom>
           <a:solidFill>
-            <a:srgbClr val="FFFFFF"/>
+            <a:srgbClr val="F4F7FD"/>
           </a:solidFill>
-          <a:ln w="15240">
-            <a:solidFill>
-              <a:srgbClr val="B9C6E8"/>
-            </a:solidFill>
-            <a:prstDash val="solid"/>
-          </a:ln>
-        </p:spPr>
-      </p:sp>
-      <p:sp>
-        <p:nvSpPr>
-          <p:cNvPr id="24" name="Text 22"/>
-          <p:cNvSpPr txBox="1"/>
-          <p:nvPr/>
-        </p:nvSpPr>
-        <p:spPr>
-          <a:xfrm>
-            <a:off x="777240" y="3657600"/>
-            <a:ext cx="914400" cy="457200"/>
-          </a:xfrm>
-          <a:prstGeom prst="rect">
-            <a:avLst/>
-          </a:prstGeom>
-          <a:noFill/>
-          <a:ln/>
-        </p:spPr>
-        <p:txBody>
-          <a:bodyPr wrap="square" lIns="0" tIns="0" rIns="0" bIns="0" rtlCol="0" anchor="t"/>
-          <a:lstStyle/>
-          <a:p>
-            <a:pPr indent="0" marL="0">
-              <a:buNone/>
-            </a:pPr>
-            <a:r>
-              <a:rPr lang="en-US" sz="2400" b="1" dirty="0">
-                <a:solidFill>
-                  <a:srgbClr val="D9534F"/>
+          <a:ln/>
+        </p:spPr>
+      </p:sp>
+      <p:sp>
+        <p:nvSpPr>
+          <p:cNvPr id="11" name="Shape 9"/>
+          <p:cNvSpPr/>
+          <p:nvPr/>
+        </p:nvSpPr>
+        <p:spPr>
+          <a:xfrm>
+            <a:off x="777240" y="1938528"/>
+            <a:ext cx="566928" cy="566928"/>
+          </a:xfrm>
+          <a:prstGeom prst="ellipse">
+            <a:avLst/>
+          </a:prstGeom>
+          <a:solidFill>
+            <a:srgbClr val="3F7CC4"/>
+          </a:solidFill>
+          <a:ln/>
+        </p:spPr>
+      </p:sp>
+      <p:sp>
+        <p:nvSpPr>
+          <p:cNvPr id="12" name="Text 10"/>
+          <p:cNvSpPr txBox="1"/>
+          <p:nvPr/>
+        </p:nvSpPr>
+        <p:spPr>
+          <a:xfrm>
+            <a:off x="777240" y="1938528"/>
+            <a:ext cx="566928" cy="566928"/>
+          </a:xfrm>
+          <a:prstGeom prst="rect">
+            <a:avLst/>
+          </a:prstGeom>
+          <a:noFill/>
+          <a:ln/>
+        </p:spPr>
+        <p:txBody>
+          <a:bodyPr wrap="square" lIns="0" tIns="0" rIns="0" bIns="0" rtlCol="0" anchor="ctr"/>
+          <a:lstStyle/>
+          <a:p>
+            <a:pPr algn="ctr" indent="0" marL="0">
+              <a:buNone/>
+            </a:pPr>
+            <a:r>
+              <a:rPr lang="en-US" sz="2200" b="1" dirty="0">
+                <a:solidFill>
+                  <a:srgbClr val="FFFFFF"/>
+                </a:solidFill>
+                <a:latin typeface="Calibri" pitchFamily="34" charset="0"/>
+                <a:ea typeface="Calibri" pitchFamily="34" charset="-122"/>
+                <a:cs typeface="Calibri" pitchFamily="34" charset="-120"/>
+              </a:rPr>
+              <a:t>A</a:t>
+            </a:r>
+            <a:endParaRPr lang="en-US" sz="2200" dirty="0"/>
+          </a:p>
+        </p:txBody>
+      </p:sp>
+      <p:sp>
+        <p:nvSpPr>
+          <p:cNvPr id="13" name="Text 11"/>
+          <p:cNvSpPr txBox="1"/>
+          <p:nvPr/>
+        </p:nvSpPr>
+        <p:spPr>
+          <a:xfrm>
+            <a:off x="1417320" y="1938528"/>
+            <a:ext cx="1737360" cy="566928"/>
+          </a:xfrm>
+          <a:prstGeom prst="rect">
+            <a:avLst/>
+          </a:prstGeom>
+          <a:noFill/>
+          <a:ln/>
+        </p:spPr>
+        <p:txBody>
+          <a:bodyPr wrap="square" lIns="0" tIns="0" rIns="0" bIns="0" rtlCol="0" anchor="ctr"/>
+          <a:lstStyle/>
+          <a:p>
+            <a:pPr indent="0" marL="0">
+              <a:buNone/>
+            </a:pPr>
+            <a:r>
+              <a:rPr lang="en-US" sz="1300" b="1" dirty="0">
+                <a:solidFill>
+                  <a:srgbClr val="3F7CC4"/>
                 </a:solidFill>
                 <a:latin typeface="Cambria" pitchFamily="34" charset="0"/>
                 <a:ea typeface="Cambria" pitchFamily="34" charset="-122"/>
                 <a:cs typeface="Cambria" pitchFamily="34" charset="-120"/>
               </a:rPr>
-              <a:t>4'</a:t>
-            </a:r>
-            <a:endParaRPr lang="en-US" sz="2400" dirty="0"/>
-          </a:p>
-        </p:txBody>
-      </p:sp>
-      <p:sp>
-        <p:nvSpPr>
-          <p:cNvPr id="25" name="Text 23"/>
-          <p:cNvSpPr txBox="1"/>
-          <p:nvPr/>
-        </p:nvSpPr>
-        <p:spPr>
-          <a:xfrm>
-            <a:off x="1645920" y="3703320"/>
-            <a:ext cx="2286000" cy="411480"/>
+              <a:t>Ich-Botschaft</a:t>
+            </a:r>
+            <a:endParaRPr lang="en-US" sz="1300" dirty="0"/>
+          </a:p>
+        </p:txBody>
+      </p:sp>
+      <p:sp>
+        <p:nvSpPr>
+          <p:cNvPr id="14" name="Text 12"/>
+          <p:cNvSpPr txBox="1"/>
+          <p:nvPr/>
+        </p:nvSpPr>
+        <p:spPr>
+          <a:xfrm>
+            <a:off x="777240" y="2697480"/>
+            <a:ext cx="2194560" cy="365760"/>
           </a:xfrm>
           <a:prstGeom prst="rect">
             <a:avLst/>
@@ -8239,30 +8400,30 @@
               <a:buNone/>
             </a:pPr>
             <a:r>
-              <a:rPr lang="en-US" sz="1900" b="1" dirty="0">
+              <a:rPr lang="en-US" sz="1600" b="1" dirty="0">
                 <a:solidFill>
                   <a:srgbClr val="1E2761"/>
                 </a:solidFill>
-                <a:latin typeface="Cambria" pitchFamily="34" charset="0"/>
-                <a:ea typeface="Cambria" pitchFamily="34" charset="-122"/>
-                <a:cs typeface="Cambria" pitchFamily="34" charset="-120"/>
-              </a:rPr>
-              <a:t>Lesen</a:t>
-            </a:r>
-            <a:endParaRPr lang="en-US" sz="1900" dirty="0"/>
-          </a:p>
-        </p:txBody>
-      </p:sp>
-      <p:sp>
-        <p:nvSpPr>
-          <p:cNvPr id="26" name="Text 24"/>
-          <p:cNvSpPr txBox="1"/>
-          <p:nvPr/>
-        </p:nvSpPr>
-        <p:spPr>
-          <a:xfrm>
-            <a:off x="777240" y="4206240"/>
-            <a:ext cx="3154680" cy="1097280"/>
+                <a:latin typeface="Calibri" pitchFamily="34" charset="0"/>
+                <a:ea typeface="Calibri" pitchFamily="34" charset="-122"/>
+                <a:cs typeface="Calibri" pitchFamily="34" charset="-120"/>
+              </a:rPr>
+              <a:t>→ Zeile 3 umschreiben</a:t>
+            </a:r>
+            <a:endParaRPr lang="en-US" sz="1600" dirty="0"/>
+          </a:p>
+        </p:txBody>
+      </p:sp>
+      <p:sp>
+        <p:nvSpPr>
+          <p:cNvPr id="15" name="Text 13"/>
+          <p:cNvSpPr txBox="1"/>
+          <p:nvPr/>
+        </p:nvSpPr>
+        <p:spPr>
+          <a:xfrm>
+            <a:off x="777240" y="3108960"/>
+            <a:ext cx="2194560" cy="320040"/>
           </a:xfrm>
           <a:prstGeom prst="rect">
             <a:avLst/>
@@ -8278,30 +8439,30 @@
               <a:buNone/>
             </a:pPr>
             <a:r>
-              <a:rPr lang="en-US" sz="1500" dirty="0">
-                <a:solidFill>
-                  <a:srgbClr val="1E2761"/>
-                </a:solidFill>
-                <a:latin typeface="Calibri" pitchFamily="34" charset="0"/>
-                <a:ea typeface="Calibri" pitchFamily="34" charset="-122"/>
-                <a:cs typeface="Calibri" pitchFamily="34" charset="-120"/>
-              </a:rPr>
-              <a:t>A liest eine Person allein, B, C und D je ein Tandem.</a:t>
-            </a:r>
-            <a:endParaRPr lang="en-US" sz="1500" dirty="0"/>
-          </a:p>
-        </p:txBody>
-      </p:sp>
-      <p:sp>
-        <p:nvSpPr>
-          <p:cNvPr id="27" name="Shape 25"/>
+              <a:rPr lang="en-US" sz="1300" dirty="0">
+                <a:solidFill>
+                  <a:srgbClr val="5B6B8C"/>
+                </a:solidFill>
+                <a:latin typeface="Calibri" pitchFamily="34" charset="0"/>
+                <a:ea typeface="Calibri" pitchFamily="34" charset="-122"/>
+                <a:cs typeface="Calibri" pitchFamily="34" charset="-120"/>
+              </a:rPr>
+              <a:t>4 Min.</a:t>
+            </a:r>
+            <a:endParaRPr lang="en-US" sz="1300" dirty="0"/>
+          </a:p>
+        </p:txBody>
+      </p:sp>
+      <p:sp>
+        <p:nvSpPr>
+          <p:cNvPr id="16" name="Shape 14"/>
           <p:cNvSpPr/>
           <p:nvPr/>
         </p:nvSpPr>
         <p:spPr>
           <a:xfrm>
-            <a:off x="4297680" y="3520440"/>
-            <a:ext cx="3566160" cy="1828800"/>
+            <a:off x="3364992" y="1783080"/>
+            <a:ext cx="2651760" cy="1828800"/>
           </a:xfrm>
           <a:prstGeom prst="roundRect">
             <a:avLst>
@@ -8309,65 +8470,119 @@
             </a:avLst>
           </a:prstGeom>
           <a:solidFill>
-            <a:srgbClr val="FFFFFF"/>
+            <a:srgbClr val="F4F7FD"/>
           </a:solidFill>
-          <a:ln w="15240">
-            <a:solidFill>
-              <a:srgbClr val="B9C6E8"/>
-            </a:solidFill>
-            <a:prstDash val="solid"/>
-          </a:ln>
-        </p:spPr>
-      </p:sp>
-      <p:sp>
-        <p:nvSpPr>
-          <p:cNvPr id="28" name="Text 26"/>
-          <p:cNvSpPr txBox="1"/>
-          <p:nvPr/>
-        </p:nvSpPr>
-        <p:spPr>
-          <a:xfrm>
-            <a:off x="4526280" y="3657600"/>
-            <a:ext cx="914400" cy="457200"/>
-          </a:xfrm>
-          <a:prstGeom prst="rect">
-            <a:avLst/>
-          </a:prstGeom>
-          <a:noFill/>
-          <a:ln/>
-        </p:spPr>
-        <p:txBody>
-          <a:bodyPr wrap="square" lIns="0" tIns="0" rIns="0" bIns="0" rtlCol="0" anchor="t"/>
-          <a:lstStyle/>
-          <a:p>
-            <a:pPr indent="0" marL="0">
-              <a:buNone/>
-            </a:pPr>
-            <a:r>
-              <a:rPr lang="en-US" sz="2400" b="1" dirty="0">
-                <a:solidFill>
-                  <a:srgbClr val="D9534F"/>
+          <a:ln/>
+        </p:spPr>
+      </p:sp>
+      <p:sp>
+        <p:nvSpPr>
+          <p:cNvPr id="17" name="Shape 15"/>
+          <p:cNvSpPr/>
+          <p:nvPr/>
+        </p:nvSpPr>
+        <p:spPr>
+          <a:xfrm>
+            <a:off x="3593592" y="1938528"/>
+            <a:ext cx="566928" cy="566928"/>
+          </a:xfrm>
+          <a:prstGeom prst="ellipse">
+            <a:avLst/>
+          </a:prstGeom>
+          <a:solidFill>
+            <a:srgbClr val="2E9E6B"/>
+          </a:solidFill>
+          <a:ln/>
+        </p:spPr>
+      </p:sp>
+      <p:sp>
+        <p:nvSpPr>
+          <p:cNvPr id="18" name="Text 16"/>
+          <p:cNvSpPr txBox="1"/>
+          <p:nvPr/>
+        </p:nvSpPr>
+        <p:spPr>
+          <a:xfrm>
+            <a:off x="3593592" y="1938528"/>
+            <a:ext cx="566928" cy="566928"/>
+          </a:xfrm>
+          <a:prstGeom prst="rect">
+            <a:avLst/>
+          </a:prstGeom>
+          <a:noFill/>
+          <a:ln/>
+        </p:spPr>
+        <p:txBody>
+          <a:bodyPr wrap="square" lIns="0" tIns="0" rIns="0" bIns="0" rtlCol="0" anchor="ctr"/>
+          <a:lstStyle/>
+          <a:p>
+            <a:pPr algn="ctr" indent="0" marL="0">
+              <a:buNone/>
+            </a:pPr>
+            <a:r>
+              <a:rPr lang="en-US" sz="2200" b="1" dirty="0">
+                <a:solidFill>
+                  <a:srgbClr val="FFFFFF"/>
+                </a:solidFill>
+                <a:latin typeface="Calibri" pitchFamily="34" charset="0"/>
+                <a:ea typeface="Calibri" pitchFamily="34" charset="-122"/>
+                <a:cs typeface="Calibri" pitchFamily="34" charset="-120"/>
+              </a:rPr>
+              <a:t>B</a:t>
+            </a:r>
+            <a:endParaRPr lang="en-US" sz="2200" dirty="0"/>
+          </a:p>
+        </p:txBody>
+      </p:sp>
+      <p:sp>
+        <p:nvSpPr>
+          <p:cNvPr id="19" name="Text 17"/>
+          <p:cNvSpPr txBox="1"/>
+          <p:nvPr/>
+        </p:nvSpPr>
+        <p:spPr>
+          <a:xfrm>
+            <a:off x="4233672" y="1938528"/>
+            <a:ext cx="1737360" cy="566928"/>
+          </a:xfrm>
+          <a:prstGeom prst="rect">
+            <a:avLst/>
+          </a:prstGeom>
+          <a:noFill/>
+          <a:ln/>
+        </p:spPr>
+        <p:txBody>
+          <a:bodyPr wrap="square" lIns="0" tIns="0" rIns="0" bIns="0" rtlCol="0" anchor="ctr"/>
+          <a:lstStyle/>
+          <a:p>
+            <a:pPr indent="0" marL="0">
+              <a:buNone/>
+            </a:pPr>
+            <a:r>
+              <a:rPr lang="en-US" sz="1300" b="1" dirty="0">
+                <a:solidFill>
+                  <a:srgbClr val="2E9E6B"/>
                 </a:solidFill>
                 <a:latin typeface="Cambria" pitchFamily="34" charset="0"/>
                 <a:ea typeface="Cambria" pitchFamily="34" charset="-122"/>
                 <a:cs typeface="Cambria" pitchFamily="34" charset="-120"/>
               </a:rPr>
-              <a:t>7'</a:t>
-            </a:r>
-            <a:endParaRPr lang="en-US" sz="2400" dirty="0"/>
-          </a:p>
-        </p:txBody>
-      </p:sp>
-      <p:sp>
-        <p:nvSpPr>
-          <p:cNvPr id="29" name="Text 27"/>
-          <p:cNvSpPr txBox="1"/>
-          <p:nvPr/>
-        </p:nvSpPr>
-        <p:spPr>
-          <a:xfrm>
-            <a:off x="5394960" y="3703320"/>
-            <a:ext cx="2286000" cy="411480"/>
+              <a:t>Empathie</a:t>
+            </a:r>
+            <a:endParaRPr lang="en-US" sz="1300" dirty="0"/>
+          </a:p>
+        </p:txBody>
+      </p:sp>
+      <p:sp>
+        <p:nvSpPr>
+          <p:cNvPr id="20" name="Text 18"/>
+          <p:cNvSpPr txBox="1"/>
+          <p:nvPr/>
+        </p:nvSpPr>
+        <p:spPr>
+          <a:xfrm>
+            <a:off x="3593592" y="2697480"/>
+            <a:ext cx="2194560" cy="365760"/>
           </a:xfrm>
           <a:prstGeom prst="rect">
             <a:avLst/>
@@ -8383,30 +8598,30 @@
               <a:buNone/>
             </a:pPr>
             <a:r>
-              <a:rPr lang="en-US" sz="1900" b="1" dirty="0">
+              <a:rPr lang="en-US" sz="1600" b="1" dirty="0">
                 <a:solidFill>
                   <a:srgbClr val="1E2761"/>
                 </a:solidFill>
-                <a:latin typeface="Cambria" pitchFamily="34" charset="0"/>
-                <a:ea typeface="Cambria" pitchFamily="34" charset="-122"/>
-                <a:cs typeface="Cambria" pitchFamily="34" charset="-120"/>
-              </a:rPr>
-              <a:t>Erklären</a:t>
-            </a:r>
-            <a:endParaRPr lang="en-US" sz="1900" dirty="0"/>
-          </a:p>
-        </p:txBody>
-      </p:sp>
-      <p:sp>
-        <p:nvSpPr>
-          <p:cNvPr id="30" name="Text 28"/>
-          <p:cNvSpPr txBox="1"/>
-          <p:nvPr/>
-        </p:nvSpPr>
-        <p:spPr>
-          <a:xfrm>
-            <a:off x="4526280" y="4206240"/>
-            <a:ext cx="3154680" cy="1097280"/>
+                <a:latin typeface="Calibri" pitchFamily="34" charset="0"/>
+                <a:ea typeface="Calibri" pitchFamily="34" charset="-122"/>
+                <a:cs typeface="Calibri" pitchFamily="34" charset="-120"/>
+              </a:rPr>
+              <a:t>→ Zeile 4 umschreiben</a:t>
+            </a:r>
+            <a:endParaRPr lang="en-US" sz="1600" dirty="0"/>
+          </a:p>
+        </p:txBody>
+      </p:sp>
+      <p:sp>
+        <p:nvSpPr>
+          <p:cNvPr id="21" name="Text 19"/>
+          <p:cNvSpPr txBox="1"/>
+          <p:nvPr/>
+        </p:nvSpPr>
+        <p:spPr>
+          <a:xfrm>
+            <a:off x="3593592" y="3108960"/>
+            <a:ext cx="2194560" cy="320040"/>
           </a:xfrm>
           <a:prstGeom prst="rect">
             <a:avLst/>
@@ -8422,30 +8637,30 @@
               <a:buNone/>
             </a:pPr>
             <a:r>
-              <a:rPr lang="en-US" sz="1500" dirty="0">
-                <a:solidFill>
-                  <a:srgbClr val="1E2761"/>
-                </a:solidFill>
-                <a:latin typeface="Calibri" pitchFamily="34" charset="0"/>
-                <a:ea typeface="Calibri" pitchFamily="34" charset="-122"/>
-                <a:cs typeface="Calibri" pitchFamily="34" charset="-120"/>
-              </a:rPr>
-              <a:t>Reihum: jede Strategie in höchstens 90 Sekunden – mit Beispiel.</a:t>
-            </a:r>
-            <a:endParaRPr lang="en-US" sz="1500" dirty="0"/>
-          </a:p>
-        </p:txBody>
-      </p:sp>
-      <p:sp>
-        <p:nvSpPr>
-          <p:cNvPr id="31" name="Shape 29"/>
+              <a:rPr lang="en-US" sz="1300" dirty="0">
+                <a:solidFill>
+                  <a:srgbClr val="5B6B8C"/>
+                </a:solidFill>
+                <a:latin typeface="Calibri" pitchFamily="34" charset="0"/>
+                <a:ea typeface="Calibri" pitchFamily="34" charset="-122"/>
+                <a:cs typeface="Calibri" pitchFamily="34" charset="-120"/>
+              </a:rPr>
+              <a:t>4 Min.</a:t>
+            </a:r>
+            <a:endParaRPr lang="en-US" sz="1300" dirty="0"/>
+          </a:p>
+        </p:txBody>
+      </p:sp>
+      <p:sp>
+        <p:nvSpPr>
+          <p:cNvPr id="22" name="Shape 20"/>
           <p:cNvSpPr/>
           <p:nvPr/>
         </p:nvSpPr>
         <p:spPr>
           <a:xfrm>
-            <a:off x="8046720" y="3520440"/>
-            <a:ext cx="3566160" cy="1828800"/>
+            <a:off x="6181344" y="1783080"/>
+            <a:ext cx="2651760" cy="1828800"/>
           </a:xfrm>
           <a:prstGeom prst="roundRect">
             <a:avLst>
@@ -8453,65 +8668,119 @@
             </a:avLst>
           </a:prstGeom>
           <a:solidFill>
-            <a:srgbClr val="FFFFFF"/>
+            <a:srgbClr val="F4F7FD"/>
           </a:solidFill>
-          <a:ln w="15240">
-            <a:solidFill>
-              <a:srgbClr val="B9C6E8"/>
-            </a:solidFill>
-            <a:prstDash val="solid"/>
-          </a:ln>
-        </p:spPr>
-      </p:sp>
-      <p:sp>
-        <p:nvSpPr>
-          <p:cNvPr id="32" name="Text 30"/>
-          <p:cNvSpPr txBox="1"/>
-          <p:nvPr/>
-        </p:nvSpPr>
-        <p:spPr>
-          <a:xfrm>
-            <a:off x="8275320" y="3657600"/>
-            <a:ext cx="914400" cy="457200"/>
-          </a:xfrm>
-          <a:prstGeom prst="rect">
-            <a:avLst/>
-          </a:prstGeom>
-          <a:noFill/>
-          <a:ln/>
-        </p:spPr>
-        <p:txBody>
-          <a:bodyPr wrap="square" lIns="0" tIns="0" rIns="0" bIns="0" rtlCol="0" anchor="t"/>
-          <a:lstStyle/>
-          <a:p>
-            <a:pPr indent="0" marL="0">
-              <a:buNone/>
-            </a:pPr>
-            <a:r>
-              <a:rPr lang="en-US" sz="2400" b="1" dirty="0">
-                <a:solidFill>
-                  <a:srgbClr val="D9534F"/>
+          <a:ln/>
+        </p:spPr>
+      </p:sp>
+      <p:sp>
+        <p:nvSpPr>
+          <p:cNvPr id="23" name="Shape 21"/>
+          <p:cNvSpPr/>
+          <p:nvPr/>
+        </p:nvSpPr>
+        <p:spPr>
+          <a:xfrm>
+            <a:off x="6409944" y="1938528"/>
+            <a:ext cx="566928" cy="566928"/>
+          </a:xfrm>
+          <a:prstGeom prst="ellipse">
+            <a:avLst/>
+          </a:prstGeom>
+          <a:solidFill>
+            <a:srgbClr val="E8A33D"/>
+          </a:solidFill>
+          <a:ln/>
+        </p:spPr>
+      </p:sp>
+      <p:sp>
+        <p:nvSpPr>
+          <p:cNvPr id="24" name="Text 22"/>
+          <p:cNvSpPr txBox="1"/>
+          <p:nvPr/>
+        </p:nvSpPr>
+        <p:spPr>
+          <a:xfrm>
+            <a:off x="6409944" y="1938528"/>
+            <a:ext cx="566928" cy="566928"/>
+          </a:xfrm>
+          <a:prstGeom prst="rect">
+            <a:avLst/>
+          </a:prstGeom>
+          <a:noFill/>
+          <a:ln/>
+        </p:spPr>
+        <p:txBody>
+          <a:bodyPr wrap="square" lIns="0" tIns="0" rIns="0" bIns="0" rtlCol="0" anchor="ctr"/>
+          <a:lstStyle/>
+          <a:p>
+            <a:pPr algn="ctr" indent="0" marL="0">
+              <a:buNone/>
+            </a:pPr>
+            <a:r>
+              <a:rPr lang="en-US" sz="2200" b="1" dirty="0">
+                <a:solidFill>
+                  <a:srgbClr val="FFFFFF"/>
+                </a:solidFill>
+                <a:latin typeface="Calibri" pitchFamily="34" charset="0"/>
+                <a:ea typeface="Calibri" pitchFamily="34" charset="-122"/>
+                <a:cs typeface="Calibri" pitchFamily="34" charset="-120"/>
+              </a:rPr>
+              <a:t>C</a:t>
+            </a:r>
+            <a:endParaRPr lang="en-US" sz="2200" dirty="0"/>
+          </a:p>
+        </p:txBody>
+      </p:sp>
+      <p:sp>
+        <p:nvSpPr>
+          <p:cNvPr id="25" name="Text 23"/>
+          <p:cNvSpPr txBox="1"/>
+          <p:nvPr/>
+        </p:nvSpPr>
+        <p:spPr>
+          <a:xfrm>
+            <a:off x="7050024" y="1938528"/>
+            <a:ext cx="1737360" cy="566928"/>
+          </a:xfrm>
+          <a:prstGeom prst="rect">
+            <a:avLst/>
+          </a:prstGeom>
+          <a:noFill/>
+          <a:ln/>
+        </p:spPr>
+        <p:txBody>
+          <a:bodyPr wrap="square" lIns="0" tIns="0" rIns="0" bIns="0" rtlCol="0" anchor="ctr"/>
+          <a:lstStyle/>
+          <a:p>
+            <a:pPr indent="0" marL="0">
+              <a:buNone/>
+            </a:pPr>
+            <a:r>
+              <a:rPr lang="en-US" sz="1300" b="1" dirty="0">
+                <a:solidFill>
+                  <a:srgbClr val="E8A33D"/>
                 </a:solidFill>
                 <a:latin typeface="Cambria" pitchFamily="34" charset="0"/>
                 <a:ea typeface="Cambria" pitchFamily="34" charset="-122"/>
                 <a:cs typeface="Cambria" pitchFamily="34" charset="-120"/>
               </a:rPr>
-              <a:t>6'</a:t>
-            </a:r>
-            <a:endParaRPr lang="en-US" sz="2400" dirty="0"/>
-          </a:p>
-        </p:txBody>
-      </p:sp>
-      <p:sp>
-        <p:nvSpPr>
-          <p:cNvPr id="33" name="Text 31"/>
-          <p:cNvSpPr txBox="1"/>
-          <p:nvPr/>
-        </p:nvSpPr>
-        <p:spPr>
-          <a:xfrm>
-            <a:off x="9144000" y="3703320"/>
-            <a:ext cx="2286000" cy="411480"/>
+              <a:t>Wunsch &amp; Bitte</a:t>
+            </a:r>
+            <a:endParaRPr lang="en-US" sz="1300" dirty="0"/>
+          </a:p>
+        </p:txBody>
+      </p:sp>
+      <p:sp>
+        <p:nvSpPr>
+          <p:cNvPr id="26" name="Text 24"/>
+          <p:cNvSpPr txBox="1"/>
+          <p:nvPr/>
+        </p:nvSpPr>
+        <p:spPr>
+          <a:xfrm>
+            <a:off x="6409944" y="2697480"/>
+            <a:ext cx="2194560" cy="365760"/>
           </a:xfrm>
           <a:prstGeom prst="rect">
             <a:avLst/>
@@ -8527,17 +8796,254 @@
               <a:buNone/>
             </a:pPr>
             <a:r>
-              <a:rPr lang="en-US" sz="1900" b="1" dirty="0">
+              <a:rPr lang="en-US" sz="1600" b="1" dirty="0">
                 <a:solidFill>
                   <a:srgbClr val="1E2761"/>
+                </a:solidFill>
+                <a:latin typeface="Calibri" pitchFamily="34" charset="0"/>
+                <a:ea typeface="Calibri" pitchFamily="34" charset="-122"/>
+                <a:cs typeface="Calibri" pitchFamily="34" charset="-120"/>
+              </a:rPr>
+              <a:t>→ Zeile 5 umschreiben</a:t>
+            </a:r>
+            <a:endParaRPr lang="en-US" sz="1600" dirty="0"/>
+          </a:p>
+        </p:txBody>
+      </p:sp>
+      <p:sp>
+        <p:nvSpPr>
+          <p:cNvPr id="27" name="Text 25"/>
+          <p:cNvSpPr txBox="1"/>
+          <p:nvPr/>
+        </p:nvSpPr>
+        <p:spPr>
+          <a:xfrm>
+            <a:off x="6409944" y="3108960"/>
+            <a:ext cx="2194560" cy="320040"/>
+          </a:xfrm>
+          <a:prstGeom prst="rect">
+            <a:avLst/>
+          </a:prstGeom>
+          <a:noFill/>
+          <a:ln/>
+        </p:spPr>
+        <p:txBody>
+          <a:bodyPr wrap="square" lIns="0" tIns="0" rIns="0" bIns="0" rtlCol="0" anchor="t"/>
+          <a:lstStyle/>
+          <a:p>
+            <a:pPr indent="0" marL="0">
+              <a:buNone/>
+            </a:pPr>
+            <a:r>
+              <a:rPr lang="en-US" sz="1300" dirty="0">
+                <a:solidFill>
+                  <a:srgbClr val="5B6B8C"/>
+                </a:solidFill>
+                <a:latin typeface="Calibri" pitchFamily="34" charset="0"/>
+                <a:ea typeface="Calibri" pitchFamily="34" charset="-122"/>
+                <a:cs typeface="Calibri" pitchFamily="34" charset="-120"/>
+              </a:rPr>
+              <a:t>4 Min.</a:t>
+            </a:r>
+            <a:endParaRPr lang="en-US" sz="1300" dirty="0"/>
+          </a:p>
+        </p:txBody>
+      </p:sp>
+      <p:sp>
+        <p:nvSpPr>
+          <p:cNvPr id="28" name="Shape 26"/>
+          <p:cNvSpPr/>
+          <p:nvPr/>
+        </p:nvSpPr>
+        <p:spPr>
+          <a:xfrm>
+            <a:off x="8997696" y="1783080"/>
+            <a:ext cx="2651760" cy="1828800"/>
+          </a:xfrm>
+          <a:prstGeom prst="roundRect">
+            <a:avLst>
+              <a:gd name="adj" fmla="val 4000"/>
+            </a:avLst>
+          </a:prstGeom>
+          <a:solidFill>
+            <a:srgbClr val="F4F7FD"/>
+          </a:solidFill>
+          <a:ln/>
+        </p:spPr>
+      </p:sp>
+      <p:sp>
+        <p:nvSpPr>
+          <p:cNvPr id="29" name="Shape 27"/>
+          <p:cNvSpPr/>
+          <p:nvPr/>
+        </p:nvSpPr>
+        <p:spPr>
+          <a:xfrm>
+            <a:off x="9226296" y="1938528"/>
+            <a:ext cx="566928" cy="566928"/>
+          </a:xfrm>
+          <a:prstGeom prst="ellipse">
+            <a:avLst/>
+          </a:prstGeom>
+          <a:solidFill>
+            <a:srgbClr val="8E5BB5"/>
+          </a:solidFill>
+          <a:ln/>
+        </p:spPr>
+      </p:sp>
+      <p:sp>
+        <p:nvSpPr>
+          <p:cNvPr id="30" name="Text 28"/>
+          <p:cNvSpPr txBox="1"/>
+          <p:nvPr/>
+        </p:nvSpPr>
+        <p:spPr>
+          <a:xfrm>
+            <a:off x="9226296" y="1938528"/>
+            <a:ext cx="566928" cy="566928"/>
+          </a:xfrm>
+          <a:prstGeom prst="rect">
+            <a:avLst/>
+          </a:prstGeom>
+          <a:noFill/>
+          <a:ln/>
+        </p:spPr>
+        <p:txBody>
+          <a:bodyPr wrap="square" lIns="0" tIns="0" rIns="0" bIns="0" rtlCol="0" anchor="ctr"/>
+          <a:lstStyle/>
+          <a:p>
+            <a:pPr algn="ctr" indent="0" marL="0">
+              <a:buNone/>
+            </a:pPr>
+            <a:r>
+              <a:rPr lang="en-US" sz="2200" b="1" dirty="0">
+                <a:solidFill>
+                  <a:srgbClr val="FFFFFF"/>
+                </a:solidFill>
+                <a:latin typeface="Calibri" pitchFamily="34" charset="0"/>
+                <a:ea typeface="Calibri" pitchFamily="34" charset="-122"/>
+                <a:cs typeface="Calibri" pitchFamily="34" charset="-120"/>
+              </a:rPr>
+              <a:t>D</a:t>
+            </a:r>
+            <a:endParaRPr lang="en-US" sz="2200" dirty="0"/>
+          </a:p>
+        </p:txBody>
+      </p:sp>
+      <p:sp>
+        <p:nvSpPr>
+          <p:cNvPr id="31" name="Text 29"/>
+          <p:cNvSpPr txBox="1"/>
+          <p:nvPr/>
+        </p:nvSpPr>
+        <p:spPr>
+          <a:xfrm>
+            <a:off x="9866376" y="1938528"/>
+            <a:ext cx="1737360" cy="566928"/>
+          </a:xfrm>
+          <a:prstGeom prst="rect">
+            <a:avLst/>
+          </a:prstGeom>
+          <a:noFill/>
+          <a:ln/>
+        </p:spPr>
+        <p:txBody>
+          <a:bodyPr wrap="square" lIns="0" tIns="0" rIns="0" bIns="0" rtlCol="0" anchor="ctr"/>
+          <a:lstStyle/>
+          <a:p>
+            <a:pPr indent="0" marL="0">
+              <a:buNone/>
+            </a:pPr>
+            <a:r>
+              <a:rPr lang="en-US" sz="1300" b="1" dirty="0">
+                <a:solidFill>
+                  <a:srgbClr val="8E5BB5"/>
                 </a:solidFill>
                 <a:latin typeface="Cambria" pitchFamily="34" charset="0"/>
                 <a:ea typeface="Cambria" pitchFamily="34" charset="-122"/>
                 <a:cs typeface="Cambria" pitchFamily="34" charset="-120"/>
               </a:rPr>
-              <a:t>Umschreiben</a:t>
-            </a:r>
-            <a:endParaRPr lang="en-US" sz="1900" dirty="0"/>
+              <a:t>Metakommunikation</a:t>
+            </a:r>
+            <a:endParaRPr lang="en-US" sz="1300" dirty="0"/>
+          </a:p>
+        </p:txBody>
+      </p:sp>
+      <p:sp>
+        <p:nvSpPr>
+          <p:cNvPr id="32" name="Text 30"/>
+          <p:cNvSpPr txBox="1"/>
+          <p:nvPr/>
+        </p:nvSpPr>
+        <p:spPr>
+          <a:xfrm>
+            <a:off x="9226296" y="2697480"/>
+            <a:ext cx="2194560" cy="365760"/>
+          </a:xfrm>
+          <a:prstGeom prst="rect">
+            <a:avLst/>
+          </a:prstGeom>
+          <a:noFill/>
+          <a:ln/>
+        </p:spPr>
+        <p:txBody>
+          <a:bodyPr wrap="square" lIns="0" tIns="0" rIns="0" bIns="0" rtlCol="0" anchor="t"/>
+          <a:lstStyle/>
+          <a:p>
+            <a:pPr indent="0" marL="0">
+              <a:buNone/>
+            </a:pPr>
+            <a:r>
+              <a:rPr lang="en-US" sz="1600" b="1" dirty="0">
+                <a:solidFill>
+                  <a:srgbClr val="1E2761"/>
+                </a:solidFill>
+                <a:latin typeface="Calibri" pitchFamily="34" charset="0"/>
+                <a:ea typeface="Calibri" pitchFamily="34" charset="-122"/>
+                <a:cs typeface="Calibri" pitchFamily="34" charset="-120"/>
+              </a:rPr>
+              <a:t>→ Zeile 7 umschreiben</a:t>
+            </a:r>
+            <a:endParaRPr lang="en-US" sz="1600" dirty="0"/>
+          </a:p>
+        </p:txBody>
+      </p:sp>
+      <p:sp>
+        <p:nvSpPr>
+          <p:cNvPr id="33" name="Text 31"/>
+          <p:cNvSpPr txBox="1"/>
+          <p:nvPr/>
+        </p:nvSpPr>
+        <p:spPr>
+          <a:xfrm>
+            <a:off x="9226296" y="3108960"/>
+            <a:ext cx="2194560" cy="320040"/>
+          </a:xfrm>
+          <a:prstGeom prst="rect">
+            <a:avLst/>
+          </a:prstGeom>
+          <a:noFill/>
+          <a:ln/>
+        </p:spPr>
+        <p:txBody>
+          <a:bodyPr wrap="square" lIns="0" tIns="0" rIns="0" bIns="0" rtlCol="0" anchor="t"/>
+          <a:lstStyle/>
+          <a:p>
+            <a:pPr indent="0" marL="0">
+              <a:buNone/>
+            </a:pPr>
+            <a:r>
+              <a:rPr lang="en-US" sz="1300" dirty="0">
+                <a:solidFill>
+                  <a:srgbClr val="5B6B8C"/>
+                </a:solidFill>
+                <a:latin typeface="Calibri" pitchFamily="34" charset="0"/>
+                <a:ea typeface="Calibri" pitchFamily="34" charset="-122"/>
+                <a:cs typeface="Calibri" pitchFamily="34" charset="-120"/>
+              </a:rPr>
+              <a:t>4 Min.</a:t>
+            </a:r>
+            <a:endParaRPr lang="en-US" sz="1300" dirty="0"/>
           </a:p>
         </p:txBody>
       </p:sp>
@@ -8549,8 +9055,8 @@
         </p:nvSpPr>
         <p:spPr>
           <a:xfrm>
-            <a:off x="8275320" y="4206240"/>
-            <a:ext cx="3154680" cy="1097280"/>
+            <a:off x="548640" y="3886200"/>
+            <a:ext cx="4572000" cy="365760"/>
           </a:xfrm>
           <a:prstGeom prst="rect">
             <a:avLst/>
@@ -8566,17 +9072,17 @@
               <a:buNone/>
             </a:pPr>
             <a:r>
-              <a:rPr lang="en-US" sz="1500" dirty="0">
+              <a:rPr lang="en-US" sz="1800" b="1" dirty="0">
                 <a:solidFill>
                   <a:srgbClr val="1E2761"/>
                 </a:solidFill>
-                <a:latin typeface="Calibri" pitchFamily="34" charset="0"/>
-                <a:ea typeface="Calibri" pitchFamily="34" charset="-122"/>
-                <a:cs typeface="Calibri" pitchFamily="34" charset="-120"/>
-              </a:rPr>
-              <a:t>Dialog ab Zeile 3 gemeinsam neu schreiben, alle schreiben mit. Checkliste prüfen.</a:t>
-            </a:r>
-            <a:endParaRPr lang="en-US" sz="1500" dirty="0"/>
+                <a:latin typeface="Cambria" pitchFamily="34" charset="0"/>
+                <a:ea typeface="Cambria" pitchFamily="34" charset="-122"/>
+                <a:cs typeface="Cambria" pitchFamily="34" charset="-120"/>
+              </a:rPr>
+              <a:t>Bei jeder Technik</a:t>
+            </a:r>
+            <a:endParaRPr lang="en-US" sz="1800" dirty="0"/>
           </a:p>
         </p:txBody>
       </p:sp>
@@ -8588,13 +9094,11 @@
         </p:nvSpPr>
         <p:spPr>
           <a:xfrm>
-            <a:off x="548640" y="5577840"/>
-            <a:ext cx="11109960" cy="548640"/>
-          </a:xfrm>
-          <a:prstGeom prst="roundRect">
-            <a:avLst>
-              <a:gd name="adj" fmla="val 13333"/>
-            </a:avLst>
+            <a:off x="548640" y="4389120"/>
+            <a:ext cx="384048" cy="384048"/>
+          </a:xfrm>
+          <a:prstGeom prst="ellipse">
+            <a:avLst/>
           </a:prstGeom>
           <a:solidFill>
             <a:srgbClr val="1E2761"/>
@@ -8610,8 +9114,8 @@
         </p:nvSpPr>
         <p:spPr>
           <a:xfrm>
-            <a:off x="822960" y="5577840"/>
-            <a:ext cx="10607040" cy="548640"/>
+            <a:off x="548640" y="4389120"/>
+            <a:ext cx="384048" cy="384048"/>
           </a:xfrm>
           <a:prstGeom prst="rect">
             <a:avLst/>
@@ -8623,11 +9127,11 @@
           <a:bodyPr wrap="square" lIns="0" tIns="0" rIns="0" bIns="0" rtlCol="0" anchor="ctr"/>
           <a:lstStyle/>
           <a:p>
-            <a:pPr indent="0" marL="0">
-              <a:buNone/>
-            </a:pPr>
-            <a:r>
-              <a:rPr lang="en-US" sz="1500" b="1" dirty="0">
+            <a:pPr algn="ctr" indent="0" marL="0">
+              <a:buNone/>
+            </a:pPr>
+            <a:r>
+              <a:rPr lang="en-US" sz="1400" b="1" dirty="0">
                 <a:solidFill>
                   <a:srgbClr val="FFFFFF"/>
                 </a:solidFill>
@@ -8635,9 +9139,422 @@
                 <a:ea typeface="Calibri" pitchFamily="34" charset="-122"/>
                 <a:cs typeface="Calibri" pitchFamily="34" charset="-120"/>
               </a:rPr>
-              <a:t>Danach: Die Protokoll-Person liest eure Version im Unterrichtsgespräch vor.</a:t>
-            </a:r>
-            <a:endParaRPr lang="en-US" sz="1500" dirty="0"/>
+              <a:t>1</a:t>
+            </a:r>
+            <a:endParaRPr lang="en-US" sz="1400" dirty="0"/>
+          </a:p>
+        </p:txBody>
+      </p:sp>
+      <p:sp>
+        <p:nvSpPr>
+          <p:cNvPr id="37" name="Text 35"/>
+          <p:cNvSpPr txBox="1"/>
+          <p:nvPr/>
+        </p:nvSpPr>
+        <p:spPr>
+          <a:xfrm>
+            <a:off x="1051560" y="4370832"/>
+            <a:ext cx="3017520" cy="411480"/>
+          </a:xfrm>
+          <a:prstGeom prst="rect">
+            <a:avLst/>
+          </a:prstGeom>
+          <a:noFill/>
+          <a:ln/>
+        </p:spPr>
+        <p:txBody>
+          <a:bodyPr wrap="square" lIns="0" tIns="0" rIns="0" bIns="0" rtlCol="0" anchor="t"/>
+          <a:lstStyle/>
+          <a:p>
+            <a:pPr indent="0" marL="0">
+              <a:buNone/>
+            </a:pPr>
+            <a:r>
+              <a:rPr lang="en-US" sz="1800" b="1" dirty="0">
+                <a:solidFill>
+                  <a:srgbClr val="1E2761"/>
+                </a:solidFill>
+                <a:latin typeface="Cambria" pitchFamily="34" charset="0"/>
+                <a:ea typeface="Cambria" pitchFamily="34" charset="-122"/>
+                <a:cs typeface="Cambria" pitchFamily="34" charset="-120"/>
+              </a:rPr>
+              <a:t>Lesen</a:t>
+            </a:r>
+            <a:endParaRPr lang="en-US" sz="1800" dirty="0"/>
+          </a:p>
+        </p:txBody>
+      </p:sp>
+      <p:sp>
+        <p:nvSpPr>
+          <p:cNvPr id="38" name="Text 36"/>
+          <p:cNvSpPr txBox="1"/>
+          <p:nvPr/>
+        </p:nvSpPr>
+        <p:spPr>
+          <a:xfrm>
+            <a:off x="1051560" y="4754880"/>
+            <a:ext cx="3017520" cy="411480"/>
+          </a:xfrm>
+          <a:prstGeom prst="rect">
+            <a:avLst/>
+          </a:prstGeom>
+          <a:noFill/>
+          <a:ln/>
+        </p:spPr>
+        <p:txBody>
+          <a:bodyPr wrap="square" lIns="0" tIns="0" rIns="0" bIns="0" rtlCol="0" anchor="t"/>
+          <a:lstStyle/>
+          <a:p>
+            <a:pPr indent="0" marL="0">
+              <a:buNone/>
+            </a:pPr>
+            <a:r>
+              <a:rPr lang="en-US" sz="1400" dirty="0">
+                <a:solidFill>
+                  <a:srgbClr val="5B6B8C"/>
+                </a:solidFill>
+                <a:latin typeface="Calibri" pitchFamily="34" charset="0"/>
+                <a:ea typeface="Calibri" pitchFamily="34" charset="-122"/>
+                <a:cs typeface="Calibri" pitchFamily="34" charset="-120"/>
+              </a:rPr>
+              <a:t>Formel, So geht’s, WG-Beispiel</a:t>
+            </a:r>
+            <a:endParaRPr lang="en-US" sz="1400" dirty="0"/>
+          </a:p>
+        </p:txBody>
+      </p:sp>
+      <p:sp>
+        <p:nvSpPr>
+          <p:cNvPr id="39" name="Shape 37"/>
+          <p:cNvSpPr/>
+          <p:nvPr/>
+        </p:nvSpPr>
+        <p:spPr>
+          <a:xfrm>
+            <a:off x="4297680" y="4389120"/>
+            <a:ext cx="384048" cy="384048"/>
+          </a:xfrm>
+          <a:prstGeom prst="ellipse">
+            <a:avLst/>
+          </a:prstGeom>
+          <a:solidFill>
+            <a:srgbClr val="1E2761"/>
+          </a:solidFill>
+          <a:ln/>
+        </p:spPr>
+      </p:sp>
+      <p:sp>
+        <p:nvSpPr>
+          <p:cNvPr id="40" name="Text 38"/>
+          <p:cNvSpPr txBox="1"/>
+          <p:nvPr/>
+        </p:nvSpPr>
+        <p:spPr>
+          <a:xfrm>
+            <a:off x="4297680" y="4389120"/>
+            <a:ext cx="384048" cy="384048"/>
+          </a:xfrm>
+          <a:prstGeom prst="rect">
+            <a:avLst/>
+          </a:prstGeom>
+          <a:noFill/>
+          <a:ln/>
+        </p:spPr>
+        <p:txBody>
+          <a:bodyPr wrap="square" lIns="0" tIns="0" rIns="0" bIns="0" rtlCol="0" anchor="ctr"/>
+          <a:lstStyle/>
+          <a:p>
+            <a:pPr algn="ctr" indent="0" marL="0">
+              <a:buNone/>
+            </a:pPr>
+            <a:r>
+              <a:rPr lang="en-US" sz="1400" b="1" dirty="0">
+                <a:solidFill>
+                  <a:srgbClr val="FFFFFF"/>
+                </a:solidFill>
+                <a:latin typeface="Calibri" pitchFamily="34" charset="0"/>
+                <a:ea typeface="Calibri" pitchFamily="34" charset="-122"/>
+                <a:cs typeface="Calibri" pitchFamily="34" charset="-120"/>
+              </a:rPr>
+              <a:t>2</a:t>
+            </a:r>
+            <a:endParaRPr lang="en-US" sz="1400" dirty="0"/>
+          </a:p>
+        </p:txBody>
+      </p:sp>
+      <p:sp>
+        <p:nvSpPr>
+          <p:cNvPr id="41" name="Text 39"/>
+          <p:cNvSpPr txBox="1"/>
+          <p:nvPr/>
+        </p:nvSpPr>
+        <p:spPr>
+          <a:xfrm>
+            <a:off x="4800600" y="4370832"/>
+            <a:ext cx="3017520" cy="411480"/>
+          </a:xfrm>
+          <a:prstGeom prst="rect">
+            <a:avLst/>
+          </a:prstGeom>
+          <a:noFill/>
+          <a:ln/>
+        </p:spPr>
+        <p:txBody>
+          <a:bodyPr wrap="square" lIns="0" tIns="0" rIns="0" bIns="0" rtlCol="0" anchor="t"/>
+          <a:lstStyle/>
+          <a:p>
+            <a:pPr indent="0" marL="0">
+              <a:buNone/>
+            </a:pPr>
+            <a:r>
+              <a:rPr lang="en-US" sz="1800" b="1" dirty="0">
+                <a:solidFill>
+                  <a:srgbClr val="1E2761"/>
+                </a:solidFill>
+                <a:latin typeface="Cambria" pitchFamily="34" charset="0"/>
+                <a:ea typeface="Cambria" pitchFamily="34" charset="-122"/>
+                <a:cs typeface="Cambria" pitchFamily="34" charset="-120"/>
+              </a:rPr>
+              <a:t>Anwenden</a:t>
+            </a:r>
+            <a:endParaRPr lang="en-US" sz="1800" dirty="0"/>
+          </a:p>
+        </p:txBody>
+      </p:sp>
+      <p:sp>
+        <p:nvSpPr>
+          <p:cNvPr id="42" name="Text 40"/>
+          <p:cNvSpPr txBox="1"/>
+          <p:nvPr/>
+        </p:nvSpPr>
+        <p:spPr>
+          <a:xfrm>
+            <a:off x="4800600" y="4754880"/>
+            <a:ext cx="3017520" cy="411480"/>
+          </a:xfrm>
+          <a:prstGeom prst="rect">
+            <a:avLst/>
+          </a:prstGeom>
+          <a:noFill/>
+          <a:ln/>
+        </p:spPr>
+        <p:txBody>
+          <a:bodyPr wrap="square" lIns="0" tIns="0" rIns="0" bIns="0" rtlCol="0" anchor="t"/>
+          <a:lstStyle/>
+          <a:p>
+            <a:pPr indent="0" marL="0">
+              <a:buNone/>
+            </a:pPr>
+            <a:r>
+              <a:rPr lang="en-US" sz="1400" dirty="0">
+                <a:solidFill>
+                  <a:srgbClr val="5B6B8C"/>
+                </a:solidFill>
+                <a:latin typeface="Calibri" pitchFamily="34" charset="0"/>
+                <a:ea typeface="Calibri" pitchFamily="34" charset="-122"/>
+                <a:cs typeface="Calibri" pitchFamily="34" charset="-120"/>
+              </a:rPr>
+              <a:t>den Kipppunkt aus M1 umschreiben</a:t>
+            </a:r>
+            <a:endParaRPr lang="en-US" sz="1400" dirty="0"/>
+          </a:p>
+        </p:txBody>
+      </p:sp>
+      <p:sp>
+        <p:nvSpPr>
+          <p:cNvPr id="43" name="Shape 41"/>
+          <p:cNvSpPr/>
+          <p:nvPr/>
+        </p:nvSpPr>
+        <p:spPr>
+          <a:xfrm>
+            <a:off x="8046720" y="4389120"/>
+            <a:ext cx="384048" cy="384048"/>
+          </a:xfrm>
+          <a:prstGeom prst="ellipse">
+            <a:avLst/>
+          </a:prstGeom>
+          <a:solidFill>
+            <a:srgbClr val="1E2761"/>
+          </a:solidFill>
+          <a:ln/>
+        </p:spPr>
+      </p:sp>
+      <p:sp>
+        <p:nvSpPr>
+          <p:cNvPr id="44" name="Text 42"/>
+          <p:cNvSpPr txBox="1"/>
+          <p:nvPr/>
+        </p:nvSpPr>
+        <p:spPr>
+          <a:xfrm>
+            <a:off x="8046720" y="4389120"/>
+            <a:ext cx="384048" cy="384048"/>
+          </a:xfrm>
+          <a:prstGeom prst="rect">
+            <a:avLst/>
+          </a:prstGeom>
+          <a:noFill/>
+          <a:ln/>
+        </p:spPr>
+        <p:txBody>
+          <a:bodyPr wrap="square" lIns="0" tIns="0" rIns="0" bIns="0" rtlCol="0" anchor="ctr"/>
+          <a:lstStyle/>
+          <a:p>
+            <a:pPr algn="ctr" indent="0" marL="0">
+              <a:buNone/>
+            </a:pPr>
+            <a:r>
+              <a:rPr lang="en-US" sz="1400" b="1" dirty="0">
+                <a:solidFill>
+                  <a:srgbClr val="FFFFFF"/>
+                </a:solidFill>
+                <a:latin typeface="Calibri" pitchFamily="34" charset="0"/>
+                <a:ea typeface="Calibri" pitchFamily="34" charset="-122"/>
+                <a:cs typeface="Calibri" pitchFamily="34" charset="-120"/>
+              </a:rPr>
+              <a:t>3</a:t>
+            </a:r>
+            <a:endParaRPr lang="en-US" sz="1400" dirty="0"/>
+          </a:p>
+        </p:txBody>
+      </p:sp>
+      <p:sp>
+        <p:nvSpPr>
+          <p:cNvPr id="45" name="Text 43"/>
+          <p:cNvSpPr txBox="1"/>
+          <p:nvPr/>
+        </p:nvSpPr>
+        <p:spPr>
+          <a:xfrm>
+            <a:off x="8549640" y="4370832"/>
+            <a:ext cx="3017520" cy="411480"/>
+          </a:xfrm>
+          <a:prstGeom prst="rect">
+            <a:avLst/>
+          </a:prstGeom>
+          <a:noFill/>
+          <a:ln/>
+        </p:spPr>
+        <p:txBody>
+          <a:bodyPr wrap="square" lIns="0" tIns="0" rIns="0" bIns="0" rtlCol="0" anchor="t"/>
+          <a:lstStyle/>
+          <a:p>
+            <a:pPr indent="0" marL="0">
+              <a:buNone/>
+            </a:pPr>
+            <a:r>
+              <a:rPr lang="en-US" sz="1800" b="1" dirty="0">
+                <a:solidFill>
+                  <a:srgbClr val="1E2761"/>
+                </a:solidFill>
+                <a:latin typeface="Cambria" pitchFamily="34" charset="0"/>
+                <a:ea typeface="Cambria" pitchFamily="34" charset="-122"/>
+                <a:cs typeface="Cambria" pitchFamily="34" charset="-120"/>
+              </a:rPr>
+              <a:t>Prüfen</a:t>
+            </a:r>
+            <a:endParaRPr lang="en-US" sz="1800" dirty="0"/>
+          </a:p>
+        </p:txBody>
+      </p:sp>
+      <p:sp>
+        <p:nvSpPr>
+          <p:cNvPr id="46" name="Text 44"/>
+          <p:cNvSpPr txBox="1"/>
+          <p:nvPr/>
+        </p:nvSpPr>
+        <p:spPr>
+          <a:xfrm>
+            <a:off x="8549640" y="4754880"/>
+            <a:ext cx="3017520" cy="411480"/>
+          </a:xfrm>
+          <a:prstGeom prst="rect">
+            <a:avLst/>
+          </a:prstGeom>
+          <a:noFill/>
+          <a:ln/>
+        </p:spPr>
+        <p:txBody>
+          <a:bodyPr wrap="square" lIns="0" tIns="0" rIns="0" bIns="0" rtlCol="0" anchor="t"/>
+          <a:lstStyle/>
+          <a:p>
+            <a:pPr indent="0" marL="0">
+              <a:buNone/>
+            </a:pPr>
+            <a:r>
+              <a:rPr lang="en-US" sz="1400" dirty="0">
+                <a:solidFill>
+                  <a:srgbClr val="5B6B8C"/>
+                </a:solidFill>
+                <a:latin typeface="Calibri" pitchFamily="34" charset="0"/>
+                <a:ea typeface="Calibri" pitchFamily="34" charset="-122"/>
+                <a:cs typeface="Calibri" pitchFamily="34" charset="-120"/>
+              </a:rPr>
+              <a:t>Mini-Checkliste abhaken</a:t>
+            </a:r>
+            <a:endParaRPr lang="en-US" sz="1400" dirty="0"/>
+          </a:p>
+        </p:txBody>
+      </p:sp>
+      <p:sp>
+        <p:nvSpPr>
+          <p:cNvPr id="47" name="Shape 45"/>
+          <p:cNvSpPr/>
+          <p:nvPr/>
+        </p:nvSpPr>
+        <p:spPr>
+          <a:xfrm>
+            <a:off x="548640" y="5486400"/>
+            <a:ext cx="11109960" cy="594360"/>
+          </a:xfrm>
+          <a:prstGeom prst="roundRect">
+            <a:avLst>
+              <a:gd name="adj" fmla="val 12308"/>
+            </a:avLst>
+          </a:prstGeom>
+          <a:solidFill>
+            <a:srgbClr val="1E2761"/>
+          </a:solidFill>
+          <a:ln/>
+        </p:spPr>
+      </p:sp>
+      <p:sp>
+        <p:nvSpPr>
+          <p:cNvPr id="48" name="Text 46"/>
+          <p:cNvSpPr txBox="1"/>
+          <p:nvPr/>
+        </p:nvSpPr>
+        <p:spPr>
+          <a:xfrm>
+            <a:off x="822960" y="5486400"/>
+            <a:ext cx="10607040" cy="594360"/>
+          </a:xfrm>
+          <a:prstGeom prst="rect">
+            <a:avLst/>
+          </a:prstGeom>
+          <a:noFill/>
+          <a:ln/>
+        </p:spPr>
+        <p:txBody>
+          <a:bodyPr wrap="square" lIns="0" tIns="0" rIns="0" bIns="0" rtlCol="0" anchor="ctr"/>
+          <a:lstStyle/>
+          <a:p>
+            <a:pPr indent="0" marL="0">
+              <a:buNone/>
+            </a:pPr>
+            <a:r>
+              <a:rPr lang="en-US" sz="1600" b="1" dirty="0">
+                <a:solidFill>
+                  <a:srgbClr val="FFFFFF"/>
+                </a:solidFill>
+                <a:latin typeface="Calibri" pitchFamily="34" charset="0"/>
+                <a:ea typeface="Calibri" pitchFamily="34" charset="-122"/>
+                <a:cs typeface="Calibri" pitchFamily="34" charset="-120"/>
+              </a:rPr>
+              <a:t>Gong = nächste Technik.   Zum Schluss 2 Minuten: Vergleich mit dem Sitznachbarn.</a:t>
+            </a:r>
+            <a:endParaRPr lang="en-US" sz="1600" dirty="0"/>
           </a:p>
         </p:txBody>
       </p:sp>
@@ -8706,7 +9623,7 @@
                 <a:ea typeface="Calibri" pitchFamily="34" charset="-122"/>
                 <a:cs typeface="Calibri" pitchFamily="34" charset="-120"/>
               </a:rPr>
-              <a:t>SICHERUNG · VERGLEICH MIT EUREM MERKKASTEN</a:t>
+              <a:t>SICHERUNG · UNTERRICHTSGESPRÄCH 2</a:t>
             </a:r>
             <a:endParaRPr lang="en-US" sz="1200" dirty="0"/>
           </a:p>
@@ -8784,7 +9701,7 @@
                 <a:ea typeface="Calibri" pitchFamily="34" charset="-122"/>
                 <a:cs typeface="Calibri" pitchFamily="34" charset="-120"/>
               </a:rPr>
-              <a:t>Vier Strategien, um ein kippendes Gespräch zu retten</a:t>
+              <a:t>Vergleicht mit euren eigenen Lösungen auf S. 3–4</a:t>
             </a:r>
             <a:endParaRPr lang="en-US" sz="1400" dirty="0"/>
           </a:p>
@@ -10056,16 +10973,16 @@
         </p:nvSpPr>
         <p:spPr>
           <a:xfrm>
-            <a:off x="9966960" y="411480"/>
-            <a:ext cx="1691640" cy="914400"/>
+            <a:off x="9966960" y="685800"/>
+            <a:ext cx="1691640" cy="384048"/>
           </a:xfrm>
           <a:prstGeom prst="roundRect">
             <a:avLst>
-              <a:gd name="adj" fmla="val 8000"/>
+              <a:gd name="adj" fmla="val 50000"/>
             </a:avLst>
           </a:prstGeom>
           <a:solidFill>
-            <a:srgbClr val="1E2761"/>
+            <a:srgbClr val="5B6B8C"/>
           </a:solidFill>
           <a:ln/>
         </p:spPr>
@@ -10078,8 +10995,8 @@
         </p:nvSpPr>
         <p:spPr>
           <a:xfrm>
-            <a:off x="9966960" y="457200"/>
-            <a:ext cx="1691640" cy="502920"/>
+            <a:off x="9966960" y="685800"/>
+            <a:ext cx="1691640" cy="384048"/>
           </a:xfrm>
           <a:prstGeom prst="rect">
             <a:avLst/>
@@ -10095,54 +11012,15 @@
               <a:buNone/>
             </a:pPr>
             <a:r>
-              <a:rPr lang="en-US" sz="2600" b="1" dirty="0">
+              <a:rPr lang="en-US" sz="1200" b="1" dirty="0">
                 <a:solidFill>
                   <a:srgbClr val="FFFFFF"/>
                 </a:solidFill>
-                <a:latin typeface="Cambria" pitchFamily="34" charset="0"/>
-                <a:ea typeface="Cambria" pitchFamily="34" charset="-122"/>
-                <a:cs typeface="Cambria" pitchFamily="34" charset="-120"/>
-              </a:rPr>
-              <a:t>7 Min.</a:t>
-            </a:r>
-            <a:endParaRPr lang="en-US" sz="2600" dirty="0"/>
-          </a:p>
-        </p:txBody>
-      </p:sp>
-      <p:sp>
-        <p:nvSpPr>
-          <p:cNvPr id="9" name="Text 7"/>
-          <p:cNvSpPr txBox="1"/>
-          <p:nvPr/>
-        </p:nvSpPr>
-        <p:spPr>
-          <a:xfrm>
-            <a:off x="9966960" y="932688"/>
-            <a:ext cx="1691640" cy="320040"/>
-          </a:xfrm>
-          <a:prstGeom prst="rect">
-            <a:avLst/>
-          </a:prstGeom>
-          <a:noFill/>
-          <a:ln/>
-        </p:spPr>
-        <p:txBody>
-          <a:bodyPr wrap="square" lIns="0" tIns="0" rIns="0" bIns="0" rtlCol="0" anchor="ctr"/>
-          <a:lstStyle/>
-          <a:p>
-            <a:pPr algn="ctr" indent="0" marL="0">
-              <a:buNone/>
-            </a:pPr>
-            <a:r>
-              <a:rPr lang="en-US" sz="1200" dirty="0">
-                <a:solidFill>
-                  <a:srgbClr val="CADCFC"/>
-                </a:solidFill>
-                <a:latin typeface="Calibri" pitchFamily="34" charset="0"/>
-                <a:ea typeface="Calibri" pitchFamily="34" charset="-122"/>
-                <a:cs typeface="Calibri" pitchFamily="34" charset="-120"/>
-              </a:rPr>
-              <a:t>Plenum</a:t>
+                <a:latin typeface="Calibri" pitchFamily="34" charset="0"/>
+                <a:ea typeface="Calibri" pitchFamily="34" charset="-122"/>
+                <a:cs typeface="Calibri" pitchFamily="34" charset="-120"/>
+              </a:rPr>
+              <a:t>OPTIONAL</a:t>
             </a:r>
             <a:endParaRPr lang="en-US" sz="1200" dirty="0"/>
           </a:p>
@@ -10150,7 +11028,7 @@
       </p:sp>
       <p:sp>
         <p:nvSpPr>
-          <p:cNvPr id="10" name="Shape 8"/>
+          <p:cNvPr id="9" name="Shape 7"/>
           <p:cNvSpPr/>
           <p:nvPr/>
         </p:nvSpPr>
@@ -10172,7 +11050,7 @@
       </p:sp>
       <p:sp>
         <p:nvSpPr>
-          <p:cNvPr id="11" name="Text 9"/>
+          <p:cNvPr id="10" name="Text 8"/>
           <p:cNvSpPr txBox="1"/>
           <p:nvPr/>
         </p:nvSpPr>
@@ -10211,7 +11089,7 @@
       </p:sp>
       <p:sp>
         <p:nvSpPr>
-          <p:cNvPr id="12" name="Text 10"/>
+          <p:cNvPr id="11" name="Text 9"/>
           <p:cNvSpPr txBox="1"/>
           <p:nvPr/>
         </p:nvSpPr>
@@ -10250,7 +11128,7 @@
       </p:sp>
       <p:sp>
         <p:nvSpPr>
-          <p:cNvPr id="13" name="Shape 11"/>
+          <p:cNvPr id="12" name="Shape 10"/>
           <p:cNvSpPr/>
           <p:nvPr/>
         </p:nvSpPr>
@@ -10272,7 +11150,7 @@
       </p:sp>
       <p:sp>
         <p:nvSpPr>
-          <p:cNvPr id="14" name="Text 12"/>
+          <p:cNvPr id="13" name="Text 11"/>
           <p:cNvSpPr txBox="1"/>
           <p:nvPr/>
         </p:nvSpPr>
@@ -10311,7 +11189,7 @@
       </p:sp>
       <p:sp>
         <p:nvSpPr>
-          <p:cNvPr id="15" name="Shape 13"/>
+          <p:cNvPr id="14" name="Shape 12"/>
           <p:cNvSpPr/>
           <p:nvPr/>
         </p:nvSpPr>
@@ -10333,7 +11211,7 @@
       </p:sp>
       <p:sp>
         <p:nvSpPr>
-          <p:cNvPr id="16" name="Text 14"/>
+          <p:cNvPr id="15" name="Text 13"/>
           <p:cNvSpPr txBox="1"/>
           <p:nvPr/>
         </p:nvSpPr>
@@ -10372,7 +11250,7 @@
       </p:sp>
       <p:sp>
         <p:nvSpPr>
-          <p:cNvPr id="17" name="Text 15"/>
+          <p:cNvPr id="16" name="Text 14"/>
           <p:cNvSpPr txBox="1"/>
           <p:nvPr/>
         </p:nvSpPr>
@@ -10411,7 +11289,7 @@
       </p:sp>
       <p:sp>
         <p:nvSpPr>
-          <p:cNvPr id="18" name="Shape 16"/>
+          <p:cNvPr id="17" name="Shape 15"/>
           <p:cNvSpPr/>
           <p:nvPr/>
         </p:nvSpPr>
@@ -10433,7 +11311,7 @@
       </p:sp>
       <p:sp>
         <p:nvSpPr>
-          <p:cNvPr id="19" name="Text 17"/>
+          <p:cNvPr id="18" name="Text 16"/>
           <p:cNvSpPr txBox="1"/>
           <p:nvPr/>
         </p:nvSpPr>
@@ -10472,7 +11350,7 @@
       </p:sp>
       <p:sp>
         <p:nvSpPr>
-          <p:cNvPr id="20" name="Shape 18"/>
+          <p:cNvPr id="19" name="Shape 17"/>
           <p:cNvSpPr/>
           <p:nvPr/>
         </p:nvSpPr>
@@ -10494,7 +11372,7 @@
       </p:sp>
       <p:sp>
         <p:nvSpPr>
-          <p:cNvPr id="21" name="Text 19"/>
+          <p:cNvPr id="20" name="Text 18"/>
           <p:cNvSpPr txBox="1"/>
           <p:nvPr/>
         </p:nvSpPr>
@@ -10533,7 +11411,7 @@
       </p:sp>
       <p:sp>
         <p:nvSpPr>
-          <p:cNvPr id="22" name="Text 20"/>
+          <p:cNvPr id="21" name="Text 19"/>
           <p:cNvSpPr txBox="1"/>
           <p:nvPr/>
         </p:nvSpPr>
@@ -10572,7 +11450,7 @@
       </p:sp>
       <p:sp>
         <p:nvSpPr>
-          <p:cNvPr id="23" name="Shape 21"/>
+          <p:cNvPr id="22" name="Shape 20"/>
           <p:cNvSpPr/>
           <p:nvPr/>
         </p:nvSpPr>
@@ -10594,7 +11472,7 @@
       </p:sp>
       <p:sp>
         <p:nvSpPr>
-          <p:cNvPr id="24" name="Text 22"/>
+          <p:cNvPr id="23" name="Text 21"/>
           <p:cNvSpPr txBox="1"/>
           <p:nvPr/>
         </p:nvSpPr>
@@ -10633,7 +11511,7 @@
       </p:sp>
       <p:sp>
         <p:nvSpPr>
-          <p:cNvPr id="25" name="Shape 23"/>
+          <p:cNvPr id="24" name="Shape 22"/>
           <p:cNvSpPr/>
           <p:nvPr/>
         </p:nvSpPr>
@@ -10655,7 +11533,7 @@
       </p:sp>
       <p:sp>
         <p:nvSpPr>
-          <p:cNvPr id="26" name="Text 24"/>
+          <p:cNvPr id="25" name="Text 23"/>
           <p:cNvSpPr txBox="1"/>
           <p:nvPr/>
         </p:nvSpPr>
@@ -10694,7 +11572,7 @@
       </p:sp>
       <p:sp>
         <p:nvSpPr>
-          <p:cNvPr id="27" name="Text 25"/>
+          <p:cNvPr id="26" name="Text 24"/>
           <p:cNvSpPr txBox="1"/>
           <p:nvPr/>
         </p:nvSpPr>
@@ -10733,7 +11611,7 @@
       </p:sp>
       <p:sp>
         <p:nvSpPr>
-          <p:cNvPr id="28" name="Shape 26"/>
+          <p:cNvPr id="27" name="Shape 25"/>
           <p:cNvSpPr/>
           <p:nvPr/>
         </p:nvSpPr>
@@ -10755,7 +11633,7 @@
       </p:sp>
       <p:sp>
         <p:nvSpPr>
-          <p:cNvPr id="29" name="Text 27"/>
+          <p:cNvPr id="28" name="Text 26"/>
           <p:cNvSpPr txBox="1"/>
           <p:nvPr/>
         </p:nvSpPr>
@@ -10794,7 +11672,7 @@
       </p:sp>
       <p:sp>
         <p:nvSpPr>
-          <p:cNvPr id="30" name="Shape 28"/>
+          <p:cNvPr id="29" name="Shape 27"/>
           <p:cNvSpPr/>
           <p:nvPr/>
         </p:nvSpPr>
@@ -10816,7 +11694,7 @@
       </p:sp>
       <p:sp>
         <p:nvSpPr>
-          <p:cNvPr id="31" name="Text 29"/>
+          <p:cNvPr id="30" name="Text 28"/>
           <p:cNvSpPr txBox="1"/>
           <p:nvPr/>
         </p:nvSpPr>
@@ -10855,7 +11733,7 @@
       </p:sp>
       <p:sp>
         <p:nvSpPr>
-          <p:cNvPr id="32" name="Text 30"/>
+          <p:cNvPr id="31" name="Text 29"/>
           <p:cNvSpPr txBox="1"/>
           <p:nvPr/>
         </p:nvSpPr>
@@ -10894,7 +11772,7 @@
       </p:sp>
       <p:sp>
         <p:nvSpPr>
-          <p:cNvPr id="33" name="Shape 31"/>
+          <p:cNvPr id="32" name="Shape 30"/>
           <p:cNvSpPr/>
           <p:nvPr/>
         </p:nvSpPr>
@@ -10916,7 +11794,7 @@
       </p:sp>
       <p:sp>
         <p:nvSpPr>
-          <p:cNvPr id="34" name="Text 32"/>
+          <p:cNvPr id="33" name="Text 31"/>
           <p:cNvSpPr txBox="1"/>
           <p:nvPr/>
         </p:nvSpPr>
@@ -11096,7 +11974,7 @@
                 <a:ea typeface="Calibri" pitchFamily="34" charset="-122"/>
                 <a:cs typeface="Calibri" pitchFamily="34" charset="-120"/>
               </a:rPr>
-              <a:t>Arbeitsblatt S. 5 · Denkt euch selbst eine Situation aus! Euer Merkkasten (S. 4) hilft.</a:t>
+              <a:t>Arbeitsblatt S. 5 · Zuerst: als Reihe zusammenrücken, Umschlag öffnen, Rollen verteilen</a:t>
             </a:r>
             <a:endParaRPr lang="en-US" sz="1400" dirty="0"/>
           </a:p>
@@ -11235,7 +12113,7 @@
                 <a:ea typeface="Cambria" pitchFamily="34" charset="-122"/>
                 <a:cs typeface="Cambria" pitchFamily="34" charset="-120"/>
               </a:rPr>
-              <a:t>17 Min.</a:t>
+              <a:t>16 Min.</a:t>
             </a:r>
             <a:endParaRPr lang="en-US" sz="2600" dirty="0"/>
           </a:p>
@@ -11274,7 +12152,7 @@
                 <a:ea typeface="Calibri" pitchFamily="34" charset="-122"/>
                 <a:cs typeface="Calibri" pitchFamily="34" charset="-120"/>
               </a:rPr>
-              <a:t>Gruppe</a:t>
+              <a:t>+ 3 Min. Umsetzen</a:t>
             </a:r>
             <a:endParaRPr lang="en-US" sz="1200" dirty="0"/>
           </a:p>

</xml_diff>

<commit_message>
Deutsch 11: Folie Technik-Training Layout
Co-Authored-By: Claude Opus 5.5 <noreply@anthropic.com>
Claude-Session: https://claude.ai/code/session_01Kzh1oWiqhC6W8oSNq8mKnj
</commit_message>
<xml_diff>
--- a/Deutsch_11/Kommunikationsstoerungen_loesen/Praesentation_Kommunikationsstoerungen_loesen.pptx
+++ b/Deutsch_11/Kommunikationsstoerungen_loesen/Praesentation_Kommunikationsstoerungen_loesen.pptx
@@ -8344,8 +8344,8 @@
         </p:nvSpPr>
         <p:spPr>
           <a:xfrm>
-            <a:off x="1417320" y="1938528"/>
-            <a:ext cx="1737360" cy="566928"/>
+            <a:off x="1463040" y="1938528"/>
+            <a:ext cx="1554480" cy="566928"/>
           </a:xfrm>
           <a:prstGeom prst="rect">
             <a:avLst/>
@@ -8357,11 +8357,50 @@
           <a:bodyPr wrap="square" lIns="0" tIns="0" rIns="0" bIns="0" rtlCol="0" anchor="ctr"/>
           <a:lstStyle/>
           <a:p>
-            <a:pPr indent="0" marL="0">
-              <a:buNone/>
-            </a:pPr>
-            <a:r>
-              <a:rPr lang="en-US" sz="1300" b="1" dirty="0">
+            <a:pPr algn="r" indent="0" marL="0">
+              <a:buNone/>
+            </a:pPr>
+            <a:r>
+              <a:rPr lang="en-US" sz="1300" dirty="0">
+                <a:solidFill>
+                  <a:srgbClr val="5B6B8C"/>
+                </a:solidFill>
+                <a:latin typeface="Calibri" pitchFamily="34" charset="0"/>
+                <a:ea typeface="Calibri" pitchFamily="34" charset="-122"/>
+                <a:cs typeface="Calibri" pitchFamily="34" charset="-120"/>
+              </a:rPr>
+              <a:t>18'–22'</a:t>
+            </a:r>
+            <a:endParaRPr lang="en-US" sz="1300" dirty="0"/>
+          </a:p>
+        </p:txBody>
+      </p:sp>
+      <p:sp>
+        <p:nvSpPr>
+          <p:cNvPr id="14" name="Text 12"/>
+          <p:cNvSpPr txBox="1"/>
+          <p:nvPr/>
+        </p:nvSpPr>
+        <p:spPr>
+          <a:xfrm>
+            <a:off x="731520" y="2606040"/>
+            <a:ext cx="2377440" cy="411480"/>
+          </a:xfrm>
+          <a:prstGeom prst="rect">
+            <a:avLst/>
+          </a:prstGeom>
+          <a:noFill/>
+          <a:ln/>
+        </p:spPr>
+        <p:txBody>
+          <a:bodyPr wrap="square" lIns="0" tIns="0" rIns="0" bIns="0" rtlCol="0" anchor="t"/>
+          <a:lstStyle/>
+          <a:p>
+            <a:pPr indent="0" marL="0">
+              <a:buNone/>
+            </a:pPr>
+            <a:r>
+              <a:rPr lang="en-US" sz="1400" b="1" dirty="0">
                 <a:solidFill>
                   <a:srgbClr val="3F7CC4"/>
                 </a:solidFill>
@@ -8371,20 +8410,20 @@
               </a:rPr>
               <a:t>Ich-Botschaft</a:t>
             </a:r>
-            <a:endParaRPr lang="en-US" sz="1300" dirty="0"/>
-          </a:p>
-        </p:txBody>
-      </p:sp>
-      <p:sp>
-        <p:nvSpPr>
-          <p:cNvPr id="14" name="Text 12"/>
-          <p:cNvSpPr txBox="1"/>
-          <p:nvPr/>
-        </p:nvSpPr>
-        <p:spPr>
-          <a:xfrm>
-            <a:off x="777240" y="2697480"/>
-            <a:ext cx="2194560" cy="365760"/>
+            <a:endParaRPr lang="en-US" sz="1400" dirty="0"/>
+          </a:p>
+        </p:txBody>
+      </p:sp>
+      <p:sp>
+        <p:nvSpPr>
+          <p:cNvPr id="15" name="Text 13"/>
+          <p:cNvSpPr txBox="1"/>
+          <p:nvPr/>
+        </p:nvSpPr>
+        <p:spPr>
+          <a:xfrm>
+            <a:off x="777240" y="3017520"/>
+            <a:ext cx="2194560" cy="411480"/>
           </a:xfrm>
           <a:prstGeom prst="rect">
             <a:avLst/>
@@ -8400,7 +8439,7 @@
               <a:buNone/>
             </a:pPr>
             <a:r>
-              <a:rPr lang="en-US" sz="1600" b="1" dirty="0">
+              <a:rPr lang="en-US" sz="1500" b="1" dirty="0">
                 <a:solidFill>
                   <a:srgbClr val="1E2761"/>
                 </a:solidFill>
@@ -8410,46 +8449,7 @@
               </a:rPr>
               <a:t>→ Zeile 3 umschreiben</a:t>
             </a:r>
-            <a:endParaRPr lang="en-US" sz="1600" dirty="0"/>
-          </a:p>
-        </p:txBody>
-      </p:sp>
-      <p:sp>
-        <p:nvSpPr>
-          <p:cNvPr id="15" name="Text 13"/>
-          <p:cNvSpPr txBox="1"/>
-          <p:nvPr/>
-        </p:nvSpPr>
-        <p:spPr>
-          <a:xfrm>
-            <a:off x="777240" y="3108960"/>
-            <a:ext cx="2194560" cy="320040"/>
-          </a:xfrm>
-          <a:prstGeom prst="rect">
-            <a:avLst/>
-          </a:prstGeom>
-          <a:noFill/>
-          <a:ln/>
-        </p:spPr>
-        <p:txBody>
-          <a:bodyPr wrap="square" lIns="0" tIns="0" rIns="0" bIns="0" rtlCol="0" anchor="t"/>
-          <a:lstStyle/>
-          <a:p>
-            <a:pPr indent="0" marL="0">
-              <a:buNone/>
-            </a:pPr>
-            <a:r>
-              <a:rPr lang="en-US" sz="1300" dirty="0">
-                <a:solidFill>
-                  <a:srgbClr val="5B6B8C"/>
-                </a:solidFill>
-                <a:latin typeface="Calibri" pitchFamily="34" charset="0"/>
-                <a:ea typeface="Calibri" pitchFamily="34" charset="-122"/>
-                <a:cs typeface="Calibri" pitchFamily="34" charset="-120"/>
-              </a:rPr>
-              <a:t>4 Min.</a:t>
-            </a:r>
-            <a:endParaRPr lang="en-US" sz="1300" dirty="0"/>
+            <a:endParaRPr lang="en-US" sz="1500" dirty="0"/>
           </a:p>
         </p:txBody>
       </p:sp>
@@ -8542,8 +8542,8 @@
         </p:nvSpPr>
         <p:spPr>
           <a:xfrm>
-            <a:off x="4233672" y="1938528"/>
-            <a:ext cx="1737360" cy="566928"/>
+            <a:off x="4279392" y="1938528"/>
+            <a:ext cx="1554480" cy="566928"/>
           </a:xfrm>
           <a:prstGeom prst="rect">
             <a:avLst/>
@@ -8555,11 +8555,50 @@
           <a:bodyPr wrap="square" lIns="0" tIns="0" rIns="0" bIns="0" rtlCol="0" anchor="ctr"/>
           <a:lstStyle/>
           <a:p>
-            <a:pPr indent="0" marL="0">
-              <a:buNone/>
-            </a:pPr>
-            <a:r>
-              <a:rPr lang="en-US" sz="1300" b="1" dirty="0">
+            <a:pPr algn="r" indent="0" marL="0">
+              <a:buNone/>
+            </a:pPr>
+            <a:r>
+              <a:rPr lang="en-US" sz="1300" dirty="0">
+                <a:solidFill>
+                  <a:srgbClr val="5B6B8C"/>
+                </a:solidFill>
+                <a:latin typeface="Calibri" pitchFamily="34" charset="0"/>
+                <a:ea typeface="Calibri" pitchFamily="34" charset="-122"/>
+                <a:cs typeface="Calibri" pitchFamily="34" charset="-120"/>
+              </a:rPr>
+              <a:t>22'–26'</a:t>
+            </a:r>
+            <a:endParaRPr lang="en-US" sz="1300" dirty="0"/>
+          </a:p>
+        </p:txBody>
+      </p:sp>
+      <p:sp>
+        <p:nvSpPr>
+          <p:cNvPr id="20" name="Text 18"/>
+          <p:cNvSpPr txBox="1"/>
+          <p:nvPr/>
+        </p:nvSpPr>
+        <p:spPr>
+          <a:xfrm>
+            <a:off x="3547872" y="2606040"/>
+            <a:ext cx="2377440" cy="411480"/>
+          </a:xfrm>
+          <a:prstGeom prst="rect">
+            <a:avLst/>
+          </a:prstGeom>
+          <a:noFill/>
+          <a:ln/>
+        </p:spPr>
+        <p:txBody>
+          <a:bodyPr wrap="square" lIns="0" tIns="0" rIns="0" bIns="0" rtlCol="0" anchor="t"/>
+          <a:lstStyle/>
+          <a:p>
+            <a:pPr indent="0" marL="0">
+              <a:buNone/>
+            </a:pPr>
+            <a:r>
+              <a:rPr lang="en-US" sz="1400" b="1" dirty="0">
                 <a:solidFill>
                   <a:srgbClr val="2E9E6B"/>
                 </a:solidFill>
@@ -8569,20 +8608,20 @@
               </a:rPr>
               <a:t>Empathie</a:t>
             </a:r>
-            <a:endParaRPr lang="en-US" sz="1300" dirty="0"/>
-          </a:p>
-        </p:txBody>
-      </p:sp>
-      <p:sp>
-        <p:nvSpPr>
-          <p:cNvPr id="20" name="Text 18"/>
-          <p:cNvSpPr txBox="1"/>
-          <p:nvPr/>
-        </p:nvSpPr>
-        <p:spPr>
-          <a:xfrm>
-            <a:off x="3593592" y="2697480"/>
-            <a:ext cx="2194560" cy="365760"/>
+            <a:endParaRPr lang="en-US" sz="1400" dirty="0"/>
+          </a:p>
+        </p:txBody>
+      </p:sp>
+      <p:sp>
+        <p:nvSpPr>
+          <p:cNvPr id="21" name="Text 19"/>
+          <p:cNvSpPr txBox="1"/>
+          <p:nvPr/>
+        </p:nvSpPr>
+        <p:spPr>
+          <a:xfrm>
+            <a:off x="3593592" y="3017520"/>
+            <a:ext cx="2194560" cy="411480"/>
           </a:xfrm>
           <a:prstGeom prst="rect">
             <a:avLst/>
@@ -8598,7 +8637,7 @@
               <a:buNone/>
             </a:pPr>
             <a:r>
-              <a:rPr lang="en-US" sz="1600" b="1" dirty="0">
+              <a:rPr lang="en-US" sz="1500" b="1" dirty="0">
                 <a:solidFill>
                   <a:srgbClr val="1E2761"/>
                 </a:solidFill>
@@ -8608,46 +8647,7 @@
               </a:rPr>
               <a:t>→ Zeile 4 umschreiben</a:t>
             </a:r>
-            <a:endParaRPr lang="en-US" sz="1600" dirty="0"/>
-          </a:p>
-        </p:txBody>
-      </p:sp>
-      <p:sp>
-        <p:nvSpPr>
-          <p:cNvPr id="21" name="Text 19"/>
-          <p:cNvSpPr txBox="1"/>
-          <p:nvPr/>
-        </p:nvSpPr>
-        <p:spPr>
-          <a:xfrm>
-            <a:off x="3593592" y="3108960"/>
-            <a:ext cx="2194560" cy="320040"/>
-          </a:xfrm>
-          <a:prstGeom prst="rect">
-            <a:avLst/>
-          </a:prstGeom>
-          <a:noFill/>
-          <a:ln/>
-        </p:spPr>
-        <p:txBody>
-          <a:bodyPr wrap="square" lIns="0" tIns="0" rIns="0" bIns="0" rtlCol="0" anchor="t"/>
-          <a:lstStyle/>
-          <a:p>
-            <a:pPr indent="0" marL="0">
-              <a:buNone/>
-            </a:pPr>
-            <a:r>
-              <a:rPr lang="en-US" sz="1300" dirty="0">
-                <a:solidFill>
-                  <a:srgbClr val="5B6B8C"/>
-                </a:solidFill>
-                <a:latin typeface="Calibri" pitchFamily="34" charset="0"/>
-                <a:ea typeface="Calibri" pitchFamily="34" charset="-122"/>
-                <a:cs typeface="Calibri" pitchFamily="34" charset="-120"/>
-              </a:rPr>
-              <a:t>4 Min.</a:t>
-            </a:r>
-            <a:endParaRPr lang="en-US" sz="1300" dirty="0"/>
+            <a:endParaRPr lang="en-US" sz="1500" dirty="0"/>
           </a:p>
         </p:txBody>
       </p:sp>
@@ -8740,8 +8740,8 @@
         </p:nvSpPr>
         <p:spPr>
           <a:xfrm>
-            <a:off x="7050024" y="1938528"/>
-            <a:ext cx="1737360" cy="566928"/>
+            <a:off x="7095744" y="1938528"/>
+            <a:ext cx="1554480" cy="566928"/>
           </a:xfrm>
           <a:prstGeom prst="rect">
             <a:avLst/>
@@ -8753,11 +8753,50 @@
           <a:bodyPr wrap="square" lIns="0" tIns="0" rIns="0" bIns="0" rtlCol="0" anchor="ctr"/>
           <a:lstStyle/>
           <a:p>
-            <a:pPr indent="0" marL="0">
-              <a:buNone/>
-            </a:pPr>
-            <a:r>
-              <a:rPr lang="en-US" sz="1300" b="1" dirty="0">
+            <a:pPr algn="r" indent="0" marL="0">
+              <a:buNone/>
+            </a:pPr>
+            <a:r>
+              <a:rPr lang="en-US" sz="1300" dirty="0">
+                <a:solidFill>
+                  <a:srgbClr val="5B6B8C"/>
+                </a:solidFill>
+                <a:latin typeface="Calibri" pitchFamily="34" charset="0"/>
+                <a:ea typeface="Calibri" pitchFamily="34" charset="-122"/>
+                <a:cs typeface="Calibri" pitchFamily="34" charset="-120"/>
+              </a:rPr>
+              <a:t>26'–30'</a:t>
+            </a:r>
+            <a:endParaRPr lang="en-US" sz="1300" dirty="0"/>
+          </a:p>
+        </p:txBody>
+      </p:sp>
+      <p:sp>
+        <p:nvSpPr>
+          <p:cNvPr id="26" name="Text 24"/>
+          <p:cNvSpPr txBox="1"/>
+          <p:nvPr/>
+        </p:nvSpPr>
+        <p:spPr>
+          <a:xfrm>
+            <a:off x="6364224" y="2606040"/>
+            <a:ext cx="2377440" cy="411480"/>
+          </a:xfrm>
+          <a:prstGeom prst="rect">
+            <a:avLst/>
+          </a:prstGeom>
+          <a:noFill/>
+          <a:ln/>
+        </p:spPr>
+        <p:txBody>
+          <a:bodyPr wrap="square" lIns="0" tIns="0" rIns="0" bIns="0" rtlCol="0" anchor="t"/>
+          <a:lstStyle/>
+          <a:p>
+            <a:pPr indent="0" marL="0">
+              <a:buNone/>
+            </a:pPr>
+            <a:r>
+              <a:rPr lang="en-US" sz="1400" b="1" dirty="0">
                 <a:solidFill>
                   <a:srgbClr val="E8A33D"/>
                 </a:solidFill>
@@ -8767,20 +8806,20 @@
               </a:rPr>
               <a:t>Wunsch &amp; Bitte</a:t>
             </a:r>
-            <a:endParaRPr lang="en-US" sz="1300" dirty="0"/>
-          </a:p>
-        </p:txBody>
-      </p:sp>
-      <p:sp>
-        <p:nvSpPr>
-          <p:cNvPr id="26" name="Text 24"/>
-          <p:cNvSpPr txBox="1"/>
-          <p:nvPr/>
-        </p:nvSpPr>
-        <p:spPr>
-          <a:xfrm>
-            <a:off x="6409944" y="2697480"/>
-            <a:ext cx="2194560" cy="365760"/>
+            <a:endParaRPr lang="en-US" sz="1400" dirty="0"/>
+          </a:p>
+        </p:txBody>
+      </p:sp>
+      <p:sp>
+        <p:nvSpPr>
+          <p:cNvPr id="27" name="Text 25"/>
+          <p:cNvSpPr txBox="1"/>
+          <p:nvPr/>
+        </p:nvSpPr>
+        <p:spPr>
+          <a:xfrm>
+            <a:off x="6409944" y="3017520"/>
+            <a:ext cx="2194560" cy="411480"/>
           </a:xfrm>
           <a:prstGeom prst="rect">
             <a:avLst/>
@@ -8796,7 +8835,7 @@
               <a:buNone/>
             </a:pPr>
             <a:r>
-              <a:rPr lang="en-US" sz="1600" b="1" dirty="0">
+              <a:rPr lang="en-US" sz="1500" b="1" dirty="0">
                 <a:solidFill>
                   <a:srgbClr val="1E2761"/>
                 </a:solidFill>
@@ -8806,46 +8845,7 @@
               </a:rPr>
               <a:t>→ Zeile 5 umschreiben</a:t>
             </a:r>
-            <a:endParaRPr lang="en-US" sz="1600" dirty="0"/>
-          </a:p>
-        </p:txBody>
-      </p:sp>
-      <p:sp>
-        <p:nvSpPr>
-          <p:cNvPr id="27" name="Text 25"/>
-          <p:cNvSpPr txBox="1"/>
-          <p:nvPr/>
-        </p:nvSpPr>
-        <p:spPr>
-          <a:xfrm>
-            <a:off x="6409944" y="3108960"/>
-            <a:ext cx="2194560" cy="320040"/>
-          </a:xfrm>
-          <a:prstGeom prst="rect">
-            <a:avLst/>
-          </a:prstGeom>
-          <a:noFill/>
-          <a:ln/>
-        </p:spPr>
-        <p:txBody>
-          <a:bodyPr wrap="square" lIns="0" tIns="0" rIns="0" bIns="0" rtlCol="0" anchor="t"/>
-          <a:lstStyle/>
-          <a:p>
-            <a:pPr indent="0" marL="0">
-              <a:buNone/>
-            </a:pPr>
-            <a:r>
-              <a:rPr lang="en-US" sz="1300" dirty="0">
-                <a:solidFill>
-                  <a:srgbClr val="5B6B8C"/>
-                </a:solidFill>
-                <a:latin typeface="Calibri" pitchFamily="34" charset="0"/>
-                <a:ea typeface="Calibri" pitchFamily="34" charset="-122"/>
-                <a:cs typeface="Calibri" pitchFamily="34" charset="-120"/>
-              </a:rPr>
-              <a:t>4 Min.</a:t>
-            </a:r>
-            <a:endParaRPr lang="en-US" sz="1300" dirty="0"/>
+            <a:endParaRPr lang="en-US" sz="1500" dirty="0"/>
           </a:p>
         </p:txBody>
       </p:sp>
@@ -8938,8 +8938,8 @@
         </p:nvSpPr>
         <p:spPr>
           <a:xfrm>
-            <a:off x="9866376" y="1938528"/>
-            <a:ext cx="1737360" cy="566928"/>
+            <a:off x="9912096" y="1938528"/>
+            <a:ext cx="1554480" cy="566928"/>
           </a:xfrm>
           <a:prstGeom prst="rect">
             <a:avLst/>
@@ -8951,11 +8951,50 @@
           <a:bodyPr wrap="square" lIns="0" tIns="0" rIns="0" bIns="0" rtlCol="0" anchor="ctr"/>
           <a:lstStyle/>
           <a:p>
-            <a:pPr indent="0" marL="0">
-              <a:buNone/>
-            </a:pPr>
-            <a:r>
-              <a:rPr lang="en-US" sz="1300" b="1" dirty="0">
+            <a:pPr algn="r" indent="0" marL="0">
+              <a:buNone/>
+            </a:pPr>
+            <a:r>
+              <a:rPr lang="en-US" sz="1300" dirty="0">
+                <a:solidFill>
+                  <a:srgbClr val="5B6B8C"/>
+                </a:solidFill>
+                <a:latin typeface="Calibri" pitchFamily="34" charset="0"/>
+                <a:ea typeface="Calibri" pitchFamily="34" charset="-122"/>
+                <a:cs typeface="Calibri" pitchFamily="34" charset="-120"/>
+              </a:rPr>
+              <a:t>30'–34'</a:t>
+            </a:r>
+            <a:endParaRPr lang="en-US" sz="1300" dirty="0"/>
+          </a:p>
+        </p:txBody>
+      </p:sp>
+      <p:sp>
+        <p:nvSpPr>
+          <p:cNvPr id="32" name="Text 30"/>
+          <p:cNvSpPr txBox="1"/>
+          <p:nvPr/>
+        </p:nvSpPr>
+        <p:spPr>
+          <a:xfrm>
+            <a:off x="9180576" y="2606040"/>
+            <a:ext cx="2377440" cy="411480"/>
+          </a:xfrm>
+          <a:prstGeom prst="rect">
+            <a:avLst/>
+          </a:prstGeom>
+          <a:noFill/>
+          <a:ln/>
+        </p:spPr>
+        <p:txBody>
+          <a:bodyPr wrap="square" lIns="0" tIns="0" rIns="0" bIns="0" rtlCol="0" anchor="t"/>
+          <a:lstStyle/>
+          <a:p>
+            <a:pPr indent="0" marL="0">
+              <a:buNone/>
+            </a:pPr>
+            <a:r>
+              <a:rPr lang="en-US" sz="1400" b="1" dirty="0">
                 <a:solidFill>
                   <a:srgbClr val="8E5BB5"/>
                 </a:solidFill>
@@ -8965,20 +9004,20 @@
               </a:rPr>
               <a:t>Metakommunikation</a:t>
             </a:r>
-            <a:endParaRPr lang="en-US" sz="1300" dirty="0"/>
-          </a:p>
-        </p:txBody>
-      </p:sp>
-      <p:sp>
-        <p:nvSpPr>
-          <p:cNvPr id="32" name="Text 30"/>
-          <p:cNvSpPr txBox="1"/>
-          <p:nvPr/>
-        </p:nvSpPr>
-        <p:spPr>
-          <a:xfrm>
-            <a:off x="9226296" y="2697480"/>
-            <a:ext cx="2194560" cy="365760"/>
+            <a:endParaRPr lang="en-US" sz="1400" dirty="0"/>
+          </a:p>
+        </p:txBody>
+      </p:sp>
+      <p:sp>
+        <p:nvSpPr>
+          <p:cNvPr id="33" name="Text 31"/>
+          <p:cNvSpPr txBox="1"/>
+          <p:nvPr/>
+        </p:nvSpPr>
+        <p:spPr>
+          <a:xfrm>
+            <a:off x="9226296" y="3017520"/>
+            <a:ext cx="2194560" cy="411480"/>
           </a:xfrm>
           <a:prstGeom prst="rect">
             <a:avLst/>
@@ -8994,7 +9033,7 @@
               <a:buNone/>
             </a:pPr>
             <a:r>
-              <a:rPr lang="en-US" sz="1600" b="1" dirty="0">
+              <a:rPr lang="en-US" sz="1500" b="1" dirty="0">
                 <a:solidFill>
                   <a:srgbClr val="1E2761"/>
                 </a:solidFill>
@@ -9004,46 +9043,7 @@
               </a:rPr>
               <a:t>→ Zeile 7 umschreiben</a:t>
             </a:r>
-            <a:endParaRPr lang="en-US" sz="1600" dirty="0"/>
-          </a:p>
-        </p:txBody>
-      </p:sp>
-      <p:sp>
-        <p:nvSpPr>
-          <p:cNvPr id="33" name="Text 31"/>
-          <p:cNvSpPr txBox="1"/>
-          <p:nvPr/>
-        </p:nvSpPr>
-        <p:spPr>
-          <a:xfrm>
-            <a:off x="9226296" y="3108960"/>
-            <a:ext cx="2194560" cy="320040"/>
-          </a:xfrm>
-          <a:prstGeom prst="rect">
-            <a:avLst/>
-          </a:prstGeom>
-          <a:noFill/>
-          <a:ln/>
-        </p:spPr>
-        <p:txBody>
-          <a:bodyPr wrap="square" lIns="0" tIns="0" rIns="0" bIns="0" rtlCol="0" anchor="t"/>
-          <a:lstStyle/>
-          <a:p>
-            <a:pPr indent="0" marL="0">
-              <a:buNone/>
-            </a:pPr>
-            <a:r>
-              <a:rPr lang="en-US" sz="1300" dirty="0">
-                <a:solidFill>
-                  <a:srgbClr val="5B6B8C"/>
-                </a:solidFill>
-                <a:latin typeface="Calibri" pitchFamily="34" charset="0"/>
-                <a:ea typeface="Calibri" pitchFamily="34" charset="-122"/>
-                <a:cs typeface="Calibri" pitchFamily="34" charset="-120"/>
-              </a:rPr>
-              <a:t>4 Min.</a:t>
-            </a:r>
-            <a:endParaRPr lang="en-US" sz="1300" dirty="0"/>
+            <a:endParaRPr lang="en-US" sz="1500" dirty="0"/>
           </a:p>
         </p:txBody>
       </p:sp>

</xml_diff>